<commit_message>
Replace emoji arrows with shapes; add PDF export of retreat deck
Co-Authored-By: Claude Opus 5.5 <noreply@anthropic.com>
Claude-Session: https://claude.ai/code/session_01BLxZCgvJ3UR61Vf1LDEwyR
</commit_message>
<xml_diff>
--- a/retreat-2026-10/20261009_1day合宿_全社_第8期振り返りと第9期に向けて.pptx
+++ b/retreat-2026-10/20261009_1day合宿_全社_第8期振り返りと第9期に向けて.pptx
@@ -5547,40 +5547,45 @@
       </p:sp>
       <p:sp>
         <p:nvSpPr>
-          <p:cNvPr id="7" name="TextBox 6"/>
-          <p:cNvSpPr txBox="1"/>
-          <p:nvPr/>
-        </p:nvSpPr>
-        <p:spPr>
-          <a:xfrm>
-            <a:off x="1410511" y="1913106"/>
-            <a:ext cx="226979" cy="583660"/>
-          </a:xfrm>
-          <a:prstGeom prst="rect">
-            <a:avLst/>
-          </a:prstGeom>
-          <a:noFill/>
-        </p:spPr>
-        <p:txBody>
-          <a:bodyPr wrap="square" anchor="ctr" lIns="0" rIns="0" tIns="0" bIns="0"/>
-          <a:lstStyle/>
-          <a:p>
-            <a:pPr algn="ctr">
-              <a:lnSpc>
-                <a:spcPct val="150000"/>
-              </a:lnSpc>
-            </a:pPr>
-            <a:r>
-              <a:rPr sz="1010" b="0">
-                <a:solidFill>
-                  <a:srgbClr val="00D79C"/>
-                </a:solidFill>
-                <a:latin typeface="Zen Kaku Gothic New"/>
-                <a:ea typeface="Zen Kaku Gothic New"/>
-                <a:cs typeface="Zen Kaku Gothic New"/>
-              </a:rPr>
-              <a:t>▶</a:t>
-            </a:r>
+          <p:cNvPr id="7" name="Isosceles Triangle 6"/>
+          <p:cNvSpPr/>
+          <p:nvPr/>
+        </p:nvSpPr>
+        <p:spPr>
+          <a:xfrm rot="5400000">
+            <a:off x="1475362" y="2148191"/>
+            <a:ext cx="97277" cy="113489"/>
+          </a:xfrm>
+          <a:prstGeom prst="triangle">
+            <a:avLst/>
+          </a:prstGeom>
+          <a:solidFill>
+            <a:srgbClr val="00D79C"/>
+          </a:solidFill>
+          <a:ln>
+            <a:noFill/>
+          </a:ln>
+          <a:effectLst/>
+        </p:spPr>
+        <p:style>
+          <a:lnRef idx="1">
+            <a:schemeClr val="accent1"/>
+          </a:lnRef>
+          <a:fillRef idx="3">
+            <a:schemeClr val="accent1"/>
+          </a:fillRef>
+          <a:effectRef idx="2">
+            <a:schemeClr val="accent1"/>
+          </a:effectRef>
+          <a:fontRef idx="minor">
+            <a:schemeClr val="lt1"/>
+          </a:fontRef>
+        </p:style>
+        <p:txBody>
+          <a:bodyPr rtlCol="0" anchor="ctr"/>
+          <a:lstStyle/>
+          <a:p>
+            <a:pPr algn="ctr"/>
           </a:p>
         </p:txBody>
       </p:sp>
@@ -5669,40 +5674,45 @@
       </p:sp>
       <p:sp>
         <p:nvSpPr>
-          <p:cNvPr id="10" name="TextBox 9"/>
-          <p:cNvSpPr txBox="1"/>
-          <p:nvPr/>
-        </p:nvSpPr>
-        <p:spPr>
-          <a:xfrm>
-            <a:off x="2594043" y="1913106"/>
-            <a:ext cx="226979" cy="583660"/>
-          </a:xfrm>
-          <a:prstGeom prst="rect">
-            <a:avLst/>
-          </a:prstGeom>
-          <a:noFill/>
-        </p:spPr>
-        <p:txBody>
-          <a:bodyPr wrap="square" anchor="ctr" lIns="0" rIns="0" tIns="0" bIns="0"/>
-          <a:lstStyle/>
-          <a:p>
-            <a:pPr algn="ctr">
-              <a:lnSpc>
-                <a:spcPct val="150000"/>
-              </a:lnSpc>
-            </a:pPr>
-            <a:r>
-              <a:rPr sz="1010" b="0">
-                <a:solidFill>
-                  <a:srgbClr val="00D79C"/>
-                </a:solidFill>
-                <a:latin typeface="Zen Kaku Gothic New"/>
-                <a:ea typeface="Zen Kaku Gothic New"/>
-                <a:cs typeface="Zen Kaku Gothic New"/>
-              </a:rPr>
-              <a:t>▶</a:t>
-            </a:r>
+          <p:cNvPr id="10" name="Isosceles Triangle 9"/>
+          <p:cNvSpPr/>
+          <p:nvPr/>
+        </p:nvSpPr>
+        <p:spPr>
+          <a:xfrm rot="5400000">
+            <a:off x="2658894" y="2148191"/>
+            <a:ext cx="97277" cy="113489"/>
+          </a:xfrm>
+          <a:prstGeom prst="triangle">
+            <a:avLst/>
+          </a:prstGeom>
+          <a:solidFill>
+            <a:srgbClr val="00D79C"/>
+          </a:solidFill>
+          <a:ln>
+            <a:noFill/>
+          </a:ln>
+          <a:effectLst/>
+        </p:spPr>
+        <p:style>
+          <a:lnRef idx="1">
+            <a:schemeClr val="accent1"/>
+          </a:lnRef>
+          <a:fillRef idx="3">
+            <a:schemeClr val="accent1"/>
+          </a:fillRef>
+          <a:effectRef idx="2">
+            <a:schemeClr val="accent1"/>
+          </a:effectRef>
+          <a:fontRef idx="minor">
+            <a:schemeClr val="lt1"/>
+          </a:fontRef>
+        </p:style>
+        <p:txBody>
+          <a:bodyPr rtlCol="0" anchor="ctr"/>
+          <a:lstStyle/>
+          <a:p>
+            <a:pPr algn="ctr"/>
           </a:p>
         </p:txBody>
       </p:sp>
@@ -5791,40 +5801,45 @@
       </p:sp>
       <p:sp>
         <p:nvSpPr>
-          <p:cNvPr id="13" name="TextBox 12"/>
-          <p:cNvSpPr txBox="1"/>
-          <p:nvPr/>
-        </p:nvSpPr>
-        <p:spPr>
-          <a:xfrm>
-            <a:off x="3777574" y="1913106"/>
-            <a:ext cx="226979" cy="583660"/>
-          </a:xfrm>
-          <a:prstGeom prst="rect">
-            <a:avLst/>
-          </a:prstGeom>
-          <a:noFill/>
-        </p:spPr>
-        <p:txBody>
-          <a:bodyPr wrap="square" anchor="ctr" lIns="0" rIns="0" tIns="0" bIns="0"/>
-          <a:lstStyle/>
-          <a:p>
-            <a:pPr algn="ctr">
-              <a:lnSpc>
-                <a:spcPct val="150000"/>
-              </a:lnSpc>
-            </a:pPr>
-            <a:r>
-              <a:rPr sz="1010" b="0">
-                <a:solidFill>
-                  <a:srgbClr val="00D79C"/>
-                </a:solidFill>
-                <a:latin typeface="Zen Kaku Gothic New"/>
-                <a:ea typeface="Zen Kaku Gothic New"/>
-                <a:cs typeface="Zen Kaku Gothic New"/>
-              </a:rPr>
-              <a:t>▶</a:t>
-            </a:r>
+          <p:cNvPr id="13" name="Isosceles Triangle 12"/>
+          <p:cNvSpPr/>
+          <p:nvPr/>
+        </p:nvSpPr>
+        <p:spPr>
+          <a:xfrm rot="5400000">
+            <a:off x="3842426" y="2148191"/>
+            <a:ext cx="97277" cy="113489"/>
+          </a:xfrm>
+          <a:prstGeom prst="triangle">
+            <a:avLst/>
+          </a:prstGeom>
+          <a:solidFill>
+            <a:srgbClr val="00D79C"/>
+          </a:solidFill>
+          <a:ln>
+            <a:noFill/>
+          </a:ln>
+          <a:effectLst/>
+        </p:spPr>
+        <p:style>
+          <a:lnRef idx="1">
+            <a:schemeClr val="accent1"/>
+          </a:lnRef>
+          <a:fillRef idx="3">
+            <a:schemeClr val="accent1"/>
+          </a:fillRef>
+          <a:effectRef idx="2">
+            <a:schemeClr val="accent1"/>
+          </a:effectRef>
+          <a:fontRef idx="minor">
+            <a:schemeClr val="lt1"/>
+          </a:fontRef>
+        </p:style>
+        <p:txBody>
+          <a:bodyPr rtlCol="0" anchor="ctr"/>
+          <a:lstStyle/>
+          <a:p>
+            <a:pPr algn="ctr"/>
           </a:p>
         </p:txBody>
       </p:sp>
@@ -5913,40 +5928,45 @@
       </p:sp>
       <p:sp>
         <p:nvSpPr>
-          <p:cNvPr id="16" name="TextBox 15"/>
-          <p:cNvSpPr txBox="1"/>
-          <p:nvPr/>
-        </p:nvSpPr>
-        <p:spPr>
-          <a:xfrm>
-            <a:off x="4961106" y="1913106"/>
-            <a:ext cx="226979" cy="583660"/>
-          </a:xfrm>
-          <a:prstGeom prst="rect">
-            <a:avLst/>
-          </a:prstGeom>
-          <a:noFill/>
-        </p:spPr>
-        <p:txBody>
-          <a:bodyPr wrap="square" anchor="ctr" lIns="0" rIns="0" tIns="0" bIns="0"/>
-          <a:lstStyle/>
-          <a:p>
-            <a:pPr algn="ctr">
-              <a:lnSpc>
-                <a:spcPct val="150000"/>
-              </a:lnSpc>
-            </a:pPr>
-            <a:r>
-              <a:rPr sz="1010" b="0">
-                <a:solidFill>
-                  <a:srgbClr val="00D79C"/>
-                </a:solidFill>
-                <a:latin typeface="Zen Kaku Gothic New"/>
-                <a:ea typeface="Zen Kaku Gothic New"/>
-                <a:cs typeface="Zen Kaku Gothic New"/>
-              </a:rPr>
-              <a:t>▶</a:t>
-            </a:r>
+          <p:cNvPr id="16" name="Isosceles Triangle 15"/>
+          <p:cNvSpPr/>
+          <p:nvPr/>
+        </p:nvSpPr>
+        <p:spPr>
+          <a:xfrm rot="5400000">
+            <a:off x="5025957" y="2148191"/>
+            <a:ext cx="97277" cy="113489"/>
+          </a:xfrm>
+          <a:prstGeom prst="triangle">
+            <a:avLst/>
+          </a:prstGeom>
+          <a:solidFill>
+            <a:srgbClr val="00D79C"/>
+          </a:solidFill>
+          <a:ln>
+            <a:noFill/>
+          </a:ln>
+          <a:effectLst/>
+        </p:spPr>
+        <p:style>
+          <a:lnRef idx="1">
+            <a:schemeClr val="accent1"/>
+          </a:lnRef>
+          <a:fillRef idx="3">
+            <a:schemeClr val="accent1"/>
+          </a:fillRef>
+          <a:effectRef idx="2">
+            <a:schemeClr val="accent1"/>
+          </a:effectRef>
+          <a:fontRef idx="minor">
+            <a:schemeClr val="lt1"/>
+          </a:fontRef>
+        </p:style>
+        <p:txBody>
+          <a:bodyPr rtlCol="0" anchor="ctr"/>
+          <a:lstStyle/>
+          <a:p>
+            <a:pPr algn="ctr"/>
           </a:p>
         </p:txBody>
       </p:sp>
@@ -6035,40 +6055,45 @@
       </p:sp>
       <p:sp>
         <p:nvSpPr>
-          <p:cNvPr id="19" name="TextBox 18"/>
-          <p:cNvSpPr txBox="1"/>
-          <p:nvPr/>
-        </p:nvSpPr>
-        <p:spPr>
-          <a:xfrm>
-            <a:off x="6144638" y="1913106"/>
-            <a:ext cx="226979" cy="583660"/>
-          </a:xfrm>
-          <a:prstGeom prst="rect">
-            <a:avLst/>
-          </a:prstGeom>
-          <a:noFill/>
-        </p:spPr>
-        <p:txBody>
-          <a:bodyPr wrap="square" anchor="ctr" lIns="0" rIns="0" tIns="0" bIns="0"/>
-          <a:lstStyle/>
-          <a:p>
-            <a:pPr algn="ctr">
-              <a:lnSpc>
-                <a:spcPct val="150000"/>
-              </a:lnSpc>
-            </a:pPr>
-            <a:r>
-              <a:rPr sz="1010" b="0">
-                <a:solidFill>
-                  <a:srgbClr val="00D79C"/>
-                </a:solidFill>
-                <a:latin typeface="Zen Kaku Gothic New"/>
-                <a:ea typeface="Zen Kaku Gothic New"/>
-                <a:cs typeface="Zen Kaku Gothic New"/>
-              </a:rPr>
-              <a:t>▶</a:t>
-            </a:r>
+          <p:cNvPr id="19" name="Isosceles Triangle 18"/>
+          <p:cNvSpPr/>
+          <p:nvPr/>
+        </p:nvSpPr>
+        <p:spPr>
+          <a:xfrm rot="5400000">
+            <a:off x="6209489" y="2148191"/>
+            <a:ext cx="97277" cy="113489"/>
+          </a:xfrm>
+          <a:prstGeom prst="triangle">
+            <a:avLst/>
+          </a:prstGeom>
+          <a:solidFill>
+            <a:srgbClr val="00D79C"/>
+          </a:solidFill>
+          <a:ln>
+            <a:noFill/>
+          </a:ln>
+          <a:effectLst/>
+        </p:spPr>
+        <p:style>
+          <a:lnRef idx="1">
+            <a:schemeClr val="accent1"/>
+          </a:lnRef>
+          <a:fillRef idx="3">
+            <a:schemeClr val="accent1"/>
+          </a:fillRef>
+          <a:effectRef idx="2">
+            <a:schemeClr val="accent1"/>
+          </a:effectRef>
+          <a:fontRef idx="minor">
+            <a:schemeClr val="lt1"/>
+          </a:fontRef>
+        </p:style>
+        <p:txBody>
+          <a:bodyPr rtlCol="0" anchor="ctr"/>
+          <a:lstStyle/>
+          <a:p>
+            <a:pPr algn="ctr"/>
           </a:p>
         </p:txBody>
       </p:sp>
@@ -6157,40 +6182,45 @@
       </p:sp>
       <p:sp>
         <p:nvSpPr>
-          <p:cNvPr id="22" name="TextBox 21"/>
-          <p:cNvSpPr txBox="1"/>
-          <p:nvPr/>
-        </p:nvSpPr>
-        <p:spPr>
-          <a:xfrm>
-            <a:off x="7328170" y="1913106"/>
-            <a:ext cx="226979" cy="583660"/>
-          </a:xfrm>
-          <a:prstGeom prst="rect">
-            <a:avLst/>
-          </a:prstGeom>
-          <a:noFill/>
-        </p:spPr>
-        <p:txBody>
-          <a:bodyPr wrap="square" anchor="ctr" lIns="0" rIns="0" tIns="0" bIns="0"/>
-          <a:lstStyle/>
-          <a:p>
-            <a:pPr algn="ctr">
-              <a:lnSpc>
-                <a:spcPct val="150000"/>
-              </a:lnSpc>
-            </a:pPr>
-            <a:r>
-              <a:rPr sz="1010" b="0">
-                <a:solidFill>
-                  <a:srgbClr val="00D79C"/>
-                </a:solidFill>
-                <a:latin typeface="Zen Kaku Gothic New"/>
-                <a:ea typeface="Zen Kaku Gothic New"/>
-                <a:cs typeface="Zen Kaku Gothic New"/>
-              </a:rPr>
-              <a:t>▶</a:t>
-            </a:r>
+          <p:cNvPr id="22" name="Isosceles Triangle 21"/>
+          <p:cNvSpPr/>
+          <p:nvPr/>
+        </p:nvSpPr>
+        <p:spPr>
+          <a:xfrm rot="5400000">
+            <a:off x="7393021" y="2148191"/>
+            <a:ext cx="97277" cy="113489"/>
+          </a:xfrm>
+          <a:prstGeom prst="triangle">
+            <a:avLst/>
+          </a:prstGeom>
+          <a:solidFill>
+            <a:srgbClr val="00D79C"/>
+          </a:solidFill>
+          <a:ln>
+            <a:noFill/>
+          </a:ln>
+          <a:effectLst/>
+        </p:spPr>
+        <p:style>
+          <a:lnRef idx="1">
+            <a:schemeClr val="accent1"/>
+          </a:lnRef>
+          <a:fillRef idx="3">
+            <a:schemeClr val="accent1"/>
+          </a:fillRef>
+          <a:effectRef idx="2">
+            <a:schemeClr val="accent1"/>
+          </a:effectRef>
+          <a:fontRef idx="minor">
+            <a:schemeClr val="lt1"/>
+          </a:fontRef>
+        </p:style>
+        <p:txBody>
+          <a:bodyPr rtlCol="0" anchor="ctr"/>
+          <a:lstStyle/>
+          <a:p>
+            <a:pPr algn="ctr"/>
           </a:p>
         </p:txBody>
       </p:sp>
@@ -7057,40 +7087,45 @@
       </p:sp>
       <p:sp>
         <p:nvSpPr>
-          <p:cNvPr id="18" name="TextBox 17"/>
-          <p:cNvSpPr txBox="1"/>
-          <p:nvPr/>
-        </p:nvSpPr>
-        <p:spPr>
-          <a:xfrm>
-            <a:off x="2350851" y="4944894"/>
-            <a:ext cx="243191" cy="356681"/>
-          </a:xfrm>
-          <a:prstGeom prst="rect">
-            <a:avLst/>
-          </a:prstGeom>
-          <a:noFill/>
-        </p:spPr>
-        <p:txBody>
-          <a:bodyPr wrap="square" anchor="t" lIns="0" rIns="0" tIns="0" bIns="0"/>
-          <a:lstStyle/>
-          <a:p>
-            <a:pPr algn="ctr">
-              <a:lnSpc>
-                <a:spcPct val="150000"/>
-              </a:lnSpc>
-            </a:pPr>
-            <a:r>
-              <a:rPr sz="1136" b="0">
-                <a:solidFill>
-                  <a:srgbClr val="00D79C"/>
-                </a:solidFill>
-                <a:latin typeface="Zen Kaku Gothic New"/>
-                <a:ea typeface="Zen Kaku Gothic New"/>
-                <a:cs typeface="Zen Kaku Gothic New"/>
-              </a:rPr>
-              <a:t>▶</a:t>
-            </a:r>
+          <p:cNvPr id="18" name="Isosceles Triangle 17"/>
+          <p:cNvSpPr/>
+          <p:nvPr/>
+        </p:nvSpPr>
+        <p:spPr>
+          <a:xfrm rot="5400000">
+            <a:off x="2415702" y="5042170"/>
+            <a:ext cx="97277" cy="129702"/>
+          </a:xfrm>
+          <a:prstGeom prst="triangle">
+            <a:avLst/>
+          </a:prstGeom>
+          <a:solidFill>
+            <a:srgbClr val="00D79C"/>
+          </a:solidFill>
+          <a:ln>
+            <a:noFill/>
+          </a:ln>
+          <a:effectLst/>
+        </p:spPr>
+        <p:style>
+          <a:lnRef idx="1">
+            <a:schemeClr val="accent1"/>
+          </a:lnRef>
+          <a:fillRef idx="3">
+            <a:schemeClr val="accent1"/>
+          </a:fillRef>
+          <a:effectRef idx="2">
+            <a:schemeClr val="accent1"/>
+          </a:effectRef>
+          <a:fontRef idx="minor">
+            <a:schemeClr val="lt1"/>
+          </a:fontRef>
+        </p:style>
+        <p:txBody>
+          <a:bodyPr rtlCol="0" anchor="ctr"/>
+          <a:lstStyle/>
+          <a:p>
+            <a:pPr algn="ctr"/>
           </a:p>
         </p:txBody>
       </p:sp>
@@ -7135,40 +7170,45 @@
       </p:sp>
       <p:sp>
         <p:nvSpPr>
-          <p:cNvPr id="20" name="TextBox 19"/>
-          <p:cNvSpPr txBox="1"/>
-          <p:nvPr/>
-        </p:nvSpPr>
-        <p:spPr>
-          <a:xfrm>
-            <a:off x="4458511" y="4944894"/>
-            <a:ext cx="243191" cy="356681"/>
-          </a:xfrm>
-          <a:prstGeom prst="rect">
-            <a:avLst/>
-          </a:prstGeom>
-          <a:noFill/>
-        </p:spPr>
-        <p:txBody>
-          <a:bodyPr wrap="square" anchor="t" lIns="0" rIns="0" tIns="0" bIns="0"/>
-          <a:lstStyle/>
-          <a:p>
-            <a:pPr algn="ctr">
-              <a:lnSpc>
-                <a:spcPct val="150000"/>
-              </a:lnSpc>
-            </a:pPr>
-            <a:r>
-              <a:rPr sz="1136" b="0">
-                <a:solidFill>
-                  <a:srgbClr val="00D79C"/>
-                </a:solidFill>
-                <a:latin typeface="Zen Kaku Gothic New"/>
-                <a:ea typeface="Zen Kaku Gothic New"/>
-                <a:cs typeface="Zen Kaku Gothic New"/>
-              </a:rPr>
-              <a:t>▶</a:t>
-            </a:r>
+          <p:cNvPr id="20" name="Isosceles Triangle 19"/>
+          <p:cNvSpPr/>
+          <p:nvPr/>
+        </p:nvSpPr>
+        <p:spPr>
+          <a:xfrm rot="5400000">
+            <a:off x="4523362" y="5042170"/>
+            <a:ext cx="97277" cy="129702"/>
+          </a:xfrm>
+          <a:prstGeom prst="triangle">
+            <a:avLst/>
+          </a:prstGeom>
+          <a:solidFill>
+            <a:srgbClr val="00D79C"/>
+          </a:solidFill>
+          <a:ln>
+            <a:noFill/>
+          </a:ln>
+          <a:effectLst/>
+        </p:spPr>
+        <p:style>
+          <a:lnRef idx="1">
+            <a:schemeClr val="accent1"/>
+          </a:lnRef>
+          <a:fillRef idx="3">
+            <a:schemeClr val="accent1"/>
+          </a:fillRef>
+          <a:effectRef idx="2">
+            <a:schemeClr val="accent1"/>
+          </a:effectRef>
+          <a:fontRef idx="minor">
+            <a:schemeClr val="lt1"/>
+          </a:fontRef>
+        </p:style>
+        <p:txBody>
+          <a:bodyPr rtlCol="0" anchor="ctr"/>
+          <a:lstStyle/>
+          <a:p>
+            <a:pPr algn="ctr"/>
           </a:p>
         </p:txBody>
       </p:sp>
@@ -7213,40 +7253,45 @@
       </p:sp>
       <p:sp>
         <p:nvSpPr>
-          <p:cNvPr id="22" name="TextBox 21"/>
-          <p:cNvSpPr txBox="1"/>
-          <p:nvPr/>
-        </p:nvSpPr>
-        <p:spPr>
-          <a:xfrm>
-            <a:off x="6566170" y="4944894"/>
-            <a:ext cx="243191" cy="356681"/>
-          </a:xfrm>
-          <a:prstGeom prst="rect">
-            <a:avLst/>
-          </a:prstGeom>
-          <a:noFill/>
-        </p:spPr>
-        <p:txBody>
-          <a:bodyPr wrap="square" anchor="t" lIns="0" rIns="0" tIns="0" bIns="0"/>
-          <a:lstStyle/>
-          <a:p>
-            <a:pPr algn="ctr">
-              <a:lnSpc>
-                <a:spcPct val="150000"/>
-              </a:lnSpc>
-            </a:pPr>
-            <a:r>
-              <a:rPr sz="1136" b="0">
-                <a:solidFill>
-                  <a:srgbClr val="00D79C"/>
-                </a:solidFill>
-                <a:latin typeface="Zen Kaku Gothic New"/>
-                <a:ea typeface="Zen Kaku Gothic New"/>
-                <a:cs typeface="Zen Kaku Gothic New"/>
-              </a:rPr>
-              <a:t>▶</a:t>
-            </a:r>
+          <p:cNvPr id="22" name="Isosceles Triangle 21"/>
+          <p:cNvSpPr/>
+          <p:nvPr/>
+        </p:nvSpPr>
+        <p:spPr>
+          <a:xfrm rot="5400000">
+            <a:off x="6631021" y="5042170"/>
+            <a:ext cx="97277" cy="129702"/>
+          </a:xfrm>
+          <a:prstGeom prst="triangle">
+            <a:avLst/>
+          </a:prstGeom>
+          <a:solidFill>
+            <a:srgbClr val="00D79C"/>
+          </a:solidFill>
+          <a:ln>
+            <a:noFill/>
+          </a:ln>
+          <a:effectLst/>
+        </p:spPr>
+        <p:style>
+          <a:lnRef idx="1">
+            <a:schemeClr val="accent1"/>
+          </a:lnRef>
+          <a:fillRef idx="3">
+            <a:schemeClr val="accent1"/>
+          </a:fillRef>
+          <a:effectRef idx="2">
+            <a:schemeClr val="accent1"/>
+          </a:effectRef>
+          <a:fontRef idx="minor">
+            <a:schemeClr val="lt1"/>
+          </a:fontRef>
+        </p:style>
+        <p:txBody>
+          <a:bodyPr rtlCol="0" anchor="ctr"/>
+          <a:lstStyle/>
+          <a:p>
+            <a:pPr algn="ctr"/>
           </a:p>
         </p:txBody>
       </p:sp>

</xml_diff>

<commit_message>
Center purpose slides; add company-wide FY8 numbers from trial balance
Co-Authored-By: Claude Opus 5.5 <noreply@anthropic.com>
Claude-Session: https://claude.ai/code/session_01BLxZCgvJ3UR61Vf1LDEwyR
</commit_message>
<xml_diff>
--- a/retreat-2026-10/20261009_1day合宿_全社_第8期振り返りと第9期に向けて.pptx
+++ b/retreat-2026-10/20261009_1day合宿_全社_第8期振り返りと第9期に向けて.pptx
@@ -3898,15 +3898,15 @@
               </a:lnSpc>
             </a:pPr>
             <a:r>
-              <a:rPr sz="2147" b="1">
-                <a:solidFill>
-                  <a:srgbClr val="004347"/>
-                </a:solidFill>
-                <a:latin typeface="Zen Kaku Gothic New"/>
-                <a:ea typeface="Zen Kaku Gothic New"/>
-                <a:cs typeface="Zen Kaku Gothic New"/>
-              </a:rPr>
-              <a:t>算出中</a:t>
+              <a:rPr sz="1768" b="1">
+                <a:solidFill>
+                  <a:srgbClr val="004347"/>
+                </a:solidFill>
+                <a:latin typeface="Zen Kaku Gothic New"/>
+                <a:ea typeface="Zen Kaku Gothic New"/>
+                <a:cs typeface="Zen Kaku Gothic New"/>
+              </a:rPr>
+              <a:t>第8期 ▲2.21億</a:t>
             </a:r>
           </a:p>
           <a:p>
@@ -3916,15 +3916,51 @@
               </a:lnSpc>
             </a:pPr>
             <a:r>
-              <a:rPr sz="2147" b="1">
-                <a:solidFill>
-                  <a:srgbClr val="004347"/>
-                </a:solidFill>
-                <a:latin typeface="Zen Kaku Gothic New"/>
-                <a:ea typeface="Zen Kaku Gothic New"/>
-                <a:cs typeface="Zen Kaku Gothic New"/>
-              </a:rPr>
-              <a:t>（黒字化）</a:t>
+              <a:rPr sz="1768" b="1">
+                <a:solidFill>
+                  <a:srgbClr val="004347"/>
+                </a:solidFill>
+                <a:latin typeface="Zen Kaku Gothic New"/>
+                <a:ea typeface="Zen Kaku Gothic New"/>
+                <a:cs typeface="Zen Kaku Gothic New"/>
+              </a:rPr>
+              <a:t>↓</a:t>
+            </a:r>
+          </a:p>
+          <a:p>
+            <a:pPr algn="ctr">
+              <a:lnSpc>
+                <a:spcPct val="140000"/>
+              </a:lnSpc>
+            </a:pPr>
+            <a:r>
+              <a:rPr sz="1768" b="1">
+                <a:solidFill>
+                  <a:srgbClr val="00D79C"/>
+                </a:solidFill>
+                <a:latin typeface="Zen Kaku Gothic New"/>
+                <a:ea typeface="Zen Kaku Gothic New"/>
+                <a:cs typeface="Zen Kaku Gothic New"/>
+              </a:rPr>
+              <a:t>黒字化</a:t>
+            </a:r>
+          </a:p>
+          <a:p>
+            <a:pPr algn="ctr">
+              <a:lnSpc>
+                <a:spcPct val="140000"/>
+              </a:lnSpc>
+            </a:pPr>
+            <a:r>
+              <a:rPr sz="1768" b="1">
+                <a:solidFill>
+                  <a:srgbClr val="004347"/>
+                </a:solidFill>
+                <a:latin typeface="Zen Kaku Gothic New"/>
+                <a:ea typeface="Zen Kaku Gothic New"/>
+                <a:cs typeface="Zen Kaku Gothic New"/>
+              </a:rPr>
+              <a:t>（目標額は算出中）</a:t>
             </a:r>
           </a:p>
         </p:txBody>
@@ -9295,97 +9331,19 @@
         </p:nvSpPr>
         <p:spPr>
           <a:xfrm>
-            <a:off x="778213" y="1945532"/>
-            <a:ext cx="3242553" cy="259404"/>
-          </a:xfrm>
-          <a:prstGeom prst="rect">
-            <a:avLst/>
-          </a:prstGeom>
-          <a:noFill/>
-        </p:spPr>
-        <p:txBody>
-          <a:bodyPr wrap="square" anchor="t" lIns="0" rIns="0" tIns="0" bIns="0"/>
-          <a:lstStyle/>
-          <a:p>
-            <a:pPr algn="l">
-              <a:lnSpc>
-                <a:spcPct val="150000"/>
-              </a:lnSpc>
-            </a:pPr>
-            <a:r>
-              <a:rPr sz="1389" b="0">
-                <a:solidFill>
-                  <a:srgbClr val="626262"/>
-                </a:solidFill>
-                <a:latin typeface="Zen Kaku Gothic New"/>
-                <a:ea typeface="Zen Kaku Gothic New"/>
-                <a:cs typeface="Zen Kaku Gothic New"/>
-              </a:rPr>
-              <a:t>合宿の目的  1 / 3</a:t>
-            </a:r>
-          </a:p>
-        </p:txBody>
-      </p:sp>
-      <p:sp>
-        <p:nvSpPr>
-          <p:cNvPr id="5" name="TextBox 4"/>
-          <p:cNvSpPr txBox="1"/>
-          <p:nvPr/>
-        </p:nvSpPr>
-        <p:spPr>
-          <a:xfrm>
-            <a:off x="778213" y="2431915"/>
-            <a:ext cx="1621277" cy="1215957"/>
-          </a:xfrm>
-          <a:prstGeom prst="rect">
-            <a:avLst/>
-          </a:prstGeom>
-          <a:noFill/>
-        </p:spPr>
-        <p:txBody>
-          <a:bodyPr wrap="square" anchor="t" lIns="0" rIns="0" tIns="0" bIns="0"/>
-          <a:lstStyle/>
-          <a:p>
-            <a:pPr algn="l">
-              <a:lnSpc>
-                <a:spcPct val="100000"/>
-              </a:lnSpc>
-            </a:pPr>
-            <a:r>
-              <a:rPr sz="7578" b="1">
-                <a:solidFill>
-                  <a:srgbClr val="00D79C"/>
-                </a:solidFill>
-                <a:latin typeface="Outfit"/>
-                <a:ea typeface="Outfit"/>
-                <a:cs typeface="Outfit"/>
-              </a:rPr>
-              <a:t>1</a:t>
-            </a:r>
-          </a:p>
-        </p:txBody>
-      </p:sp>
-      <p:sp>
-        <p:nvSpPr>
-          <p:cNvPr id="6" name="TextBox 5"/>
-          <p:cNvSpPr txBox="1"/>
-          <p:nvPr/>
-        </p:nvSpPr>
-        <p:spPr>
-          <a:xfrm>
-            <a:off x="778213" y="3810000"/>
-            <a:ext cx="7782128" cy="729574"/>
-          </a:xfrm>
-          <a:prstGeom prst="rect">
-            <a:avLst/>
-          </a:prstGeom>
-          <a:noFill/>
-        </p:spPr>
-        <p:txBody>
-          <a:bodyPr wrap="square" anchor="t" lIns="0" rIns="0" tIns="0" bIns="0"/>
-          <a:lstStyle/>
-          <a:p>
-            <a:pPr algn="l">
+            <a:off x="453957" y="2618362"/>
+            <a:ext cx="8236085" cy="1621277"/>
+          </a:xfrm>
+          <a:prstGeom prst="rect">
+            <a:avLst/>
+          </a:prstGeom>
+          <a:noFill/>
+        </p:spPr>
+        <p:txBody>
+          <a:bodyPr wrap="square" anchor="ctr" lIns="0" rIns="0" tIns="0" bIns="0"/>
+          <a:lstStyle/>
+          <a:p>
+            <a:pPr algn="ctr">
               <a:lnSpc>
                 <a:spcPct val="150000"/>
               </a:lnSpc>
@@ -9513,97 +9471,19 @@
         </p:nvSpPr>
         <p:spPr>
           <a:xfrm>
-            <a:off x="778213" y="1945532"/>
-            <a:ext cx="3242553" cy="259404"/>
-          </a:xfrm>
-          <a:prstGeom prst="rect">
-            <a:avLst/>
-          </a:prstGeom>
-          <a:noFill/>
-        </p:spPr>
-        <p:txBody>
-          <a:bodyPr wrap="square" anchor="t" lIns="0" rIns="0" tIns="0" bIns="0"/>
-          <a:lstStyle/>
-          <a:p>
-            <a:pPr algn="l">
-              <a:lnSpc>
-                <a:spcPct val="150000"/>
-              </a:lnSpc>
-            </a:pPr>
-            <a:r>
-              <a:rPr sz="1389" b="0">
-                <a:solidFill>
-                  <a:srgbClr val="626262"/>
-                </a:solidFill>
-                <a:latin typeface="Zen Kaku Gothic New"/>
-                <a:ea typeface="Zen Kaku Gothic New"/>
-                <a:cs typeface="Zen Kaku Gothic New"/>
-              </a:rPr>
-              <a:t>合宿の目的  2 / 3</a:t>
-            </a:r>
-          </a:p>
-        </p:txBody>
-      </p:sp>
-      <p:sp>
-        <p:nvSpPr>
-          <p:cNvPr id="5" name="TextBox 4"/>
-          <p:cNvSpPr txBox="1"/>
-          <p:nvPr/>
-        </p:nvSpPr>
-        <p:spPr>
-          <a:xfrm>
-            <a:off x="778213" y="2431915"/>
-            <a:ext cx="1621277" cy="1215957"/>
-          </a:xfrm>
-          <a:prstGeom prst="rect">
-            <a:avLst/>
-          </a:prstGeom>
-          <a:noFill/>
-        </p:spPr>
-        <p:txBody>
-          <a:bodyPr wrap="square" anchor="t" lIns="0" rIns="0" tIns="0" bIns="0"/>
-          <a:lstStyle/>
-          <a:p>
-            <a:pPr algn="l">
-              <a:lnSpc>
-                <a:spcPct val="100000"/>
-              </a:lnSpc>
-            </a:pPr>
-            <a:r>
-              <a:rPr sz="7578" b="1">
-                <a:solidFill>
-                  <a:srgbClr val="00D79C"/>
-                </a:solidFill>
-                <a:latin typeface="Outfit"/>
-                <a:ea typeface="Outfit"/>
-                <a:cs typeface="Outfit"/>
-              </a:rPr>
-              <a:t>2</a:t>
-            </a:r>
-          </a:p>
-        </p:txBody>
-      </p:sp>
-      <p:sp>
-        <p:nvSpPr>
-          <p:cNvPr id="6" name="TextBox 5"/>
-          <p:cNvSpPr txBox="1"/>
-          <p:nvPr/>
-        </p:nvSpPr>
-        <p:spPr>
-          <a:xfrm>
-            <a:off x="778213" y="3810000"/>
-            <a:ext cx="7782128" cy="729574"/>
-          </a:xfrm>
-          <a:prstGeom prst="rect">
-            <a:avLst/>
-          </a:prstGeom>
-          <a:noFill/>
-        </p:spPr>
-        <p:txBody>
-          <a:bodyPr wrap="square" anchor="t" lIns="0" rIns="0" tIns="0" bIns="0"/>
-          <a:lstStyle/>
-          <a:p>
-            <a:pPr algn="l">
+            <a:off x="453957" y="2618362"/>
+            <a:ext cx="8236085" cy="1621277"/>
+          </a:xfrm>
+          <a:prstGeom prst="rect">
+            <a:avLst/>
+          </a:prstGeom>
+          <a:noFill/>
+        </p:spPr>
+        <p:txBody>
+          <a:bodyPr wrap="square" anchor="ctr" lIns="0" rIns="0" tIns="0" bIns="0"/>
+          <a:lstStyle/>
+          <a:p>
+            <a:pPr algn="ctr">
               <a:lnSpc>
                 <a:spcPct val="150000"/>
               </a:lnSpc>
@@ -9731,97 +9611,19 @@
         </p:nvSpPr>
         <p:spPr>
           <a:xfrm>
-            <a:off x="778213" y="1945532"/>
-            <a:ext cx="3242553" cy="259404"/>
-          </a:xfrm>
-          <a:prstGeom prst="rect">
-            <a:avLst/>
-          </a:prstGeom>
-          <a:noFill/>
-        </p:spPr>
-        <p:txBody>
-          <a:bodyPr wrap="square" anchor="t" lIns="0" rIns="0" tIns="0" bIns="0"/>
-          <a:lstStyle/>
-          <a:p>
-            <a:pPr algn="l">
-              <a:lnSpc>
-                <a:spcPct val="150000"/>
-              </a:lnSpc>
-            </a:pPr>
-            <a:r>
-              <a:rPr sz="1389" b="0">
-                <a:solidFill>
-                  <a:srgbClr val="626262"/>
-                </a:solidFill>
-                <a:latin typeface="Zen Kaku Gothic New"/>
-                <a:ea typeface="Zen Kaku Gothic New"/>
-                <a:cs typeface="Zen Kaku Gothic New"/>
-              </a:rPr>
-              <a:t>合宿の目的  3 / 3</a:t>
-            </a:r>
-          </a:p>
-        </p:txBody>
-      </p:sp>
-      <p:sp>
-        <p:nvSpPr>
-          <p:cNvPr id="5" name="TextBox 4"/>
-          <p:cNvSpPr txBox="1"/>
-          <p:nvPr/>
-        </p:nvSpPr>
-        <p:spPr>
-          <a:xfrm>
-            <a:off x="778213" y="2431915"/>
-            <a:ext cx="1621277" cy="1215957"/>
-          </a:xfrm>
-          <a:prstGeom prst="rect">
-            <a:avLst/>
-          </a:prstGeom>
-          <a:noFill/>
-        </p:spPr>
-        <p:txBody>
-          <a:bodyPr wrap="square" anchor="t" lIns="0" rIns="0" tIns="0" bIns="0"/>
-          <a:lstStyle/>
-          <a:p>
-            <a:pPr algn="l">
-              <a:lnSpc>
-                <a:spcPct val="100000"/>
-              </a:lnSpc>
-            </a:pPr>
-            <a:r>
-              <a:rPr sz="7578" b="1">
-                <a:solidFill>
-                  <a:srgbClr val="00D79C"/>
-                </a:solidFill>
-                <a:latin typeface="Outfit"/>
-                <a:ea typeface="Outfit"/>
-                <a:cs typeface="Outfit"/>
-              </a:rPr>
-              <a:t>3</a:t>
-            </a:r>
-          </a:p>
-        </p:txBody>
-      </p:sp>
-      <p:sp>
-        <p:nvSpPr>
-          <p:cNvPr id="6" name="TextBox 5"/>
-          <p:cNvSpPr txBox="1"/>
-          <p:nvPr/>
-        </p:nvSpPr>
-        <p:spPr>
-          <a:xfrm>
-            <a:off x="778213" y="3810000"/>
-            <a:ext cx="7782128" cy="729574"/>
-          </a:xfrm>
-          <a:prstGeom prst="rect">
-            <a:avLst/>
-          </a:prstGeom>
-          <a:noFill/>
-        </p:spPr>
-        <p:txBody>
-          <a:bodyPr wrap="square" anchor="t" lIns="0" rIns="0" tIns="0" bIns="0"/>
-          <a:lstStyle/>
-          <a:p>
-            <a:pPr algn="l">
+            <a:off x="453957" y="2618362"/>
+            <a:ext cx="8236085" cy="1621277"/>
+          </a:xfrm>
+          <a:prstGeom prst="rect">
+            <a:avLst/>
+          </a:prstGeom>
+          <a:noFill/>
+        </p:spPr>
+        <p:txBody>
+          <a:bodyPr wrap="square" anchor="ctr" lIns="0" rIns="0" tIns="0" bIns="0"/>
+          <a:lstStyle/>
+          <a:p>
+            <a:pPr algn="ctr">
               <a:lnSpc>
                 <a:spcPct val="150000"/>
               </a:lnSpc>
@@ -10186,7 +9988,7 @@
                 <a:ea typeface="Zen Kaku Gothic New"/>
                 <a:cs typeface="Zen Kaku Gothic New"/>
               </a:rPr>
-              <a:t>第8期の数字</a:t>
+              <a:t>全社の数字</a:t>
             </a:r>
           </a:p>
         </p:txBody>
@@ -10225,7 +10027,7 @@
                 <a:ea typeface="Zen Kaku Gothic New"/>
                 <a:cs typeface="Zen Kaku Gothic New"/>
               </a:rPr>
-              <a:t>第7期 → 第8期（前年比）　※税抜</a:t>
+              <a:t>第8期（2025年10月〜2026年9月）　※税抜</a:t>
             </a:r>
           </a:p>
         </p:txBody>
@@ -10277,8 +10079,8 @@
         </p:nvSpPr>
         <p:spPr>
           <a:xfrm>
-            <a:off x="453957" y="1394298"/>
-            <a:ext cx="2788596" cy="226979"/>
+            <a:off x="453957" y="1361872"/>
+            <a:ext cx="2756170" cy="243191"/>
           </a:xfrm>
           <a:prstGeom prst="rect">
             <a:avLst/>
@@ -10295,7 +10097,7 @@
               </a:lnSpc>
             </a:pPr>
             <a:r>
-              <a:rPr sz="1136" b="0">
+              <a:rPr sz="1389" b="0">
                 <a:solidFill>
                   <a:srgbClr val="626262"/>
                 </a:solidFill>
@@ -10303,7 +10105,7 @@
                 <a:ea typeface="Zen Kaku Gothic New"/>
                 <a:cs typeface="Zen Kaku Gothic New"/>
               </a:rPr>
-              <a:t>AND PLANTS / AND FLOWER</a:t>
+              <a:t>売上高</a:t>
             </a:r>
           </a:p>
         </p:txBody>
@@ -10316,8 +10118,8 @@
         </p:nvSpPr>
         <p:spPr>
           <a:xfrm>
-            <a:off x="453957" y="1653702"/>
-            <a:ext cx="2788596" cy="324255"/>
+            <a:off x="453957" y="1621277"/>
+            <a:ext cx="2756170" cy="680936"/>
           </a:xfrm>
           <a:prstGeom prst="rect">
             <a:avLst/>
@@ -10330,133 +10132,100 @@
           <a:p>
             <a:pPr algn="l">
               <a:lnSpc>
-                <a:spcPct val="150000"/>
-              </a:lnSpc>
-            </a:pPr>
-            <a:r>
-              <a:rPr sz="1768" b="1">
-                <a:solidFill>
-                  <a:srgbClr val="004347"/>
-                </a:solidFill>
-                <a:latin typeface="Zen Kaku Gothic New"/>
-                <a:ea typeface="Zen Kaku Gothic New"/>
-                <a:cs typeface="Zen Kaku Gothic New"/>
-              </a:rPr>
-              <a:t>売上</a:t>
-            </a:r>
-          </a:p>
-        </p:txBody>
-      </p:sp>
-      <p:sp>
-        <p:nvSpPr>
-          <p:cNvPr id="8" name="TextBox 7"/>
-          <p:cNvSpPr txBox="1"/>
-          <p:nvPr/>
-        </p:nvSpPr>
-        <p:spPr>
-          <a:xfrm>
-            <a:off x="453957" y="2026596"/>
-            <a:ext cx="2788596" cy="583660"/>
-          </a:xfrm>
-          <a:prstGeom prst="rect">
-            <a:avLst/>
-          </a:prstGeom>
-          <a:noFill/>
-        </p:spPr>
-        <p:txBody>
-          <a:bodyPr wrap="square" anchor="t" lIns="0" rIns="0" tIns="0" bIns="0"/>
-          <a:lstStyle/>
-          <a:p>
-            <a:pPr algn="l">
-              <a:lnSpc>
                 <a:spcPct val="100000"/>
               </a:lnSpc>
             </a:pPr>
             <a:r>
-              <a:rPr sz="3536" b="1">
-                <a:solidFill>
-                  <a:srgbClr val="00D79C"/>
+              <a:rPr sz="4547" b="1">
+                <a:solidFill>
+                  <a:srgbClr val="004347"/>
                 </a:solidFill>
                 <a:latin typeface="Outfit"/>
                 <a:ea typeface="Outfit"/>
                 <a:cs typeface="Outfit"/>
               </a:rPr>
-              <a:t>+2%</a:t>
-            </a:r>
-          </a:p>
-        </p:txBody>
-      </p:sp>
-      <p:sp>
-        <p:nvSpPr>
-          <p:cNvPr id="9" name="Rectangle 8"/>
-          <p:cNvSpPr/>
-          <p:nvPr/>
-        </p:nvSpPr>
-        <p:spPr>
-          <a:xfrm>
-            <a:off x="843064" y="3290753"/>
-            <a:ext cx="778213" cy="1735204"/>
-          </a:xfrm>
-          <a:prstGeom prst="rect">
-            <a:avLst/>
-          </a:prstGeom>
-          <a:solidFill>
-            <a:srgbClr val="CBD0D3"/>
-          </a:solidFill>
-          <a:ln>
-            <a:noFill/>
-          </a:ln>
-          <a:effectLst/>
-        </p:spPr>
-        <p:style>
-          <a:lnRef idx="1">
-            <a:schemeClr val="accent1"/>
-          </a:lnRef>
-          <a:fillRef idx="3">
-            <a:schemeClr val="accent1"/>
-          </a:fillRef>
-          <a:effectRef idx="2">
-            <a:schemeClr val="accent1"/>
-          </a:effectRef>
-          <a:fontRef idx="minor">
-            <a:schemeClr val="lt1"/>
-          </a:fontRef>
-        </p:style>
-        <p:txBody>
-          <a:bodyPr rtlCol="0" anchor="ctr"/>
-          <a:lstStyle/>
-          <a:p>
-            <a:pPr algn="ctr"/>
-          </a:p>
-        </p:txBody>
-      </p:sp>
-      <p:sp>
-        <p:nvSpPr>
-          <p:cNvPr id="10" name="TextBox 9"/>
-          <p:cNvSpPr txBox="1"/>
-          <p:nvPr/>
-        </p:nvSpPr>
-        <p:spPr>
-          <a:xfrm>
-            <a:off x="680936" y="2998924"/>
-            <a:ext cx="1102468" cy="243191"/>
-          </a:xfrm>
-          <a:prstGeom prst="rect">
-            <a:avLst/>
-          </a:prstGeom>
-          <a:noFill/>
-        </p:spPr>
-        <p:txBody>
-          <a:bodyPr wrap="square" anchor="t" lIns="0" rIns="0" tIns="0" bIns="0"/>
-          <a:lstStyle/>
-          <a:p>
-            <a:pPr algn="ctr">
-              <a:lnSpc>
-                <a:spcPct val="150000"/>
-              </a:lnSpc>
-            </a:pPr>
-            <a:r>
-              <a:rPr sz="1389" b="1">
+              <a:t>8.34</a:t>
+            </a:r>
+            <a:r>
+              <a:rPr sz="1578" b="1">
+                <a:solidFill>
+                  <a:srgbClr val="004347"/>
+                </a:solidFill>
+                <a:latin typeface="Zen Kaku Gothic New"/>
+                <a:ea typeface="Zen Kaku Gothic New"/>
+                <a:cs typeface="Zen Kaku Gothic New"/>
+              </a:rPr>
+              <a:t>億円</a:t>
+            </a:r>
+          </a:p>
+        </p:txBody>
+      </p:sp>
+      <p:sp>
+        <p:nvSpPr>
+          <p:cNvPr id="8" name="TextBox 7"/>
+          <p:cNvSpPr txBox="1"/>
+          <p:nvPr/>
+        </p:nvSpPr>
+        <p:spPr>
+          <a:xfrm>
+            <a:off x="453957" y="2577830"/>
+            <a:ext cx="2756170" cy="243191"/>
+          </a:xfrm>
+          <a:prstGeom prst="rect">
+            <a:avLst/>
+          </a:prstGeom>
+          <a:noFill/>
+        </p:spPr>
+        <p:txBody>
+          <a:bodyPr wrap="square" anchor="t" lIns="0" rIns="0" tIns="0" bIns="0"/>
+          <a:lstStyle/>
+          <a:p>
+            <a:pPr algn="l">
+              <a:lnSpc>
+                <a:spcPct val="150000"/>
+              </a:lnSpc>
+            </a:pPr>
+            <a:r>
+              <a:rPr sz="1389" b="0">
+                <a:solidFill>
+                  <a:srgbClr val="626262"/>
+                </a:solidFill>
+                <a:latin typeface="Zen Kaku Gothic New"/>
+                <a:ea typeface="Zen Kaku Gothic New"/>
+                <a:cs typeface="Zen Kaku Gothic New"/>
+              </a:rPr>
+              <a:t>売上総利益</a:t>
+            </a:r>
+          </a:p>
+        </p:txBody>
+      </p:sp>
+      <p:sp>
+        <p:nvSpPr>
+          <p:cNvPr id="9" name="TextBox 8"/>
+          <p:cNvSpPr txBox="1"/>
+          <p:nvPr/>
+        </p:nvSpPr>
+        <p:spPr>
+          <a:xfrm>
+            <a:off x="453957" y="2837234"/>
+            <a:ext cx="2756170" cy="680936"/>
+          </a:xfrm>
+          <a:prstGeom prst="rect">
+            <a:avLst/>
+          </a:prstGeom>
+          <a:noFill/>
+        </p:spPr>
+        <p:txBody>
+          <a:bodyPr wrap="square" anchor="t" lIns="0" rIns="0" tIns="0" bIns="0"/>
+          <a:lstStyle/>
+          <a:p>
+            <a:pPr algn="l">
+              <a:lnSpc>
+                <a:spcPct val="100000"/>
+              </a:lnSpc>
+            </a:pPr>
+            <a:r>
+              <a:rPr sz="4547" b="1">
                 <a:solidFill>
                   <a:srgbClr val="004347"/>
                 </a:solidFill>
@@ -10464,7 +10233,57 @@
                 <a:ea typeface="Outfit"/>
                 <a:cs typeface="Outfit"/>
               </a:rPr>
-              <a:t>7.2</a:t>
+              <a:t>5.02</a:t>
+            </a:r>
+            <a:r>
+              <a:rPr sz="1578" b="1">
+                <a:solidFill>
+                  <a:srgbClr val="004347"/>
+                </a:solidFill>
+                <a:latin typeface="Zen Kaku Gothic New"/>
+                <a:ea typeface="Zen Kaku Gothic New"/>
+                <a:cs typeface="Zen Kaku Gothic New"/>
+              </a:rPr>
+              <a:t>億円</a:t>
+            </a:r>
+          </a:p>
+        </p:txBody>
+      </p:sp>
+      <p:sp>
+        <p:nvSpPr>
+          <p:cNvPr id="10" name="TextBox 9"/>
+          <p:cNvSpPr txBox="1"/>
+          <p:nvPr/>
+        </p:nvSpPr>
+        <p:spPr>
+          <a:xfrm>
+            <a:off x="453957" y="3793787"/>
+            <a:ext cx="2756170" cy="243191"/>
+          </a:xfrm>
+          <a:prstGeom prst="rect">
+            <a:avLst/>
+          </a:prstGeom>
+          <a:noFill/>
+        </p:spPr>
+        <p:txBody>
+          <a:bodyPr wrap="square" anchor="t" lIns="0" rIns="0" tIns="0" bIns="0"/>
+          <a:lstStyle/>
+          <a:p>
+            <a:pPr algn="l">
+              <a:lnSpc>
+                <a:spcPct val="150000"/>
+              </a:lnSpc>
+            </a:pPr>
+            <a:r>
+              <a:rPr sz="1389" b="0">
+                <a:solidFill>
+                  <a:srgbClr val="626262"/>
+                </a:solidFill>
+                <a:latin typeface="Zen Kaku Gothic New"/>
+                <a:ea typeface="Zen Kaku Gothic New"/>
+                <a:cs typeface="Zen Kaku Gothic New"/>
+              </a:rPr>
+              <a:t>営業利益</a:t>
             </a:r>
           </a:p>
         </p:txBody>
@@ -10477,25 +10296,75 @@
         </p:nvSpPr>
         <p:spPr>
           <a:xfrm>
-            <a:off x="680936" y="5107021"/>
-            <a:ext cx="1102468" cy="226979"/>
-          </a:xfrm>
-          <a:prstGeom prst="rect">
-            <a:avLst/>
-          </a:prstGeom>
-          <a:noFill/>
-        </p:spPr>
-        <p:txBody>
-          <a:bodyPr wrap="square" anchor="t" lIns="0" rIns="0" tIns="0" bIns="0"/>
-          <a:lstStyle/>
-          <a:p>
-            <a:pPr algn="ctr">
-              <a:lnSpc>
-                <a:spcPct val="150000"/>
-              </a:lnSpc>
-            </a:pPr>
-            <a:r>
-              <a:rPr sz="1136" b="0">
+            <a:off x="453957" y="4053191"/>
+            <a:ext cx="2756170" cy="680936"/>
+          </a:xfrm>
+          <a:prstGeom prst="rect">
+            <a:avLst/>
+          </a:prstGeom>
+          <a:noFill/>
+        </p:spPr>
+        <p:txBody>
+          <a:bodyPr wrap="square" anchor="t" lIns="0" rIns="0" tIns="0" bIns="0"/>
+          <a:lstStyle/>
+          <a:p>
+            <a:pPr algn="l">
+              <a:lnSpc>
+                <a:spcPct val="100000"/>
+              </a:lnSpc>
+            </a:pPr>
+            <a:r>
+              <a:rPr sz="4547" b="1">
+                <a:solidFill>
+                  <a:srgbClr val="E16464"/>
+                </a:solidFill>
+                <a:latin typeface="Outfit"/>
+                <a:ea typeface="Outfit"/>
+                <a:cs typeface="Outfit"/>
+              </a:rPr>
+              <a:t>▲2.21</a:t>
+            </a:r>
+            <a:r>
+              <a:rPr sz="1578" b="1">
+                <a:solidFill>
+                  <a:srgbClr val="E16464"/>
+                </a:solidFill>
+                <a:latin typeface="Zen Kaku Gothic New"/>
+                <a:ea typeface="Zen Kaku Gothic New"/>
+                <a:cs typeface="Zen Kaku Gothic New"/>
+              </a:rPr>
+              <a:t>億円</a:t>
+            </a:r>
+          </a:p>
+        </p:txBody>
+      </p:sp>
+      <p:sp>
+        <p:nvSpPr>
+          <p:cNvPr id="12" name="TextBox 11"/>
+          <p:cNvSpPr txBox="1"/>
+          <p:nvPr/>
+        </p:nvSpPr>
+        <p:spPr>
+          <a:xfrm>
+            <a:off x="453957" y="4944894"/>
+            <a:ext cx="2756170" cy="243191"/>
+          </a:xfrm>
+          <a:prstGeom prst="rect">
+            <a:avLst/>
+          </a:prstGeom>
+          <a:noFill/>
+        </p:spPr>
+        <p:txBody>
+          <a:bodyPr wrap="square" anchor="t" lIns="0" rIns="0" tIns="0" bIns="0"/>
+          <a:lstStyle/>
+          <a:p>
+            <a:pPr algn="l">
+              <a:lnSpc>
+                <a:spcPct val="150000"/>
+              </a:lnSpc>
+            </a:pPr>
+            <a:r>
+              <a:rPr sz="1389" b="0">
                 <a:solidFill>
                   <a:srgbClr val="626262"/>
                 </a:solidFill>
@@ -10503,21 +10372,60 @@
                 <a:ea typeface="Zen Kaku Gothic New"/>
                 <a:cs typeface="Zen Kaku Gothic New"/>
               </a:rPr>
-              <a:t>第7期</a:t>
-            </a:r>
-          </a:p>
-        </p:txBody>
-      </p:sp>
-      <p:sp>
-        <p:nvSpPr>
-          <p:cNvPr id="12" name="Rectangle 11"/>
+              <a:t>粗利率 60%</a:t>
+            </a:r>
+          </a:p>
+        </p:txBody>
+      </p:sp>
+      <p:sp>
+        <p:nvSpPr>
+          <p:cNvPr id="13" name="TextBox 12"/>
+          <p:cNvSpPr txBox="1"/>
+          <p:nvPr/>
+        </p:nvSpPr>
+        <p:spPr>
+          <a:xfrm>
+            <a:off x="3501957" y="1361872"/>
+            <a:ext cx="3242553" cy="194553"/>
+          </a:xfrm>
+          <a:prstGeom prst="rect">
+            <a:avLst/>
+          </a:prstGeom>
+          <a:noFill/>
+        </p:spPr>
+        <p:txBody>
+          <a:bodyPr wrap="square" anchor="t" lIns="0" rIns="0" tIns="0" bIns="0"/>
+          <a:lstStyle/>
+          <a:p>
+            <a:pPr algn="l">
+              <a:lnSpc>
+                <a:spcPct val="150000"/>
+              </a:lnSpc>
+            </a:pPr>
+            <a:r>
+              <a:rPr sz="1010" b="0">
+                <a:solidFill>
+                  <a:srgbClr val="626262"/>
+                </a:solidFill>
+                <a:latin typeface="Zen Kaku Gothic New"/>
+                <a:ea typeface="Zen Kaku Gothic New"/>
+                <a:cs typeface="Zen Kaku Gothic New"/>
+              </a:rPr>
+              <a:t>月次売上　単位：百万円</a:t>
+            </a:r>
+          </a:p>
+        </p:txBody>
+      </p:sp>
+      <p:sp>
+        <p:nvSpPr>
+          <p:cNvPr id="14" name="Rectangle 13"/>
           <p:cNvSpPr/>
           <p:nvPr/>
         </p:nvSpPr>
         <p:spPr>
           <a:xfrm>
-            <a:off x="1945532" y="3242553"/>
-            <a:ext cx="778213" cy="1783404"/>
+            <a:off x="3501957" y="3443504"/>
+            <a:ext cx="324255" cy="1420326"/>
           </a:xfrm>
           <a:prstGeom prst="rect">
             <a:avLst/>
@@ -10554,14 +10462,14 @@
       </p:sp>
       <p:sp>
         <p:nvSpPr>
-          <p:cNvPr id="13" name="TextBox 12"/>
-          <p:cNvSpPr txBox="1"/>
-          <p:nvPr/>
-        </p:nvSpPr>
-        <p:spPr>
-          <a:xfrm>
-            <a:off x="1783404" y="2950723"/>
-            <a:ext cx="1102468" cy="243191"/>
+          <p:cNvPr id="15" name="TextBox 14"/>
+          <p:cNvSpPr txBox="1"/>
+          <p:nvPr/>
+        </p:nvSpPr>
+        <p:spPr>
+          <a:xfrm>
+            <a:off x="3420894" y="3216526"/>
+            <a:ext cx="486383" cy="194553"/>
           </a:xfrm>
           <a:prstGeom prst="rect">
             <a:avLst/>
@@ -10578,7 +10486,7 @@
               </a:lnSpc>
             </a:pPr>
             <a:r>
-              <a:rPr sz="1389" b="1">
+              <a:rPr sz="947" b="1">
                 <a:solidFill>
                   <a:srgbClr val="004347"/>
                 </a:solidFill>
@@ -10586,21 +10494,21 @@
                 <a:ea typeface="Outfit"/>
                 <a:cs typeface="Outfit"/>
               </a:rPr>
-              <a:t>7.4</a:t>
-            </a:r>
-          </a:p>
-        </p:txBody>
-      </p:sp>
-      <p:sp>
-        <p:nvSpPr>
-          <p:cNvPr id="14" name="TextBox 13"/>
-          <p:cNvSpPr txBox="1"/>
-          <p:nvPr/>
-        </p:nvSpPr>
-        <p:spPr>
-          <a:xfrm>
-            <a:off x="1783404" y="5107021"/>
-            <a:ext cx="1102468" cy="226979"/>
+              <a:t>59</a:t>
+            </a:r>
+          </a:p>
+        </p:txBody>
+      </p:sp>
+      <p:sp>
+        <p:nvSpPr>
+          <p:cNvPr id="16" name="TextBox 15"/>
+          <p:cNvSpPr txBox="1"/>
+          <p:nvPr/>
+        </p:nvSpPr>
+        <p:spPr>
+          <a:xfrm>
+            <a:off x="3420894" y="4928681"/>
+            <a:ext cx="486383" cy="194553"/>
           </a:xfrm>
           <a:prstGeom prst="rect">
             <a:avLst/>
@@ -10617,7 +10525,7 @@
               </a:lnSpc>
             </a:pPr>
             <a:r>
-              <a:rPr sz="1136" b="0">
+              <a:rPr sz="947" b="0">
                 <a:solidFill>
                   <a:srgbClr val="626262"/>
                 </a:solidFill>
@@ -10625,334 +10533,21 @@
                 <a:ea typeface="Zen Kaku Gothic New"/>
                 <a:cs typeface="Zen Kaku Gothic New"/>
               </a:rPr>
-              <a:t>第8期</a:t>
-            </a:r>
-          </a:p>
-        </p:txBody>
-      </p:sp>
-      <p:cxnSp>
-        <p:nvCxnSpPr>
-          <p:cNvPr id="15" name="Connector 14"/>
-          <p:cNvCxnSpPr/>
-          <p:nvPr/>
-        </p:nvCxnSpPr>
-        <p:spPr>
-          <a:xfrm>
-            <a:off x="648511" y="5025957"/>
-            <a:ext cx="2399489" cy="0"/>
-          </a:xfrm>
-          <a:prstGeom prst="line">
-            <a:avLst/>
-          </a:prstGeom>
-          <a:ln w="12700">
-            <a:solidFill>
-              <a:srgbClr val="C9CFCF"/>
-            </a:solidFill>
-          </a:ln>
-        </p:spPr>
-        <p:style>
-          <a:lnRef idx="2">
-            <a:schemeClr val="accent1"/>
-          </a:lnRef>
-          <a:fillRef idx="0">
-            <a:schemeClr val="accent1"/>
-          </a:fillRef>
-          <a:effectRef idx="1">
-            <a:schemeClr val="accent1"/>
-          </a:effectRef>
-          <a:fontRef idx="minor">
-            <a:schemeClr val="tx1"/>
-          </a:fontRef>
-        </p:style>
-      </p:cxnSp>
-      <p:sp>
-        <p:nvSpPr>
-          <p:cNvPr id="16" name="TextBox 15"/>
-          <p:cNvSpPr txBox="1"/>
-          <p:nvPr/>
-        </p:nvSpPr>
-        <p:spPr>
-          <a:xfrm>
-            <a:off x="453957" y="2691319"/>
-            <a:ext cx="2788596" cy="194553"/>
-          </a:xfrm>
-          <a:prstGeom prst="rect">
-            <a:avLst/>
-          </a:prstGeom>
-          <a:noFill/>
-        </p:spPr>
-        <p:txBody>
-          <a:bodyPr wrap="square" anchor="t" lIns="0" rIns="0" tIns="0" bIns="0"/>
-          <a:lstStyle/>
-          <a:p>
-            <a:pPr algn="l">
-              <a:lnSpc>
-                <a:spcPct val="150000"/>
-              </a:lnSpc>
-            </a:pPr>
-            <a:r>
-              <a:rPr sz="1010" b="0">
-                <a:solidFill>
-                  <a:srgbClr val="626262"/>
-                </a:solidFill>
-                <a:latin typeface="Zen Kaku Gothic New"/>
-                <a:ea typeface="Zen Kaku Gothic New"/>
-                <a:cs typeface="Zen Kaku Gothic New"/>
-              </a:rPr>
-              <a:t>単位：億円</a:t>
-            </a:r>
-          </a:p>
-        </p:txBody>
-      </p:sp>
-      <p:sp>
-        <p:nvSpPr>
-          <p:cNvPr id="17" name="TextBox 16"/>
-          <p:cNvSpPr txBox="1"/>
-          <p:nvPr/>
-        </p:nvSpPr>
-        <p:spPr>
-          <a:xfrm>
-            <a:off x="3372255" y="1394298"/>
-            <a:ext cx="2788596" cy="226979"/>
-          </a:xfrm>
-          <a:prstGeom prst="rect">
-            <a:avLst/>
-          </a:prstGeom>
-          <a:noFill/>
-        </p:spPr>
-        <p:txBody>
-          <a:bodyPr wrap="square" anchor="t" lIns="0" rIns="0" tIns="0" bIns="0"/>
-          <a:lstStyle/>
-          <a:p>
-            <a:pPr algn="l">
-              <a:lnSpc>
-                <a:spcPct val="150000"/>
-              </a:lnSpc>
-            </a:pPr>
-            <a:r>
-              <a:rPr sz="1136" b="0">
-                <a:solidFill>
-                  <a:srgbClr val="626262"/>
-                </a:solidFill>
-                <a:latin typeface="Zen Kaku Gothic New"/>
-                <a:ea typeface="Zen Kaku Gothic New"/>
-                <a:cs typeface="Zen Kaku Gothic New"/>
-              </a:rPr>
-              <a:t>AND PLANTS / AND FLOWER</a:t>
-            </a:r>
-          </a:p>
-        </p:txBody>
-      </p:sp>
-      <p:sp>
-        <p:nvSpPr>
-          <p:cNvPr id="18" name="TextBox 17"/>
-          <p:cNvSpPr txBox="1"/>
-          <p:nvPr/>
-        </p:nvSpPr>
-        <p:spPr>
-          <a:xfrm>
-            <a:off x="3372255" y="1653702"/>
-            <a:ext cx="2788596" cy="324255"/>
-          </a:xfrm>
-          <a:prstGeom prst="rect">
-            <a:avLst/>
-          </a:prstGeom>
-          <a:noFill/>
-        </p:spPr>
-        <p:txBody>
-          <a:bodyPr wrap="square" anchor="t" lIns="0" rIns="0" tIns="0" bIns="0"/>
-          <a:lstStyle/>
-          <a:p>
-            <a:pPr algn="l">
-              <a:lnSpc>
-                <a:spcPct val="150000"/>
-              </a:lnSpc>
-            </a:pPr>
-            <a:r>
-              <a:rPr sz="1768" b="1">
-                <a:solidFill>
-                  <a:srgbClr val="004347"/>
-                </a:solidFill>
-                <a:latin typeface="Zen Kaku Gothic New"/>
-                <a:ea typeface="Zen Kaku Gothic New"/>
-                <a:cs typeface="Zen Kaku Gothic New"/>
-              </a:rPr>
-              <a:t>広告費込み限界利益</a:t>
-            </a:r>
-          </a:p>
-        </p:txBody>
-      </p:sp>
-      <p:sp>
-        <p:nvSpPr>
-          <p:cNvPr id="19" name="TextBox 18"/>
-          <p:cNvSpPr txBox="1"/>
-          <p:nvPr/>
-        </p:nvSpPr>
-        <p:spPr>
-          <a:xfrm>
-            <a:off x="3372255" y="2026596"/>
-            <a:ext cx="2788596" cy="583660"/>
-          </a:xfrm>
-          <a:prstGeom prst="rect">
-            <a:avLst/>
-          </a:prstGeom>
-          <a:noFill/>
-        </p:spPr>
-        <p:txBody>
-          <a:bodyPr wrap="square" anchor="t" lIns="0" rIns="0" tIns="0" bIns="0"/>
-          <a:lstStyle/>
-          <a:p>
-            <a:pPr algn="l">
-              <a:lnSpc>
-                <a:spcPct val="100000"/>
-              </a:lnSpc>
-            </a:pPr>
-            <a:r>
-              <a:rPr sz="3536" b="1">
-                <a:solidFill>
-                  <a:srgbClr val="00D79C"/>
-                </a:solidFill>
-                <a:latin typeface="Outfit"/>
-                <a:ea typeface="Outfit"/>
-                <a:cs typeface="Outfit"/>
-              </a:rPr>
-              <a:t>+47%</a:t>
-            </a:r>
-          </a:p>
-        </p:txBody>
-      </p:sp>
-      <p:sp>
-        <p:nvSpPr>
-          <p:cNvPr id="20" name="Rectangle 19"/>
+              <a:t>10月</a:t>
+            </a:r>
+          </a:p>
+        </p:txBody>
+      </p:sp>
+      <p:sp>
+        <p:nvSpPr>
+          <p:cNvPr id="17" name="Rectangle 16"/>
           <p:cNvSpPr/>
           <p:nvPr/>
         </p:nvSpPr>
         <p:spPr>
           <a:xfrm>
-            <a:off x="3761362" y="3810000"/>
-            <a:ext cx="778213" cy="1215957"/>
-          </a:xfrm>
-          <a:prstGeom prst="rect">
-            <a:avLst/>
-          </a:prstGeom>
-          <a:solidFill>
-            <a:srgbClr val="CBD0D3"/>
-          </a:solidFill>
-          <a:ln>
-            <a:noFill/>
-          </a:ln>
-          <a:effectLst/>
-        </p:spPr>
-        <p:style>
-          <a:lnRef idx="1">
-            <a:schemeClr val="accent1"/>
-          </a:lnRef>
-          <a:fillRef idx="3">
-            <a:schemeClr val="accent1"/>
-          </a:fillRef>
-          <a:effectRef idx="2">
-            <a:schemeClr val="accent1"/>
-          </a:effectRef>
-          <a:fontRef idx="minor">
-            <a:schemeClr val="lt1"/>
-          </a:fontRef>
-        </p:style>
-        <p:txBody>
-          <a:bodyPr rtlCol="0" anchor="ctr"/>
-          <a:lstStyle/>
-          <a:p>
-            <a:pPr algn="ctr"/>
-          </a:p>
-        </p:txBody>
-      </p:sp>
-      <p:sp>
-        <p:nvSpPr>
-          <p:cNvPr id="21" name="TextBox 20"/>
-          <p:cNvSpPr txBox="1"/>
-          <p:nvPr/>
-        </p:nvSpPr>
-        <p:spPr>
-          <a:xfrm>
-            <a:off x="3599234" y="3518170"/>
-            <a:ext cx="1102468" cy="243191"/>
-          </a:xfrm>
-          <a:prstGeom prst="rect">
-            <a:avLst/>
-          </a:prstGeom>
-          <a:noFill/>
-        </p:spPr>
-        <p:txBody>
-          <a:bodyPr wrap="square" anchor="t" lIns="0" rIns="0" tIns="0" bIns="0"/>
-          <a:lstStyle/>
-          <a:p>
-            <a:pPr algn="ctr">
-              <a:lnSpc>
-                <a:spcPct val="150000"/>
-              </a:lnSpc>
-            </a:pPr>
-            <a:r>
-              <a:rPr sz="1389" b="1">
-                <a:solidFill>
-                  <a:srgbClr val="004347"/>
-                </a:solidFill>
-                <a:latin typeface="Outfit"/>
-                <a:ea typeface="Outfit"/>
-                <a:cs typeface="Outfit"/>
-              </a:rPr>
-              <a:t>1.5</a:t>
-            </a:r>
-          </a:p>
-        </p:txBody>
-      </p:sp>
-      <p:sp>
-        <p:nvSpPr>
-          <p:cNvPr id="22" name="TextBox 21"/>
-          <p:cNvSpPr txBox="1"/>
-          <p:nvPr/>
-        </p:nvSpPr>
-        <p:spPr>
-          <a:xfrm>
-            <a:off x="3599234" y="5107021"/>
-            <a:ext cx="1102468" cy="226979"/>
-          </a:xfrm>
-          <a:prstGeom prst="rect">
-            <a:avLst/>
-          </a:prstGeom>
-          <a:noFill/>
-        </p:spPr>
-        <p:txBody>
-          <a:bodyPr wrap="square" anchor="t" lIns="0" rIns="0" tIns="0" bIns="0"/>
-          <a:lstStyle/>
-          <a:p>
-            <a:pPr algn="ctr">
-              <a:lnSpc>
-                <a:spcPct val="150000"/>
-              </a:lnSpc>
-            </a:pPr>
-            <a:r>
-              <a:rPr sz="1136" b="0">
-                <a:solidFill>
-                  <a:srgbClr val="626262"/>
-                </a:solidFill>
-                <a:latin typeface="Zen Kaku Gothic New"/>
-                <a:ea typeface="Zen Kaku Gothic New"/>
-                <a:cs typeface="Zen Kaku Gothic New"/>
-              </a:rPr>
-              <a:t>第7期</a:t>
-            </a:r>
-          </a:p>
-        </p:txBody>
-      </p:sp>
-      <p:sp>
-        <p:nvSpPr>
-          <p:cNvPr id="23" name="Rectangle 22"/>
-          <p:cNvSpPr/>
-          <p:nvPr/>
-        </p:nvSpPr>
-        <p:spPr>
-          <a:xfrm>
-            <a:off x="4863830" y="3242553"/>
-            <a:ext cx="778213" cy="1783404"/>
+            <a:off x="3939702" y="3429109"/>
+            <a:ext cx="324255" cy="1434721"/>
           </a:xfrm>
           <a:prstGeom prst="rect">
             <a:avLst/>
@@ -10989,14 +10584,14 @@
       </p:sp>
       <p:sp>
         <p:nvSpPr>
-          <p:cNvPr id="24" name="TextBox 23"/>
-          <p:cNvSpPr txBox="1"/>
-          <p:nvPr/>
-        </p:nvSpPr>
-        <p:spPr>
-          <a:xfrm>
-            <a:off x="4701702" y="2950723"/>
-            <a:ext cx="1102468" cy="243191"/>
+          <p:cNvPr id="18" name="TextBox 17"/>
+          <p:cNvSpPr txBox="1"/>
+          <p:nvPr/>
+        </p:nvSpPr>
+        <p:spPr>
+          <a:xfrm>
+            <a:off x="3858638" y="3202130"/>
+            <a:ext cx="486383" cy="194553"/>
           </a:xfrm>
           <a:prstGeom prst="rect">
             <a:avLst/>
@@ -11013,7 +10608,7 @@
               </a:lnSpc>
             </a:pPr>
             <a:r>
-              <a:rPr sz="1389" b="1">
+              <a:rPr sz="947" b="1">
                 <a:solidFill>
                   <a:srgbClr val="004347"/>
                 </a:solidFill>
@@ -11021,21 +10616,21 @@
                 <a:ea typeface="Outfit"/>
                 <a:cs typeface="Outfit"/>
               </a:rPr>
-              <a:t>2.2</a:t>
-            </a:r>
-          </a:p>
-        </p:txBody>
-      </p:sp>
-      <p:sp>
-        <p:nvSpPr>
-          <p:cNvPr id="25" name="TextBox 24"/>
-          <p:cNvSpPr txBox="1"/>
-          <p:nvPr/>
-        </p:nvSpPr>
-        <p:spPr>
-          <a:xfrm>
-            <a:off x="4701702" y="5107021"/>
-            <a:ext cx="1102468" cy="226979"/>
+              <a:t>60</a:t>
+            </a:r>
+          </a:p>
+        </p:txBody>
+      </p:sp>
+      <p:sp>
+        <p:nvSpPr>
+          <p:cNvPr id="19" name="TextBox 18"/>
+          <p:cNvSpPr txBox="1"/>
+          <p:nvPr/>
+        </p:nvSpPr>
+        <p:spPr>
+          <a:xfrm>
+            <a:off x="3858638" y="4928681"/>
+            <a:ext cx="486383" cy="194553"/>
           </a:xfrm>
           <a:prstGeom prst="rect">
             <a:avLst/>
@@ -11052,7 +10647,7 @@
               </a:lnSpc>
             </a:pPr>
             <a:r>
-              <a:rPr sz="1136" b="0">
+              <a:rPr sz="947" b="0">
                 <a:solidFill>
                   <a:srgbClr val="626262"/>
                 </a:solidFill>
@@ -11060,334 +10655,21 @@
                 <a:ea typeface="Zen Kaku Gothic New"/>
                 <a:cs typeface="Zen Kaku Gothic New"/>
               </a:rPr>
-              <a:t>第8期</a:t>
-            </a:r>
-          </a:p>
-        </p:txBody>
-      </p:sp>
-      <p:cxnSp>
-        <p:nvCxnSpPr>
-          <p:cNvPr id="26" name="Connector 25"/>
-          <p:cNvCxnSpPr/>
-          <p:nvPr/>
-        </p:nvCxnSpPr>
-        <p:spPr>
-          <a:xfrm>
-            <a:off x="3566809" y="5025957"/>
-            <a:ext cx="2399489" cy="0"/>
-          </a:xfrm>
-          <a:prstGeom prst="line">
-            <a:avLst/>
-          </a:prstGeom>
-          <a:ln w="12700">
-            <a:solidFill>
-              <a:srgbClr val="C9CFCF"/>
-            </a:solidFill>
-          </a:ln>
-        </p:spPr>
-        <p:style>
-          <a:lnRef idx="2">
-            <a:schemeClr val="accent1"/>
-          </a:lnRef>
-          <a:fillRef idx="0">
-            <a:schemeClr val="accent1"/>
-          </a:fillRef>
-          <a:effectRef idx="1">
-            <a:schemeClr val="accent1"/>
-          </a:effectRef>
-          <a:fontRef idx="minor">
-            <a:schemeClr val="tx1"/>
-          </a:fontRef>
-        </p:style>
-      </p:cxnSp>
-      <p:sp>
-        <p:nvSpPr>
-          <p:cNvPr id="27" name="TextBox 26"/>
-          <p:cNvSpPr txBox="1"/>
-          <p:nvPr/>
-        </p:nvSpPr>
-        <p:spPr>
-          <a:xfrm>
-            <a:off x="3372255" y="2691319"/>
-            <a:ext cx="2788596" cy="194553"/>
-          </a:xfrm>
-          <a:prstGeom prst="rect">
-            <a:avLst/>
-          </a:prstGeom>
-          <a:noFill/>
-        </p:spPr>
-        <p:txBody>
-          <a:bodyPr wrap="square" anchor="t" lIns="0" rIns="0" tIns="0" bIns="0"/>
-          <a:lstStyle/>
-          <a:p>
-            <a:pPr algn="l">
-              <a:lnSpc>
-                <a:spcPct val="150000"/>
-              </a:lnSpc>
-            </a:pPr>
-            <a:r>
-              <a:rPr sz="1010" b="0">
-                <a:solidFill>
-                  <a:srgbClr val="626262"/>
-                </a:solidFill>
-                <a:latin typeface="Zen Kaku Gothic New"/>
-                <a:ea typeface="Zen Kaku Gothic New"/>
-                <a:cs typeface="Zen Kaku Gothic New"/>
-              </a:rPr>
-              <a:t>単位：億円</a:t>
-            </a:r>
-          </a:p>
-        </p:txBody>
-      </p:sp>
-      <p:sp>
-        <p:nvSpPr>
-          <p:cNvPr id="28" name="TextBox 27"/>
-          <p:cNvSpPr txBox="1"/>
-          <p:nvPr/>
-        </p:nvSpPr>
-        <p:spPr>
-          <a:xfrm>
-            <a:off x="6290553" y="1394298"/>
-            <a:ext cx="2788596" cy="226979"/>
-          </a:xfrm>
-          <a:prstGeom prst="rect">
-            <a:avLst/>
-          </a:prstGeom>
-          <a:noFill/>
-        </p:spPr>
-        <p:txBody>
-          <a:bodyPr wrap="square" anchor="t" lIns="0" rIns="0" tIns="0" bIns="0"/>
-          <a:lstStyle/>
-          <a:p>
-            <a:pPr algn="l">
-              <a:lnSpc>
-                <a:spcPct val="150000"/>
-              </a:lnSpc>
-            </a:pPr>
-            <a:r>
-              <a:rPr sz="1136" b="0">
-                <a:solidFill>
-                  <a:srgbClr val="626262"/>
-                </a:solidFill>
-                <a:latin typeface="Zen Kaku Gothic New"/>
-                <a:ea typeface="Zen Kaku Gothic New"/>
-                <a:cs typeface="Zen Kaku Gothic New"/>
-              </a:rPr>
-              <a:t>ハナイチ</a:t>
-            </a:r>
-          </a:p>
-        </p:txBody>
-      </p:sp>
-      <p:sp>
-        <p:nvSpPr>
-          <p:cNvPr id="29" name="TextBox 28"/>
-          <p:cNvSpPr txBox="1"/>
-          <p:nvPr/>
-        </p:nvSpPr>
-        <p:spPr>
-          <a:xfrm>
-            <a:off x="6290553" y="1653702"/>
-            <a:ext cx="2788596" cy="324255"/>
-          </a:xfrm>
-          <a:prstGeom prst="rect">
-            <a:avLst/>
-          </a:prstGeom>
-          <a:noFill/>
-        </p:spPr>
-        <p:txBody>
-          <a:bodyPr wrap="square" anchor="t" lIns="0" rIns="0" tIns="0" bIns="0"/>
-          <a:lstStyle/>
-          <a:p>
-            <a:pPr algn="l">
-              <a:lnSpc>
-                <a:spcPct val="150000"/>
-              </a:lnSpc>
-            </a:pPr>
-            <a:r>
-              <a:rPr sz="1768" b="1">
-                <a:solidFill>
-                  <a:srgbClr val="004347"/>
-                </a:solidFill>
-                <a:latin typeface="Zen Kaku Gothic New"/>
-                <a:ea typeface="Zen Kaku Gothic New"/>
-                <a:cs typeface="Zen Kaku Gothic New"/>
-              </a:rPr>
-              <a:t>売上</a:t>
-            </a:r>
-          </a:p>
-        </p:txBody>
-      </p:sp>
-      <p:sp>
-        <p:nvSpPr>
-          <p:cNvPr id="30" name="TextBox 29"/>
-          <p:cNvSpPr txBox="1"/>
-          <p:nvPr/>
-        </p:nvSpPr>
-        <p:spPr>
-          <a:xfrm>
-            <a:off x="6290553" y="2026596"/>
-            <a:ext cx="2788596" cy="583660"/>
-          </a:xfrm>
-          <a:prstGeom prst="rect">
-            <a:avLst/>
-          </a:prstGeom>
-          <a:noFill/>
-        </p:spPr>
-        <p:txBody>
-          <a:bodyPr wrap="square" anchor="t" lIns="0" rIns="0" tIns="0" bIns="0"/>
-          <a:lstStyle/>
-          <a:p>
-            <a:pPr algn="l">
-              <a:lnSpc>
-                <a:spcPct val="100000"/>
-              </a:lnSpc>
-            </a:pPr>
-            <a:r>
-              <a:rPr sz="3536" b="1">
-                <a:solidFill>
-                  <a:srgbClr val="00D79C"/>
-                </a:solidFill>
-                <a:latin typeface="Outfit"/>
-                <a:ea typeface="Outfit"/>
-                <a:cs typeface="Outfit"/>
-              </a:rPr>
-              <a:t>+22%</a:t>
-            </a:r>
-          </a:p>
-        </p:txBody>
-      </p:sp>
-      <p:sp>
-        <p:nvSpPr>
-          <p:cNvPr id="31" name="Rectangle 30"/>
+              <a:t>11月</a:t>
+            </a:r>
+          </a:p>
+        </p:txBody>
+      </p:sp>
+      <p:sp>
+        <p:nvSpPr>
+          <p:cNvPr id="20" name="Rectangle 19"/>
           <p:cNvSpPr/>
           <p:nvPr/>
         </p:nvSpPr>
         <p:spPr>
           <a:xfrm>
-            <a:off x="6679660" y="3561030"/>
-            <a:ext cx="778213" cy="1464928"/>
-          </a:xfrm>
-          <a:prstGeom prst="rect">
-            <a:avLst/>
-          </a:prstGeom>
-          <a:solidFill>
-            <a:srgbClr val="CBD0D3"/>
-          </a:solidFill>
-          <a:ln>
-            <a:noFill/>
-          </a:ln>
-          <a:effectLst/>
-        </p:spPr>
-        <p:style>
-          <a:lnRef idx="1">
-            <a:schemeClr val="accent1"/>
-          </a:lnRef>
-          <a:fillRef idx="3">
-            <a:schemeClr val="accent1"/>
-          </a:fillRef>
-          <a:effectRef idx="2">
-            <a:schemeClr val="accent1"/>
-          </a:effectRef>
-          <a:fontRef idx="minor">
-            <a:schemeClr val="lt1"/>
-          </a:fontRef>
-        </p:style>
-        <p:txBody>
-          <a:bodyPr rtlCol="0" anchor="ctr"/>
-          <a:lstStyle/>
-          <a:p>
-            <a:pPr algn="ctr"/>
-          </a:p>
-        </p:txBody>
-      </p:sp>
-      <p:sp>
-        <p:nvSpPr>
-          <p:cNvPr id="32" name="TextBox 31"/>
-          <p:cNvSpPr txBox="1"/>
-          <p:nvPr/>
-        </p:nvSpPr>
-        <p:spPr>
-          <a:xfrm>
-            <a:off x="6517532" y="3269200"/>
-            <a:ext cx="1102468" cy="243191"/>
-          </a:xfrm>
-          <a:prstGeom prst="rect">
-            <a:avLst/>
-          </a:prstGeom>
-          <a:noFill/>
-        </p:spPr>
-        <p:txBody>
-          <a:bodyPr wrap="square" anchor="t" lIns="0" rIns="0" tIns="0" bIns="0"/>
-          <a:lstStyle/>
-          <a:p>
-            <a:pPr algn="ctr">
-              <a:lnSpc>
-                <a:spcPct val="150000"/>
-              </a:lnSpc>
-            </a:pPr>
-            <a:r>
-              <a:rPr sz="1389" b="1">
-                <a:solidFill>
-                  <a:srgbClr val="004347"/>
-                </a:solidFill>
-                <a:latin typeface="Outfit"/>
-                <a:ea typeface="Outfit"/>
-                <a:cs typeface="Outfit"/>
-              </a:rPr>
-              <a:t>4,540</a:t>
-            </a:r>
-          </a:p>
-        </p:txBody>
-      </p:sp>
-      <p:sp>
-        <p:nvSpPr>
-          <p:cNvPr id="33" name="TextBox 32"/>
-          <p:cNvSpPr txBox="1"/>
-          <p:nvPr/>
-        </p:nvSpPr>
-        <p:spPr>
-          <a:xfrm>
-            <a:off x="6517532" y="5107021"/>
-            <a:ext cx="1102468" cy="226979"/>
-          </a:xfrm>
-          <a:prstGeom prst="rect">
-            <a:avLst/>
-          </a:prstGeom>
-          <a:noFill/>
-        </p:spPr>
-        <p:txBody>
-          <a:bodyPr wrap="square" anchor="t" lIns="0" rIns="0" tIns="0" bIns="0"/>
-          <a:lstStyle/>
-          <a:p>
-            <a:pPr algn="ctr">
-              <a:lnSpc>
-                <a:spcPct val="150000"/>
-              </a:lnSpc>
-            </a:pPr>
-            <a:r>
-              <a:rPr sz="1136" b="0">
-                <a:solidFill>
-                  <a:srgbClr val="626262"/>
-                </a:solidFill>
-                <a:latin typeface="Zen Kaku Gothic New"/>
-                <a:ea typeface="Zen Kaku Gothic New"/>
-                <a:cs typeface="Zen Kaku Gothic New"/>
-              </a:rPr>
-              <a:t>第7期</a:t>
-            </a:r>
-          </a:p>
-        </p:txBody>
-      </p:sp>
-      <p:sp>
-        <p:nvSpPr>
-          <p:cNvPr id="34" name="Rectangle 33"/>
-          <p:cNvSpPr/>
-          <p:nvPr/>
-        </p:nvSpPr>
-        <p:spPr>
-          <a:xfrm>
-            <a:off x="7782128" y="3242553"/>
-            <a:ext cx="778213" cy="1783404"/>
+            <a:off x="4377447" y="3429109"/>
+            <a:ext cx="324255" cy="1434721"/>
           </a:xfrm>
           <a:prstGeom prst="rect">
             <a:avLst/>
@@ -11424,14 +10706,14 @@
       </p:sp>
       <p:sp>
         <p:nvSpPr>
-          <p:cNvPr id="35" name="TextBox 34"/>
-          <p:cNvSpPr txBox="1"/>
-          <p:nvPr/>
-        </p:nvSpPr>
-        <p:spPr>
-          <a:xfrm>
-            <a:off x="7620000" y="2950723"/>
-            <a:ext cx="1102468" cy="243191"/>
+          <p:cNvPr id="21" name="TextBox 20"/>
+          <p:cNvSpPr txBox="1"/>
+          <p:nvPr/>
+        </p:nvSpPr>
+        <p:spPr>
+          <a:xfrm>
+            <a:off x="4296383" y="3202130"/>
+            <a:ext cx="486383" cy="194553"/>
           </a:xfrm>
           <a:prstGeom prst="rect">
             <a:avLst/>
@@ -11448,7 +10730,7 @@
               </a:lnSpc>
             </a:pPr>
             <a:r>
-              <a:rPr sz="1389" b="1">
+              <a:rPr sz="947" b="1">
                 <a:solidFill>
                   <a:srgbClr val="004347"/>
                 </a:solidFill>
@@ -11456,8 +10738,579 @@
                 <a:ea typeface="Outfit"/>
                 <a:cs typeface="Outfit"/>
               </a:rPr>
-              <a:t>5,527</a:t>
-            </a:r>
+              <a:t>60</a:t>
+            </a:r>
+          </a:p>
+        </p:txBody>
+      </p:sp>
+      <p:sp>
+        <p:nvSpPr>
+          <p:cNvPr id="22" name="TextBox 21"/>
+          <p:cNvSpPr txBox="1"/>
+          <p:nvPr/>
+        </p:nvSpPr>
+        <p:spPr>
+          <a:xfrm>
+            <a:off x="4296383" y="4928681"/>
+            <a:ext cx="486383" cy="194553"/>
+          </a:xfrm>
+          <a:prstGeom prst="rect">
+            <a:avLst/>
+          </a:prstGeom>
+          <a:noFill/>
+        </p:spPr>
+        <p:txBody>
+          <a:bodyPr wrap="square" anchor="t" lIns="0" rIns="0" tIns="0" bIns="0"/>
+          <a:lstStyle/>
+          <a:p>
+            <a:pPr algn="ctr">
+              <a:lnSpc>
+                <a:spcPct val="150000"/>
+              </a:lnSpc>
+            </a:pPr>
+            <a:r>
+              <a:rPr sz="947" b="0">
+                <a:solidFill>
+                  <a:srgbClr val="626262"/>
+                </a:solidFill>
+                <a:latin typeface="Zen Kaku Gothic New"/>
+                <a:ea typeface="Zen Kaku Gothic New"/>
+                <a:cs typeface="Zen Kaku Gothic New"/>
+              </a:rPr>
+              <a:t>12月</a:t>
+            </a:r>
+          </a:p>
+        </p:txBody>
+      </p:sp>
+      <p:sp>
+        <p:nvSpPr>
+          <p:cNvPr id="23" name="Rectangle 22"/>
+          <p:cNvSpPr/>
+          <p:nvPr/>
+        </p:nvSpPr>
+        <p:spPr>
+          <a:xfrm>
+            <a:off x="4815191" y="2961265"/>
+            <a:ext cx="324255" cy="1902564"/>
+          </a:xfrm>
+          <a:prstGeom prst="rect">
+            <a:avLst/>
+          </a:prstGeom>
+          <a:solidFill>
+            <a:srgbClr val="004347"/>
+          </a:solidFill>
+          <a:ln>
+            <a:noFill/>
+          </a:ln>
+          <a:effectLst/>
+        </p:spPr>
+        <p:style>
+          <a:lnRef idx="1">
+            <a:schemeClr val="accent1"/>
+          </a:lnRef>
+          <a:fillRef idx="3">
+            <a:schemeClr val="accent1"/>
+          </a:fillRef>
+          <a:effectRef idx="2">
+            <a:schemeClr val="accent1"/>
+          </a:effectRef>
+          <a:fontRef idx="minor">
+            <a:schemeClr val="lt1"/>
+          </a:fontRef>
+        </p:style>
+        <p:txBody>
+          <a:bodyPr rtlCol="0" anchor="ctr"/>
+          <a:lstStyle/>
+          <a:p>
+            <a:pPr algn="ctr"/>
+          </a:p>
+        </p:txBody>
+      </p:sp>
+      <p:sp>
+        <p:nvSpPr>
+          <p:cNvPr id="24" name="TextBox 23"/>
+          <p:cNvSpPr txBox="1"/>
+          <p:nvPr/>
+        </p:nvSpPr>
+        <p:spPr>
+          <a:xfrm>
+            <a:off x="4734128" y="2734287"/>
+            <a:ext cx="486383" cy="194553"/>
+          </a:xfrm>
+          <a:prstGeom prst="rect">
+            <a:avLst/>
+          </a:prstGeom>
+          <a:noFill/>
+        </p:spPr>
+        <p:txBody>
+          <a:bodyPr wrap="square" anchor="t" lIns="0" rIns="0" tIns="0" bIns="0"/>
+          <a:lstStyle/>
+          <a:p>
+            <a:pPr algn="ctr">
+              <a:lnSpc>
+                <a:spcPct val="150000"/>
+              </a:lnSpc>
+            </a:pPr>
+            <a:r>
+              <a:rPr sz="947" b="1">
+                <a:solidFill>
+                  <a:srgbClr val="004347"/>
+                </a:solidFill>
+                <a:latin typeface="Outfit"/>
+                <a:ea typeface="Outfit"/>
+                <a:cs typeface="Outfit"/>
+              </a:rPr>
+              <a:t>79</a:t>
+            </a:r>
+          </a:p>
+        </p:txBody>
+      </p:sp>
+      <p:sp>
+        <p:nvSpPr>
+          <p:cNvPr id="25" name="TextBox 24"/>
+          <p:cNvSpPr txBox="1"/>
+          <p:nvPr/>
+        </p:nvSpPr>
+        <p:spPr>
+          <a:xfrm>
+            <a:off x="4734128" y="4928681"/>
+            <a:ext cx="486383" cy="194553"/>
+          </a:xfrm>
+          <a:prstGeom prst="rect">
+            <a:avLst/>
+          </a:prstGeom>
+          <a:noFill/>
+        </p:spPr>
+        <p:txBody>
+          <a:bodyPr wrap="square" anchor="t" lIns="0" rIns="0" tIns="0" bIns="0"/>
+          <a:lstStyle/>
+          <a:p>
+            <a:pPr algn="ctr">
+              <a:lnSpc>
+                <a:spcPct val="150000"/>
+              </a:lnSpc>
+            </a:pPr>
+            <a:r>
+              <a:rPr sz="947" b="0">
+                <a:solidFill>
+                  <a:srgbClr val="626262"/>
+                </a:solidFill>
+                <a:latin typeface="Zen Kaku Gothic New"/>
+                <a:ea typeface="Zen Kaku Gothic New"/>
+                <a:cs typeface="Zen Kaku Gothic New"/>
+              </a:rPr>
+              <a:t>1月</a:t>
+            </a:r>
+          </a:p>
+        </p:txBody>
+      </p:sp>
+      <p:sp>
+        <p:nvSpPr>
+          <p:cNvPr id="26" name="Rectangle 25"/>
+          <p:cNvSpPr/>
+          <p:nvPr/>
+        </p:nvSpPr>
+        <p:spPr>
+          <a:xfrm>
+            <a:off x="5252936" y="3549069"/>
+            <a:ext cx="324255" cy="1314761"/>
+          </a:xfrm>
+          <a:prstGeom prst="rect">
+            <a:avLst/>
+          </a:prstGeom>
+          <a:solidFill>
+            <a:srgbClr val="004347"/>
+          </a:solidFill>
+          <a:ln>
+            <a:noFill/>
+          </a:ln>
+          <a:effectLst/>
+        </p:spPr>
+        <p:style>
+          <a:lnRef idx="1">
+            <a:schemeClr val="accent1"/>
+          </a:lnRef>
+          <a:fillRef idx="3">
+            <a:schemeClr val="accent1"/>
+          </a:fillRef>
+          <a:effectRef idx="2">
+            <a:schemeClr val="accent1"/>
+          </a:effectRef>
+          <a:fontRef idx="minor">
+            <a:schemeClr val="lt1"/>
+          </a:fontRef>
+        </p:style>
+        <p:txBody>
+          <a:bodyPr rtlCol="0" anchor="ctr"/>
+          <a:lstStyle/>
+          <a:p>
+            <a:pPr algn="ctr"/>
+          </a:p>
+        </p:txBody>
+      </p:sp>
+      <p:sp>
+        <p:nvSpPr>
+          <p:cNvPr id="27" name="TextBox 26"/>
+          <p:cNvSpPr txBox="1"/>
+          <p:nvPr/>
+        </p:nvSpPr>
+        <p:spPr>
+          <a:xfrm>
+            <a:off x="5171872" y="3322090"/>
+            <a:ext cx="486383" cy="194553"/>
+          </a:xfrm>
+          <a:prstGeom prst="rect">
+            <a:avLst/>
+          </a:prstGeom>
+          <a:noFill/>
+        </p:spPr>
+        <p:txBody>
+          <a:bodyPr wrap="square" anchor="t" lIns="0" rIns="0" tIns="0" bIns="0"/>
+          <a:lstStyle/>
+          <a:p>
+            <a:pPr algn="ctr">
+              <a:lnSpc>
+                <a:spcPct val="150000"/>
+              </a:lnSpc>
+            </a:pPr>
+            <a:r>
+              <a:rPr sz="947" b="1">
+                <a:solidFill>
+                  <a:srgbClr val="004347"/>
+                </a:solidFill>
+                <a:latin typeface="Outfit"/>
+                <a:ea typeface="Outfit"/>
+                <a:cs typeface="Outfit"/>
+              </a:rPr>
+              <a:t>55</a:t>
+            </a:r>
+          </a:p>
+        </p:txBody>
+      </p:sp>
+      <p:sp>
+        <p:nvSpPr>
+          <p:cNvPr id="28" name="TextBox 27"/>
+          <p:cNvSpPr txBox="1"/>
+          <p:nvPr/>
+        </p:nvSpPr>
+        <p:spPr>
+          <a:xfrm>
+            <a:off x="5171872" y="4928681"/>
+            <a:ext cx="486383" cy="194553"/>
+          </a:xfrm>
+          <a:prstGeom prst="rect">
+            <a:avLst/>
+          </a:prstGeom>
+          <a:noFill/>
+        </p:spPr>
+        <p:txBody>
+          <a:bodyPr wrap="square" anchor="t" lIns="0" rIns="0" tIns="0" bIns="0"/>
+          <a:lstStyle/>
+          <a:p>
+            <a:pPr algn="ctr">
+              <a:lnSpc>
+                <a:spcPct val="150000"/>
+              </a:lnSpc>
+            </a:pPr>
+            <a:r>
+              <a:rPr sz="947" b="0">
+                <a:solidFill>
+                  <a:srgbClr val="626262"/>
+                </a:solidFill>
+                <a:latin typeface="Zen Kaku Gothic New"/>
+                <a:ea typeface="Zen Kaku Gothic New"/>
+                <a:cs typeface="Zen Kaku Gothic New"/>
+              </a:rPr>
+              <a:t>2月</a:t>
+            </a:r>
+          </a:p>
+        </p:txBody>
+      </p:sp>
+      <p:sp>
+        <p:nvSpPr>
+          <p:cNvPr id="29" name="Rectangle 28"/>
+          <p:cNvSpPr/>
+          <p:nvPr/>
+        </p:nvSpPr>
+        <p:spPr>
+          <a:xfrm>
+            <a:off x="5690681" y="3244371"/>
+            <a:ext cx="324255" cy="1619459"/>
+          </a:xfrm>
+          <a:prstGeom prst="rect">
+            <a:avLst/>
+          </a:prstGeom>
+          <a:solidFill>
+            <a:srgbClr val="004347"/>
+          </a:solidFill>
+          <a:ln>
+            <a:noFill/>
+          </a:ln>
+          <a:effectLst/>
+        </p:spPr>
+        <p:style>
+          <a:lnRef idx="1">
+            <a:schemeClr val="accent1"/>
+          </a:lnRef>
+          <a:fillRef idx="3">
+            <a:schemeClr val="accent1"/>
+          </a:fillRef>
+          <a:effectRef idx="2">
+            <a:schemeClr val="accent1"/>
+          </a:effectRef>
+          <a:fontRef idx="minor">
+            <a:schemeClr val="lt1"/>
+          </a:fontRef>
+        </p:style>
+        <p:txBody>
+          <a:bodyPr rtlCol="0" anchor="ctr"/>
+          <a:lstStyle/>
+          <a:p>
+            <a:pPr algn="ctr"/>
+          </a:p>
+        </p:txBody>
+      </p:sp>
+      <p:sp>
+        <p:nvSpPr>
+          <p:cNvPr id="30" name="TextBox 29"/>
+          <p:cNvSpPr txBox="1"/>
+          <p:nvPr/>
+        </p:nvSpPr>
+        <p:spPr>
+          <a:xfrm>
+            <a:off x="5609617" y="3017392"/>
+            <a:ext cx="486383" cy="194553"/>
+          </a:xfrm>
+          <a:prstGeom prst="rect">
+            <a:avLst/>
+          </a:prstGeom>
+          <a:noFill/>
+        </p:spPr>
+        <p:txBody>
+          <a:bodyPr wrap="square" anchor="t" lIns="0" rIns="0" tIns="0" bIns="0"/>
+          <a:lstStyle/>
+          <a:p>
+            <a:pPr algn="ctr">
+              <a:lnSpc>
+                <a:spcPct val="150000"/>
+              </a:lnSpc>
+            </a:pPr>
+            <a:r>
+              <a:rPr sz="947" b="1">
+                <a:solidFill>
+                  <a:srgbClr val="004347"/>
+                </a:solidFill>
+                <a:latin typeface="Outfit"/>
+                <a:ea typeface="Outfit"/>
+                <a:cs typeface="Outfit"/>
+              </a:rPr>
+              <a:t>68</a:t>
+            </a:r>
+          </a:p>
+        </p:txBody>
+      </p:sp>
+      <p:sp>
+        <p:nvSpPr>
+          <p:cNvPr id="31" name="TextBox 30"/>
+          <p:cNvSpPr txBox="1"/>
+          <p:nvPr/>
+        </p:nvSpPr>
+        <p:spPr>
+          <a:xfrm>
+            <a:off x="5609617" y="4928681"/>
+            <a:ext cx="486383" cy="194553"/>
+          </a:xfrm>
+          <a:prstGeom prst="rect">
+            <a:avLst/>
+          </a:prstGeom>
+          <a:noFill/>
+        </p:spPr>
+        <p:txBody>
+          <a:bodyPr wrap="square" anchor="t" lIns="0" rIns="0" tIns="0" bIns="0"/>
+          <a:lstStyle/>
+          <a:p>
+            <a:pPr algn="ctr">
+              <a:lnSpc>
+                <a:spcPct val="150000"/>
+              </a:lnSpc>
+            </a:pPr>
+            <a:r>
+              <a:rPr sz="947" b="0">
+                <a:solidFill>
+                  <a:srgbClr val="626262"/>
+                </a:solidFill>
+                <a:latin typeface="Zen Kaku Gothic New"/>
+                <a:ea typeface="Zen Kaku Gothic New"/>
+                <a:cs typeface="Zen Kaku Gothic New"/>
+              </a:rPr>
+              <a:t>3月</a:t>
+            </a:r>
+          </a:p>
+        </p:txBody>
+      </p:sp>
+      <p:sp>
+        <p:nvSpPr>
+          <p:cNvPr id="32" name="Rectangle 31"/>
+          <p:cNvSpPr/>
+          <p:nvPr/>
+        </p:nvSpPr>
+        <p:spPr>
+          <a:xfrm>
+            <a:off x="6128426" y="2503018"/>
+            <a:ext cx="324255" cy="2360811"/>
+          </a:xfrm>
+          <a:prstGeom prst="rect">
+            <a:avLst/>
+          </a:prstGeom>
+          <a:solidFill>
+            <a:srgbClr val="004347"/>
+          </a:solidFill>
+          <a:ln>
+            <a:noFill/>
+          </a:ln>
+          <a:effectLst/>
+        </p:spPr>
+        <p:style>
+          <a:lnRef idx="1">
+            <a:schemeClr val="accent1"/>
+          </a:lnRef>
+          <a:fillRef idx="3">
+            <a:schemeClr val="accent1"/>
+          </a:fillRef>
+          <a:effectRef idx="2">
+            <a:schemeClr val="accent1"/>
+          </a:effectRef>
+          <a:fontRef idx="minor">
+            <a:schemeClr val="lt1"/>
+          </a:fontRef>
+        </p:style>
+        <p:txBody>
+          <a:bodyPr rtlCol="0" anchor="ctr"/>
+          <a:lstStyle/>
+          <a:p>
+            <a:pPr algn="ctr"/>
+          </a:p>
+        </p:txBody>
+      </p:sp>
+      <p:sp>
+        <p:nvSpPr>
+          <p:cNvPr id="33" name="TextBox 32"/>
+          <p:cNvSpPr txBox="1"/>
+          <p:nvPr/>
+        </p:nvSpPr>
+        <p:spPr>
+          <a:xfrm>
+            <a:off x="6047362" y="2276040"/>
+            <a:ext cx="486383" cy="194553"/>
+          </a:xfrm>
+          <a:prstGeom prst="rect">
+            <a:avLst/>
+          </a:prstGeom>
+          <a:noFill/>
+        </p:spPr>
+        <p:txBody>
+          <a:bodyPr wrap="square" anchor="t" lIns="0" rIns="0" tIns="0" bIns="0"/>
+          <a:lstStyle/>
+          <a:p>
+            <a:pPr algn="ctr">
+              <a:lnSpc>
+                <a:spcPct val="150000"/>
+              </a:lnSpc>
+            </a:pPr>
+            <a:r>
+              <a:rPr sz="947" b="1">
+                <a:solidFill>
+                  <a:srgbClr val="004347"/>
+                </a:solidFill>
+                <a:latin typeface="Outfit"/>
+                <a:ea typeface="Outfit"/>
+                <a:cs typeface="Outfit"/>
+              </a:rPr>
+              <a:t>98</a:t>
+            </a:r>
+          </a:p>
+        </p:txBody>
+      </p:sp>
+      <p:sp>
+        <p:nvSpPr>
+          <p:cNvPr id="34" name="TextBox 33"/>
+          <p:cNvSpPr txBox="1"/>
+          <p:nvPr/>
+        </p:nvSpPr>
+        <p:spPr>
+          <a:xfrm>
+            <a:off x="6047362" y="4928681"/>
+            <a:ext cx="486383" cy="194553"/>
+          </a:xfrm>
+          <a:prstGeom prst="rect">
+            <a:avLst/>
+          </a:prstGeom>
+          <a:noFill/>
+        </p:spPr>
+        <p:txBody>
+          <a:bodyPr wrap="square" anchor="t" lIns="0" rIns="0" tIns="0" bIns="0"/>
+          <a:lstStyle/>
+          <a:p>
+            <a:pPr algn="ctr">
+              <a:lnSpc>
+                <a:spcPct val="150000"/>
+              </a:lnSpc>
+            </a:pPr>
+            <a:r>
+              <a:rPr sz="947" b="0">
+                <a:solidFill>
+                  <a:srgbClr val="626262"/>
+                </a:solidFill>
+                <a:latin typeface="Zen Kaku Gothic New"/>
+                <a:ea typeface="Zen Kaku Gothic New"/>
+                <a:cs typeface="Zen Kaku Gothic New"/>
+              </a:rPr>
+              <a:t>4月</a:t>
+            </a:r>
+          </a:p>
+        </p:txBody>
+      </p:sp>
+      <p:sp>
+        <p:nvSpPr>
+          <p:cNvPr id="35" name="Rectangle 34"/>
+          <p:cNvSpPr/>
+          <p:nvPr/>
+        </p:nvSpPr>
+        <p:spPr>
+          <a:xfrm>
+            <a:off x="6566170" y="2188723"/>
+            <a:ext cx="324255" cy="2675106"/>
+          </a:xfrm>
+          <a:prstGeom prst="rect">
+            <a:avLst/>
+          </a:prstGeom>
+          <a:solidFill>
+            <a:srgbClr val="00D79C"/>
+          </a:solidFill>
+          <a:ln>
+            <a:noFill/>
+          </a:ln>
+          <a:effectLst/>
+        </p:spPr>
+        <p:style>
+          <a:lnRef idx="1">
+            <a:schemeClr val="accent1"/>
+          </a:lnRef>
+          <a:fillRef idx="3">
+            <a:schemeClr val="accent1"/>
+          </a:fillRef>
+          <a:effectRef idx="2">
+            <a:schemeClr val="accent1"/>
+          </a:effectRef>
+          <a:fontRef idx="minor">
+            <a:schemeClr val="lt1"/>
+          </a:fontRef>
+        </p:style>
+        <p:txBody>
+          <a:bodyPr rtlCol="0" anchor="ctr"/>
+          <a:lstStyle/>
+          <a:p>
+            <a:pPr algn="ctr"/>
           </a:p>
         </p:txBody>
       </p:sp>
@@ -11469,8 +11322,8 @@
         </p:nvSpPr>
         <p:spPr>
           <a:xfrm>
-            <a:off x="7620000" y="5107021"/>
-            <a:ext cx="1102468" cy="226979"/>
+            <a:off x="6485106" y="1961745"/>
+            <a:ext cx="486383" cy="194553"/>
           </a:xfrm>
           <a:prstGeom prst="rect">
             <a:avLst/>
@@ -11487,7 +11340,46 @@
               </a:lnSpc>
             </a:pPr>
             <a:r>
-              <a:rPr sz="1136" b="0">
+              <a:rPr sz="947" b="1">
+                <a:solidFill>
+                  <a:srgbClr val="004347"/>
+                </a:solidFill>
+                <a:latin typeface="Outfit"/>
+                <a:ea typeface="Outfit"/>
+                <a:cs typeface="Outfit"/>
+              </a:rPr>
+              <a:t>112</a:t>
+            </a:r>
+          </a:p>
+        </p:txBody>
+      </p:sp>
+      <p:sp>
+        <p:nvSpPr>
+          <p:cNvPr id="37" name="TextBox 36"/>
+          <p:cNvSpPr txBox="1"/>
+          <p:nvPr/>
+        </p:nvSpPr>
+        <p:spPr>
+          <a:xfrm>
+            <a:off x="6485106" y="4928681"/>
+            <a:ext cx="486383" cy="194553"/>
+          </a:xfrm>
+          <a:prstGeom prst="rect">
+            <a:avLst/>
+          </a:prstGeom>
+          <a:noFill/>
+        </p:spPr>
+        <p:txBody>
+          <a:bodyPr wrap="square" anchor="t" lIns="0" rIns="0" tIns="0" bIns="0"/>
+          <a:lstStyle/>
+          <a:p>
+            <a:pPr algn="ctr">
+              <a:lnSpc>
+                <a:spcPct val="150000"/>
+              </a:lnSpc>
+            </a:pPr>
+            <a:r>
+              <a:rPr sz="947" b="0">
                 <a:solidFill>
                   <a:srgbClr val="626262"/>
                 </a:solidFill>
@@ -11495,21 +11387,509 @@
                 <a:ea typeface="Zen Kaku Gothic New"/>
                 <a:cs typeface="Zen Kaku Gothic New"/>
               </a:rPr>
-              <a:t>第8期</a:t>
+              <a:t>5月</a:t>
+            </a:r>
+          </a:p>
+        </p:txBody>
+      </p:sp>
+      <p:sp>
+        <p:nvSpPr>
+          <p:cNvPr id="38" name="Rectangle 37"/>
+          <p:cNvSpPr/>
+          <p:nvPr/>
+        </p:nvSpPr>
+        <p:spPr>
+          <a:xfrm>
+            <a:off x="7003915" y="3376327"/>
+            <a:ext cx="324255" cy="1487503"/>
+          </a:xfrm>
+          <a:prstGeom prst="rect">
+            <a:avLst/>
+          </a:prstGeom>
+          <a:solidFill>
+            <a:srgbClr val="004347"/>
+          </a:solidFill>
+          <a:ln>
+            <a:noFill/>
+          </a:ln>
+          <a:effectLst/>
+        </p:spPr>
+        <p:style>
+          <a:lnRef idx="1">
+            <a:schemeClr val="accent1"/>
+          </a:lnRef>
+          <a:fillRef idx="3">
+            <a:schemeClr val="accent1"/>
+          </a:fillRef>
+          <a:effectRef idx="2">
+            <a:schemeClr val="accent1"/>
+          </a:effectRef>
+          <a:fontRef idx="minor">
+            <a:schemeClr val="lt1"/>
+          </a:fontRef>
+        </p:style>
+        <p:txBody>
+          <a:bodyPr rtlCol="0" anchor="ctr"/>
+          <a:lstStyle/>
+          <a:p>
+            <a:pPr algn="ctr"/>
+          </a:p>
+        </p:txBody>
+      </p:sp>
+      <p:sp>
+        <p:nvSpPr>
+          <p:cNvPr id="39" name="TextBox 38"/>
+          <p:cNvSpPr txBox="1"/>
+          <p:nvPr/>
+        </p:nvSpPr>
+        <p:spPr>
+          <a:xfrm>
+            <a:off x="6922851" y="3149348"/>
+            <a:ext cx="486383" cy="194553"/>
+          </a:xfrm>
+          <a:prstGeom prst="rect">
+            <a:avLst/>
+          </a:prstGeom>
+          <a:noFill/>
+        </p:spPr>
+        <p:txBody>
+          <a:bodyPr wrap="square" anchor="t" lIns="0" rIns="0" tIns="0" bIns="0"/>
+          <a:lstStyle/>
+          <a:p>
+            <a:pPr algn="ctr">
+              <a:lnSpc>
+                <a:spcPct val="150000"/>
+              </a:lnSpc>
+            </a:pPr>
+            <a:r>
+              <a:rPr sz="947" b="1">
+                <a:solidFill>
+                  <a:srgbClr val="004347"/>
+                </a:solidFill>
+                <a:latin typeface="Outfit"/>
+                <a:ea typeface="Outfit"/>
+                <a:cs typeface="Outfit"/>
+              </a:rPr>
+              <a:t>62</a:t>
+            </a:r>
+          </a:p>
+        </p:txBody>
+      </p:sp>
+      <p:sp>
+        <p:nvSpPr>
+          <p:cNvPr id="40" name="TextBox 39"/>
+          <p:cNvSpPr txBox="1"/>
+          <p:nvPr/>
+        </p:nvSpPr>
+        <p:spPr>
+          <a:xfrm>
+            <a:off x="6922851" y="4928681"/>
+            <a:ext cx="486383" cy="194553"/>
+          </a:xfrm>
+          <a:prstGeom prst="rect">
+            <a:avLst/>
+          </a:prstGeom>
+          <a:noFill/>
+        </p:spPr>
+        <p:txBody>
+          <a:bodyPr wrap="square" anchor="t" lIns="0" rIns="0" tIns="0" bIns="0"/>
+          <a:lstStyle/>
+          <a:p>
+            <a:pPr algn="ctr">
+              <a:lnSpc>
+                <a:spcPct val="150000"/>
+              </a:lnSpc>
+            </a:pPr>
+            <a:r>
+              <a:rPr sz="947" b="0">
+                <a:solidFill>
+                  <a:srgbClr val="626262"/>
+                </a:solidFill>
+                <a:latin typeface="Zen Kaku Gothic New"/>
+                <a:ea typeface="Zen Kaku Gothic New"/>
+                <a:cs typeface="Zen Kaku Gothic New"/>
+              </a:rPr>
+              <a:t>6月</a:t>
+            </a:r>
+          </a:p>
+        </p:txBody>
+      </p:sp>
+      <p:sp>
+        <p:nvSpPr>
+          <p:cNvPr id="41" name="Rectangle 40"/>
+          <p:cNvSpPr/>
+          <p:nvPr/>
+        </p:nvSpPr>
+        <p:spPr>
+          <a:xfrm>
+            <a:off x="7441660" y="3385923"/>
+            <a:ext cx="324255" cy="1477906"/>
+          </a:xfrm>
+          <a:prstGeom prst="rect">
+            <a:avLst/>
+          </a:prstGeom>
+          <a:solidFill>
+            <a:srgbClr val="004347"/>
+          </a:solidFill>
+          <a:ln>
+            <a:noFill/>
+          </a:ln>
+          <a:effectLst/>
+        </p:spPr>
+        <p:style>
+          <a:lnRef idx="1">
+            <a:schemeClr val="accent1"/>
+          </a:lnRef>
+          <a:fillRef idx="3">
+            <a:schemeClr val="accent1"/>
+          </a:fillRef>
+          <a:effectRef idx="2">
+            <a:schemeClr val="accent1"/>
+          </a:effectRef>
+          <a:fontRef idx="minor">
+            <a:schemeClr val="lt1"/>
+          </a:fontRef>
+        </p:style>
+        <p:txBody>
+          <a:bodyPr rtlCol="0" anchor="ctr"/>
+          <a:lstStyle/>
+          <a:p>
+            <a:pPr algn="ctr"/>
+          </a:p>
+        </p:txBody>
+      </p:sp>
+      <p:sp>
+        <p:nvSpPr>
+          <p:cNvPr id="42" name="TextBox 41"/>
+          <p:cNvSpPr txBox="1"/>
+          <p:nvPr/>
+        </p:nvSpPr>
+        <p:spPr>
+          <a:xfrm>
+            <a:off x="7360596" y="3158945"/>
+            <a:ext cx="486383" cy="194553"/>
+          </a:xfrm>
+          <a:prstGeom prst="rect">
+            <a:avLst/>
+          </a:prstGeom>
+          <a:noFill/>
+        </p:spPr>
+        <p:txBody>
+          <a:bodyPr wrap="square" anchor="t" lIns="0" rIns="0" tIns="0" bIns="0"/>
+          <a:lstStyle/>
+          <a:p>
+            <a:pPr algn="ctr">
+              <a:lnSpc>
+                <a:spcPct val="150000"/>
+              </a:lnSpc>
+            </a:pPr>
+            <a:r>
+              <a:rPr sz="947" b="1">
+                <a:solidFill>
+                  <a:srgbClr val="004347"/>
+                </a:solidFill>
+                <a:latin typeface="Outfit"/>
+                <a:ea typeface="Outfit"/>
+                <a:cs typeface="Outfit"/>
+              </a:rPr>
+              <a:t>62</a:t>
+            </a:r>
+          </a:p>
+        </p:txBody>
+      </p:sp>
+      <p:sp>
+        <p:nvSpPr>
+          <p:cNvPr id="43" name="TextBox 42"/>
+          <p:cNvSpPr txBox="1"/>
+          <p:nvPr/>
+        </p:nvSpPr>
+        <p:spPr>
+          <a:xfrm>
+            <a:off x="7360596" y="4928681"/>
+            <a:ext cx="486383" cy="194553"/>
+          </a:xfrm>
+          <a:prstGeom prst="rect">
+            <a:avLst/>
+          </a:prstGeom>
+          <a:noFill/>
+        </p:spPr>
+        <p:txBody>
+          <a:bodyPr wrap="square" anchor="t" lIns="0" rIns="0" tIns="0" bIns="0"/>
+          <a:lstStyle/>
+          <a:p>
+            <a:pPr algn="ctr">
+              <a:lnSpc>
+                <a:spcPct val="150000"/>
+              </a:lnSpc>
+            </a:pPr>
+            <a:r>
+              <a:rPr sz="947" b="0">
+                <a:solidFill>
+                  <a:srgbClr val="626262"/>
+                </a:solidFill>
+                <a:latin typeface="Zen Kaku Gothic New"/>
+                <a:ea typeface="Zen Kaku Gothic New"/>
+                <a:cs typeface="Zen Kaku Gothic New"/>
+              </a:rPr>
+              <a:t>7月</a:t>
+            </a:r>
+          </a:p>
+        </p:txBody>
+      </p:sp>
+      <p:sp>
+        <p:nvSpPr>
+          <p:cNvPr id="44" name="Rectangle 43"/>
+          <p:cNvSpPr/>
+          <p:nvPr/>
+        </p:nvSpPr>
+        <p:spPr>
+          <a:xfrm>
+            <a:off x="7879404" y="3455500"/>
+            <a:ext cx="324255" cy="1408330"/>
+          </a:xfrm>
+          <a:prstGeom prst="rect">
+            <a:avLst/>
+          </a:prstGeom>
+          <a:solidFill>
+            <a:srgbClr val="004347"/>
+          </a:solidFill>
+          <a:ln>
+            <a:noFill/>
+          </a:ln>
+          <a:effectLst/>
+        </p:spPr>
+        <p:style>
+          <a:lnRef idx="1">
+            <a:schemeClr val="accent1"/>
+          </a:lnRef>
+          <a:fillRef idx="3">
+            <a:schemeClr val="accent1"/>
+          </a:fillRef>
+          <a:effectRef idx="2">
+            <a:schemeClr val="accent1"/>
+          </a:effectRef>
+          <a:fontRef idx="minor">
+            <a:schemeClr val="lt1"/>
+          </a:fontRef>
+        </p:style>
+        <p:txBody>
+          <a:bodyPr rtlCol="0" anchor="ctr"/>
+          <a:lstStyle/>
+          <a:p>
+            <a:pPr algn="ctr"/>
+          </a:p>
+        </p:txBody>
+      </p:sp>
+      <p:sp>
+        <p:nvSpPr>
+          <p:cNvPr id="45" name="TextBox 44"/>
+          <p:cNvSpPr txBox="1"/>
+          <p:nvPr/>
+        </p:nvSpPr>
+        <p:spPr>
+          <a:xfrm>
+            <a:off x="7798340" y="3228522"/>
+            <a:ext cx="486383" cy="194553"/>
+          </a:xfrm>
+          <a:prstGeom prst="rect">
+            <a:avLst/>
+          </a:prstGeom>
+          <a:noFill/>
+        </p:spPr>
+        <p:txBody>
+          <a:bodyPr wrap="square" anchor="t" lIns="0" rIns="0" tIns="0" bIns="0"/>
+          <a:lstStyle/>
+          <a:p>
+            <a:pPr algn="ctr">
+              <a:lnSpc>
+                <a:spcPct val="150000"/>
+              </a:lnSpc>
+            </a:pPr>
+            <a:r>
+              <a:rPr sz="947" b="1">
+                <a:solidFill>
+                  <a:srgbClr val="004347"/>
+                </a:solidFill>
+                <a:latin typeface="Outfit"/>
+                <a:ea typeface="Outfit"/>
+                <a:cs typeface="Outfit"/>
+              </a:rPr>
+              <a:t>59</a:t>
+            </a:r>
+          </a:p>
+        </p:txBody>
+      </p:sp>
+      <p:sp>
+        <p:nvSpPr>
+          <p:cNvPr id="46" name="TextBox 45"/>
+          <p:cNvSpPr txBox="1"/>
+          <p:nvPr/>
+        </p:nvSpPr>
+        <p:spPr>
+          <a:xfrm>
+            <a:off x="7798340" y="4928681"/>
+            <a:ext cx="486383" cy="194553"/>
+          </a:xfrm>
+          <a:prstGeom prst="rect">
+            <a:avLst/>
+          </a:prstGeom>
+          <a:noFill/>
+        </p:spPr>
+        <p:txBody>
+          <a:bodyPr wrap="square" anchor="t" lIns="0" rIns="0" tIns="0" bIns="0"/>
+          <a:lstStyle/>
+          <a:p>
+            <a:pPr algn="ctr">
+              <a:lnSpc>
+                <a:spcPct val="150000"/>
+              </a:lnSpc>
+            </a:pPr>
+            <a:r>
+              <a:rPr sz="947" b="0">
+                <a:solidFill>
+                  <a:srgbClr val="626262"/>
+                </a:solidFill>
+                <a:latin typeface="Zen Kaku Gothic New"/>
+                <a:ea typeface="Zen Kaku Gothic New"/>
+                <a:cs typeface="Zen Kaku Gothic New"/>
+              </a:rPr>
+              <a:t>8月</a:t>
+            </a:r>
+          </a:p>
+        </p:txBody>
+      </p:sp>
+      <p:sp>
+        <p:nvSpPr>
+          <p:cNvPr id="47" name="Rectangle 46"/>
+          <p:cNvSpPr/>
+          <p:nvPr/>
+        </p:nvSpPr>
+        <p:spPr>
+          <a:xfrm>
+            <a:off x="8317149" y="3287556"/>
+            <a:ext cx="324255" cy="1576273"/>
+          </a:xfrm>
+          <a:prstGeom prst="rect">
+            <a:avLst/>
+          </a:prstGeom>
+          <a:solidFill>
+            <a:srgbClr val="004347"/>
+          </a:solidFill>
+          <a:ln>
+            <a:noFill/>
+          </a:ln>
+          <a:effectLst/>
+        </p:spPr>
+        <p:style>
+          <a:lnRef idx="1">
+            <a:schemeClr val="accent1"/>
+          </a:lnRef>
+          <a:fillRef idx="3">
+            <a:schemeClr val="accent1"/>
+          </a:fillRef>
+          <a:effectRef idx="2">
+            <a:schemeClr val="accent1"/>
+          </a:effectRef>
+          <a:fontRef idx="minor">
+            <a:schemeClr val="lt1"/>
+          </a:fontRef>
+        </p:style>
+        <p:txBody>
+          <a:bodyPr rtlCol="0" anchor="ctr"/>
+          <a:lstStyle/>
+          <a:p>
+            <a:pPr algn="ctr"/>
+          </a:p>
+        </p:txBody>
+      </p:sp>
+      <p:sp>
+        <p:nvSpPr>
+          <p:cNvPr id="48" name="TextBox 47"/>
+          <p:cNvSpPr txBox="1"/>
+          <p:nvPr/>
+        </p:nvSpPr>
+        <p:spPr>
+          <a:xfrm>
+            <a:off x="8236085" y="3060578"/>
+            <a:ext cx="486383" cy="194553"/>
+          </a:xfrm>
+          <a:prstGeom prst="rect">
+            <a:avLst/>
+          </a:prstGeom>
+          <a:noFill/>
+        </p:spPr>
+        <p:txBody>
+          <a:bodyPr wrap="square" anchor="t" lIns="0" rIns="0" tIns="0" bIns="0"/>
+          <a:lstStyle/>
+          <a:p>
+            <a:pPr algn="ctr">
+              <a:lnSpc>
+                <a:spcPct val="150000"/>
+              </a:lnSpc>
+            </a:pPr>
+            <a:r>
+              <a:rPr sz="947" b="1">
+                <a:solidFill>
+                  <a:srgbClr val="004347"/>
+                </a:solidFill>
+                <a:latin typeface="Outfit"/>
+                <a:ea typeface="Outfit"/>
+                <a:cs typeface="Outfit"/>
+              </a:rPr>
+              <a:t>66</a:t>
+            </a:r>
+          </a:p>
+        </p:txBody>
+      </p:sp>
+      <p:sp>
+        <p:nvSpPr>
+          <p:cNvPr id="49" name="TextBox 48"/>
+          <p:cNvSpPr txBox="1"/>
+          <p:nvPr/>
+        </p:nvSpPr>
+        <p:spPr>
+          <a:xfrm>
+            <a:off x="8236085" y="4928681"/>
+            <a:ext cx="486383" cy="194553"/>
+          </a:xfrm>
+          <a:prstGeom prst="rect">
+            <a:avLst/>
+          </a:prstGeom>
+          <a:noFill/>
+        </p:spPr>
+        <p:txBody>
+          <a:bodyPr wrap="square" anchor="t" lIns="0" rIns="0" tIns="0" bIns="0"/>
+          <a:lstStyle/>
+          <a:p>
+            <a:pPr algn="ctr">
+              <a:lnSpc>
+                <a:spcPct val="150000"/>
+              </a:lnSpc>
+            </a:pPr>
+            <a:r>
+              <a:rPr sz="947" b="0">
+                <a:solidFill>
+                  <a:srgbClr val="626262"/>
+                </a:solidFill>
+                <a:latin typeface="Zen Kaku Gothic New"/>
+                <a:ea typeface="Zen Kaku Gothic New"/>
+                <a:cs typeface="Zen Kaku Gothic New"/>
+              </a:rPr>
+              <a:t>9月</a:t>
             </a:r>
           </a:p>
         </p:txBody>
       </p:sp>
       <p:cxnSp>
         <p:nvCxnSpPr>
-          <p:cNvPr id="37" name="Connector 36"/>
+          <p:cNvPr id="50" name="Connector 49"/>
           <p:cNvCxnSpPr/>
           <p:nvPr/>
         </p:nvCxnSpPr>
         <p:spPr>
           <a:xfrm>
-            <a:off x="6485106" y="5025957"/>
-            <a:ext cx="2399490" cy="0"/>
+            <a:off x="3437106" y="4863830"/>
+            <a:ext cx="5252937" cy="0"/>
           </a:xfrm>
           <a:prstGeom prst="line">
             <a:avLst/>
@@ -11537,14 +11917,14 @@
       </p:cxnSp>
       <p:sp>
         <p:nvSpPr>
-          <p:cNvPr id="38" name="TextBox 37"/>
-          <p:cNvSpPr txBox="1"/>
-          <p:nvPr/>
-        </p:nvSpPr>
-        <p:spPr>
-          <a:xfrm>
-            <a:off x="6290553" y="2691319"/>
-            <a:ext cx="2788596" cy="194553"/>
+          <p:cNvPr id="51" name="TextBox 50"/>
+          <p:cNvSpPr txBox="1"/>
+          <p:nvPr/>
+        </p:nvSpPr>
+        <p:spPr>
+          <a:xfrm>
+            <a:off x="453957" y="5512340"/>
+            <a:ext cx="8236085" cy="356681"/>
           </a:xfrm>
           <a:prstGeom prst="rect">
             <a:avLst/>
@@ -11561,45 +11941,6 @@
               </a:lnSpc>
             </a:pPr>
             <a:r>
-              <a:rPr sz="1010" b="0">
-                <a:solidFill>
-                  <a:srgbClr val="626262"/>
-                </a:solidFill>
-                <a:latin typeface="Zen Kaku Gothic New"/>
-                <a:ea typeface="Zen Kaku Gothic New"/>
-                <a:cs typeface="Zen Kaku Gothic New"/>
-              </a:rPr>
-              <a:t>単位：万円</a:t>
-            </a:r>
-          </a:p>
-        </p:txBody>
-      </p:sp>
-      <p:sp>
-        <p:nvSpPr>
-          <p:cNvPr id="39" name="TextBox 38"/>
-          <p:cNvSpPr txBox="1"/>
-          <p:nvPr/>
-        </p:nvSpPr>
-        <p:spPr>
-          <a:xfrm>
-            <a:off x="453957" y="5593404"/>
-            <a:ext cx="8106383" cy="356681"/>
-          </a:xfrm>
-          <a:prstGeom prst="rect">
-            <a:avLst/>
-          </a:prstGeom>
-          <a:noFill/>
-        </p:spPr>
-        <p:txBody>
-          <a:bodyPr wrap="square" anchor="t" lIns="0" rIns="0" tIns="0" bIns="0"/>
-          <a:lstStyle/>
-          <a:p>
-            <a:pPr algn="l">
-              <a:lnSpc>
-                <a:spcPct val="150000"/>
-              </a:lnSpc>
-            </a:pPr>
-            <a:r>
               <a:rPr sz="1768" b="1">
                 <a:solidFill>
                   <a:srgbClr val="004347"/>
@@ -11608,7 +11949,7 @@
                 <a:ea typeface="Zen Kaku Gothic New"/>
                 <a:cs typeface="Zen Kaku Gothic New"/>
               </a:rPr>
-              <a:t>広告を絞っても売上は落とさず、</a:t>
+              <a:t>5月に</a:t>
             </a:r>
             <a:r>
               <a:rPr sz="1768" b="1">
@@ -11619,7 +11960,7 @@
                 <a:ea typeface="Zen Kaku Gothic New"/>
                 <a:cs typeface="Zen Kaku Gothic New"/>
               </a:rPr>
-              <a:t>利益が大きく残る形</a:t>
+              <a:t>月商1億円</a:t>
             </a:r>
             <a:r>
               <a:rPr sz="1768" b="1">
@@ -11630,14 +11971,14 @@
                 <a:ea typeface="Zen Kaku Gothic New"/>
                 <a:cs typeface="Zen Kaku Gothic New"/>
               </a:rPr>
-              <a:t>に変わった</a:t>
-            </a:r>
-          </a:p>
-        </p:txBody>
-      </p:sp>
-      <p:sp>
-        <p:nvSpPr>
-          <p:cNvPr id="40" name="TextBox 39"/>
+              <a:t>を超えた。黒字化は、第9期にやり切る。</a:t>
+            </a:r>
+          </a:p>
+        </p:txBody>
+      </p:sp>
+      <p:sp>
+        <p:nvSpPr>
+          <p:cNvPr id="52" name="TextBox 51"/>
           <p:cNvSpPr txBox="1"/>
           <p:nvPr/>
         </p:nvSpPr>
@@ -11669,7 +12010,7 @@
                 <a:ea typeface="Zen Kaku Gothic New"/>
                 <a:cs typeface="Zen Kaku Gothic New"/>
               </a:rPr>
-              <a:t>※ AP/AFは自社EC＋モール、税抜（小松資料）。ハナイチは税抜・植木鉢＋生花ほか（比須田資料）。全社合計・イネイブラー／3PLは次ページ</a:t>
+              <a:t>※ 試算表（2026/10/8時点）の暫定値・決算整理前。9月は棚卸未反映。売上高は決算整理▲404万円を含む</a:t>
             </a:r>
           </a:p>
         </p:txBody>
@@ -11770,7 +12111,7 @@
                 <a:ea typeface="Zen Kaku Gothic New"/>
                 <a:cs typeface="Zen Kaku Gothic New"/>
               </a:rPr>
-              <a:t>全社の数字</a:t>
+              <a:t>事業別の数字</a:t>
             </a:r>
           </a:p>
         </p:txBody>
@@ -11809,7 +12150,7 @@
                 <a:ea typeface="Zen Kaku Gothic New"/>
                 <a:cs typeface="Zen Kaku Gothic New"/>
               </a:rPr>
-              <a:t>第8期 実績　※税抜</a:t>
+              <a:t>第7期 → 第8期（前年比）　※税抜</a:t>
             </a:r>
           </a:p>
         </p:txBody>
@@ -11861,8 +12202,8 @@
         </p:nvSpPr>
         <p:spPr>
           <a:xfrm>
-            <a:off x="453957" y="1588851"/>
-            <a:ext cx="2594043" cy="291830"/>
+            <a:off x="453957" y="1394298"/>
+            <a:ext cx="2788596" cy="226979"/>
           </a:xfrm>
           <a:prstGeom prst="rect">
             <a:avLst/>
@@ -11879,39 +12220,116 @@
               </a:lnSpc>
             </a:pPr>
             <a:r>
-              <a:rPr sz="1578" b="1">
-                <a:solidFill>
-                  <a:srgbClr val="004347"/>
-                </a:solidFill>
-                <a:latin typeface="Zen Kaku Gothic New"/>
-                <a:ea typeface="Zen Kaku Gothic New"/>
-                <a:cs typeface="Zen Kaku Gothic New"/>
-              </a:rPr>
-              <a:t>全社 売上</a:t>
-            </a:r>
-          </a:p>
-        </p:txBody>
-      </p:sp>
-      <p:sp>
-        <p:nvSpPr>
-          <p:cNvPr id="7" name="Rectangle 6"/>
+              <a:rPr sz="1136" b="0">
+                <a:solidFill>
+                  <a:srgbClr val="626262"/>
+                </a:solidFill>
+                <a:latin typeface="Zen Kaku Gothic New"/>
+                <a:ea typeface="Zen Kaku Gothic New"/>
+                <a:cs typeface="Zen Kaku Gothic New"/>
+              </a:rPr>
+              <a:t>AND PLANTS / AND FLOWER</a:t>
+            </a:r>
+          </a:p>
+        </p:txBody>
+      </p:sp>
+      <p:sp>
+        <p:nvSpPr>
+          <p:cNvPr id="7" name="TextBox 6"/>
+          <p:cNvSpPr txBox="1"/>
+          <p:nvPr/>
+        </p:nvSpPr>
+        <p:spPr>
+          <a:xfrm>
+            <a:off x="453957" y="1653702"/>
+            <a:ext cx="2788596" cy="324255"/>
+          </a:xfrm>
+          <a:prstGeom prst="rect">
+            <a:avLst/>
+          </a:prstGeom>
+          <a:noFill/>
+        </p:spPr>
+        <p:txBody>
+          <a:bodyPr wrap="square" anchor="t" lIns="0" rIns="0" tIns="0" bIns="0"/>
+          <a:lstStyle/>
+          <a:p>
+            <a:pPr algn="l">
+              <a:lnSpc>
+                <a:spcPct val="150000"/>
+              </a:lnSpc>
+            </a:pPr>
+            <a:r>
+              <a:rPr sz="1768" b="1">
+                <a:solidFill>
+                  <a:srgbClr val="004347"/>
+                </a:solidFill>
+                <a:latin typeface="Zen Kaku Gothic New"/>
+                <a:ea typeface="Zen Kaku Gothic New"/>
+                <a:cs typeface="Zen Kaku Gothic New"/>
+              </a:rPr>
+              <a:t>売上</a:t>
+            </a:r>
+          </a:p>
+        </p:txBody>
+      </p:sp>
+      <p:sp>
+        <p:nvSpPr>
+          <p:cNvPr id="8" name="TextBox 7"/>
+          <p:cNvSpPr txBox="1"/>
+          <p:nvPr/>
+        </p:nvSpPr>
+        <p:spPr>
+          <a:xfrm>
+            <a:off x="453957" y="2026596"/>
+            <a:ext cx="2788596" cy="583660"/>
+          </a:xfrm>
+          <a:prstGeom prst="rect">
+            <a:avLst/>
+          </a:prstGeom>
+          <a:noFill/>
+        </p:spPr>
+        <p:txBody>
+          <a:bodyPr wrap="square" anchor="t" lIns="0" rIns="0" tIns="0" bIns="0"/>
+          <a:lstStyle/>
+          <a:p>
+            <a:pPr algn="l">
+              <a:lnSpc>
+                <a:spcPct val="100000"/>
+              </a:lnSpc>
+            </a:pPr>
+            <a:r>
+              <a:rPr sz="3536" b="1">
+                <a:solidFill>
+                  <a:srgbClr val="00D79C"/>
+                </a:solidFill>
+                <a:latin typeface="Outfit"/>
+                <a:ea typeface="Outfit"/>
+                <a:cs typeface="Outfit"/>
+              </a:rPr>
+              <a:t>+2%</a:t>
+            </a:r>
+          </a:p>
+        </p:txBody>
+      </p:sp>
+      <p:sp>
+        <p:nvSpPr>
+          <p:cNvPr id="9" name="Rectangle 8"/>
           <p:cNvSpPr/>
           <p:nvPr/>
         </p:nvSpPr>
         <p:spPr>
           <a:xfrm>
-            <a:off x="453957" y="2010383"/>
-            <a:ext cx="2594043" cy="1621277"/>
-          </a:xfrm>
-          <a:prstGeom prst="rect">
-            <a:avLst/>
-          </a:prstGeom>
-          <a:noFill/>
-          <a:ln w="19050">
-            <a:solidFill>
-              <a:srgbClr val="004347"/>
-            </a:solidFill>
-            <a:prstDash val="dash"/>
+            <a:off x="843064" y="3290753"/>
+            <a:ext cx="778213" cy="1735204"/>
+          </a:xfrm>
+          <a:prstGeom prst="rect">
+            <a:avLst/>
+          </a:prstGeom>
+          <a:solidFill>
+            <a:srgbClr val="CBD0D3"/>
+          </a:solidFill>
+          <a:ln>
+            <a:noFill/>
           </a:ln>
           <a:effectLst/>
         </p:spPr>
@@ -11939,22 +12357,22 @@
       </p:sp>
       <p:sp>
         <p:nvSpPr>
-          <p:cNvPr id="8" name="TextBox 7"/>
-          <p:cNvSpPr txBox="1"/>
-          <p:nvPr/>
-        </p:nvSpPr>
-        <p:spPr>
-          <a:xfrm>
-            <a:off x="453957" y="2010383"/>
-            <a:ext cx="2594043" cy="1621277"/>
-          </a:xfrm>
-          <a:prstGeom prst="rect">
-            <a:avLst/>
-          </a:prstGeom>
-          <a:noFill/>
-        </p:spPr>
-        <p:txBody>
-          <a:bodyPr wrap="square" anchor="ctr" lIns="0" rIns="0" tIns="0" bIns="0"/>
+          <p:cNvPr id="10" name="TextBox 9"/>
+          <p:cNvSpPr txBox="1"/>
+          <p:nvPr/>
+        </p:nvSpPr>
+        <p:spPr>
+          <a:xfrm>
+            <a:off x="680936" y="2998924"/>
+            <a:ext cx="1102468" cy="243191"/>
+          </a:xfrm>
+          <a:prstGeom prst="rect">
+            <a:avLst/>
+          </a:prstGeom>
+          <a:noFill/>
+        </p:spPr>
+        <p:txBody>
+          <a:bodyPr wrap="square" anchor="t" lIns="0" rIns="0" tIns="0" bIns="0"/>
           <a:lstStyle/>
           <a:p>
             <a:pPr algn="ctr">
@@ -11963,78 +12381,77 @@
               </a:lnSpc>
             </a:pPr>
             <a:r>
-              <a:rPr sz="2778" b="1">
-                <a:solidFill>
-                  <a:srgbClr val="004347"/>
-                </a:solidFill>
-                <a:latin typeface="Zen Kaku Gothic New"/>
-                <a:ea typeface="Zen Kaku Gothic New"/>
-                <a:cs typeface="Zen Kaku Gothic New"/>
-              </a:rPr>
-              <a:t>算出中</a:t>
-            </a:r>
-          </a:p>
-        </p:txBody>
-      </p:sp>
-      <p:sp>
-        <p:nvSpPr>
-          <p:cNvPr id="9" name="TextBox 8"/>
-          <p:cNvSpPr txBox="1"/>
-          <p:nvPr/>
-        </p:nvSpPr>
-        <p:spPr>
-          <a:xfrm>
-            <a:off x="3242553" y="1588851"/>
-            <a:ext cx="2594043" cy="291830"/>
-          </a:xfrm>
-          <a:prstGeom prst="rect">
-            <a:avLst/>
-          </a:prstGeom>
-          <a:noFill/>
-        </p:spPr>
-        <p:txBody>
-          <a:bodyPr wrap="square" anchor="t" lIns="0" rIns="0" tIns="0" bIns="0"/>
-          <a:lstStyle/>
-          <a:p>
-            <a:pPr algn="l">
-              <a:lnSpc>
-                <a:spcPct val="150000"/>
-              </a:lnSpc>
-            </a:pPr>
-            <a:r>
-              <a:rPr sz="1578" b="1">
-                <a:solidFill>
-                  <a:srgbClr val="004347"/>
-                </a:solidFill>
-                <a:latin typeface="Zen Kaku Gothic New"/>
-                <a:ea typeface="Zen Kaku Gothic New"/>
-                <a:cs typeface="Zen Kaku Gothic New"/>
-              </a:rPr>
-              <a:t>全社 営業利益</a:t>
-            </a:r>
-          </a:p>
-        </p:txBody>
-      </p:sp>
-      <p:sp>
-        <p:nvSpPr>
-          <p:cNvPr id="10" name="Rectangle 9"/>
+              <a:rPr sz="1389" b="1">
+                <a:solidFill>
+                  <a:srgbClr val="004347"/>
+                </a:solidFill>
+                <a:latin typeface="Outfit"/>
+                <a:ea typeface="Outfit"/>
+                <a:cs typeface="Outfit"/>
+              </a:rPr>
+              <a:t>7.2</a:t>
+            </a:r>
+          </a:p>
+        </p:txBody>
+      </p:sp>
+      <p:sp>
+        <p:nvSpPr>
+          <p:cNvPr id="11" name="TextBox 10"/>
+          <p:cNvSpPr txBox="1"/>
+          <p:nvPr/>
+        </p:nvSpPr>
+        <p:spPr>
+          <a:xfrm>
+            <a:off x="680936" y="5107021"/>
+            <a:ext cx="1102468" cy="226979"/>
+          </a:xfrm>
+          <a:prstGeom prst="rect">
+            <a:avLst/>
+          </a:prstGeom>
+          <a:noFill/>
+        </p:spPr>
+        <p:txBody>
+          <a:bodyPr wrap="square" anchor="t" lIns="0" rIns="0" tIns="0" bIns="0"/>
+          <a:lstStyle/>
+          <a:p>
+            <a:pPr algn="ctr">
+              <a:lnSpc>
+                <a:spcPct val="150000"/>
+              </a:lnSpc>
+            </a:pPr>
+            <a:r>
+              <a:rPr sz="1136" b="0">
+                <a:solidFill>
+                  <a:srgbClr val="626262"/>
+                </a:solidFill>
+                <a:latin typeface="Zen Kaku Gothic New"/>
+                <a:ea typeface="Zen Kaku Gothic New"/>
+                <a:cs typeface="Zen Kaku Gothic New"/>
+              </a:rPr>
+              <a:t>第7期</a:t>
+            </a:r>
+          </a:p>
+        </p:txBody>
+      </p:sp>
+      <p:sp>
+        <p:nvSpPr>
+          <p:cNvPr id="12" name="Rectangle 11"/>
           <p:cNvSpPr/>
           <p:nvPr/>
         </p:nvSpPr>
         <p:spPr>
           <a:xfrm>
-            <a:off x="3242553" y="2010383"/>
-            <a:ext cx="2594043" cy="1621277"/>
-          </a:xfrm>
-          <a:prstGeom prst="rect">
-            <a:avLst/>
-          </a:prstGeom>
-          <a:noFill/>
-          <a:ln w="19050">
-            <a:solidFill>
-              <a:srgbClr val="004347"/>
-            </a:solidFill>
-            <a:prstDash val="dash"/>
+            <a:off x="1945532" y="3242553"/>
+            <a:ext cx="778213" cy="1783404"/>
+          </a:xfrm>
+          <a:prstGeom prst="rect">
+            <a:avLst/>
+          </a:prstGeom>
+          <a:solidFill>
+            <a:srgbClr val="004347"/>
+          </a:solidFill>
+          <a:ln>
+            <a:noFill/>
           </a:ln>
           <a:effectLst/>
         </p:spPr>
@@ -12062,22 +12479,22 @@
       </p:sp>
       <p:sp>
         <p:nvSpPr>
-          <p:cNvPr id="11" name="TextBox 10"/>
-          <p:cNvSpPr txBox="1"/>
-          <p:nvPr/>
-        </p:nvSpPr>
-        <p:spPr>
-          <a:xfrm>
-            <a:off x="3242553" y="2010383"/>
-            <a:ext cx="2594043" cy="1621277"/>
-          </a:xfrm>
-          <a:prstGeom prst="rect">
-            <a:avLst/>
-          </a:prstGeom>
-          <a:noFill/>
-        </p:spPr>
-        <p:txBody>
-          <a:bodyPr wrap="square" anchor="ctr" lIns="0" rIns="0" tIns="0" bIns="0"/>
+          <p:cNvPr id="13" name="TextBox 12"/>
+          <p:cNvSpPr txBox="1"/>
+          <p:nvPr/>
+        </p:nvSpPr>
+        <p:spPr>
+          <a:xfrm>
+            <a:off x="1783404" y="2950723"/>
+            <a:ext cx="1102468" cy="243191"/>
+          </a:xfrm>
+          <a:prstGeom prst="rect">
+            <a:avLst/>
+          </a:prstGeom>
+          <a:noFill/>
+        </p:spPr>
+        <p:txBody>
+          <a:bodyPr wrap="square" anchor="t" lIns="0" rIns="0" tIns="0" bIns="0"/>
           <a:lstStyle/>
           <a:p>
             <a:pPr algn="ctr">
@@ -12086,29 +12503,103 @@
               </a:lnSpc>
             </a:pPr>
             <a:r>
-              <a:rPr sz="2778" b="1">
-                <a:solidFill>
-                  <a:srgbClr val="004347"/>
-                </a:solidFill>
-                <a:latin typeface="Zen Kaku Gothic New"/>
-                <a:ea typeface="Zen Kaku Gothic New"/>
-                <a:cs typeface="Zen Kaku Gothic New"/>
-              </a:rPr>
-              <a:t>算出中</a:t>
-            </a:r>
-          </a:p>
-        </p:txBody>
-      </p:sp>
-      <p:sp>
-        <p:nvSpPr>
-          <p:cNvPr id="12" name="TextBox 11"/>
-          <p:cNvSpPr txBox="1"/>
-          <p:nvPr/>
-        </p:nvSpPr>
-        <p:spPr>
-          <a:xfrm>
-            <a:off x="6031149" y="1588851"/>
-            <a:ext cx="2594043" cy="291830"/>
+              <a:rPr sz="1389" b="1">
+                <a:solidFill>
+                  <a:srgbClr val="004347"/>
+                </a:solidFill>
+                <a:latin typeface="Outfit"/>
+                <a:ea typeface="Outfit"/>
+                <a:cs typeface="Outfit"/>
+              </a:rPr>
+              <a:t>7.4</a:t>
+            </a:r>
+          </a:p>
+        </p:txBody>
+      </p:sp>
+      <p:sp>
+        <p:nvSpPr>
+          <p:cNvPr id="14" name="TextBox 13"/>
+          <p:cNvSpPr txBox="1"/>
+          <p:nvPr/>
+        </p:nvSpPr>
+        <p:spPr>
+          <a:xfrm>
+            <a:off x="1783404" y="5107021"/>
+            <a:ext cx="1102468" cy="226979"/>
+          </a:xfrm>
+          <a:prstGeom prst="rect">
+            <a:avLst/>
+          </a:prstGeom>
+          <a:noFill/>
+        </p:spPr>
+        <p:txBody>
+          <a:bodyPr wrap="square" anchor="t" lIns="0" rIns="0" tIns="0" bIns="0"/>
+          <a:lstStyle/>
+          <a:p>
+            <a:pPr algn="ctr">
+              <a:lnSpc>
+                <a:spcPct val="150000"/>
+              </a:lnSpc>
+            </a:pPr>
+            <a:r>
+              <a:rPr sz="1136" b="0">
+                <a:solidFill>
+                  <a:srgbClr val="626262"/>
+                </a:solidFill>
+                <a:latin typeface="Zen Kaku Gothic New"/>
+                <a:ea typeface="Zen Kaku Gothic New"/>
+                <a:cs typeface="Zen Kaku Gothic New"/>
+              </a:rPr>
+              <a:t>第8期</a:t>
+            </a:r>
+          </a:p>
+        </p:txBody>
+      </p:sp>
+      <p:cxnSp>
+        <p:nvCxnSpPr>
+          <p:cNvPr id="15" name="Connector 14"/>
+          <p:cNvCxnSpPr/>
+          <p:nvPr/>
+        </p:nvCxnSpPr>
+        <p:spPr>
+          <a:xfrm>
+            <a:off x="648511" y="5025957"/>
+            <a:ext cx="2399489" cy="0"/>
+          </a:xfrm>
+          <a:prstGeom prst="line">
+            <a:avLst/>
+          </a:prstGeom>
+          <a:ln w="12700">
+            <a:solidFill>
+              <a:srgbClr val="C9CFCF"/>
+            </a:solidFill>
+          </a:ln>
+        </p:spPr>
+        <p:style>
+          <a:lnRef idx="2">
+            <a:schemeClr val="accent1"/>
+          </a:lnRef>
+          <a:fillRef idx="0">
+            <a:schemeClr val="accent1"/>
+          </a:fillRef>
+          <a:effectRef idx="1">
+            <a:schemeClr val="accent1"/>
+          </a:effectRef>
+          <a:fontRef idx="minor">
+            <a:schemeClr val="tx1"/>
+          </a:fontRef>
+        </p:style>
+      </p:cxnSp>
+      <p:sp>
+        <p:nvSpPr>
+          <p:cNvPr id="16" name="TextBox 15"/>
+          <p:cNvSpPr txBox="1"/>
+          <p:nvPr/>
+        </p:nvSpPr>
+        <p:spPr>
+          <a:xfrm>
+            <a:off x="453957" y="2691319"/>
+            <a:ext cx="2788596" cy="194553"/>
           </a:xfrm>
           <a:prstGeom prst="rect">
             <a:avLst/>
@@ -12125,39 +12616,155 @@
               </a:lnSpc>
             </a:pPr>
             <a:r>
-              <a:rPr sz="1578" b="1">
-                <a:solidFill>
-                  <a:srgbClr val="004347"/>
-                </a:solidFill>
-                <a:latin typeface="Zen Kaku Gothic New"/>
-                <a:ea typeface="Zen Kaku Gothic New"/>
-                <a:cs typeface="Zen Kaku Gothic New"/>
-              </a:rPr>
-              <a:t>イネイブラー／3PL 売上</a:t>
-            </a:r>
-          </a:p>
-        </p:txBody>
-      </p:sp>
-      <p:sp>
-        <p:nvSpPr>
-          <p:cNvPr id="13" name="Rectangle 12"/>
+              <a:rPr sz="1010" b="0">
+                <a:solidFill>
+                  <a:srgbClr val="626262"/>
+                </a:solidFill>
+                <a:latin typeface="Zen Kaku Gothic New"/>
+                <a:ea typeface="Zen Kaku Gothic New"/>
+                <a:cs typeface="Zen Kaku Gothic New"/>
+              </a:rPr>
+              <a:t>単位：億円</a:t>
+            </a:r>
+          </a:p>
+        </p:txBody>
+      </p:sp>
+      <p:sp>
+        <p:nvSpPr>
+          <p:cNvPr id="17" name="TextBox 16"/>
+          <p:cNvSpPr txBox="1"/>
+          <p:nvPr/>
+        </p:nvSpPr>
+        <p:spPr>
+          <a:xfrm>
+            <a:off x="3372255" y="1394298"/>
+            <a:ext cx="2788596" cy="226979"/>
+          </a:xfrm>
+          <a:prstGeom prst="rect">
+            <a:avLst/>
+          </a:prstGeom>
+          <a:noFill/>
+        </p:spPr>
+        <p:txBody>
+          <a:bodyPr wrap="square" anchor="t" lIns="0" rIns="0" tIns="0" bIns="0"/>
+          <a:lstStyle/>
+          <a:p>
+            <a:pPr algn="l">
+              <a:lnSpc>
+                <a:spcPct val="150000"/>
+              </a:lnSpc>
+            </a:pPr>
+            <a:r>
+              <a:rPr sz="1136" b="0">
+                <a:solidFill>
+                  <a:srgbClr val="626262"/>
+                </a:solidFill>
+                <a:latin typeface="Zen Kaku Gothic New"/>
+                <a:ea typeface="Zen Kaku Gothic New"/>
+                <a:cs typeface="Zen Kaku Gothic New"/>
+              </a:rPr>
+              <a:t>AND PLANTS / AND FLOWER</a:t>
+            </a:r>
+          </a:p>
+        </p:txBody>
+      </p:sp>
+      <p:sp>
+        <p:nvSpPr>
+          <p:cNvPr id="18" name="TextBox 17"/>
+          <p:cNvSpPr txBox="1"/>
+          <p:nvPr/>
+        </p:nvSpPr>
+        <p:spPr>
+          <a:xfrm>
+            <a:off x="3372255" y="1653702"/>
+            <a:ext cx="2788596" cy="324255"/>
+          </a:xfrm>
+          <a:prstGeom prst="rect">
+            <a:avLst/>
+          </a:prstGeom>
+          <a:noFill/>
+        </p:spPr>
+        <p:txBody>
+          <a:bodyPr wrap="square" anchor="t" lIns="0" rIns="0" tIns="0" bIns="0"/>
+          <a:lstStyle/>
+          <a:p>
+            <a:pPr algn="l">
+              <a:lnSpc>
+                <a:spcPct val="150000"/>
+              </a:lnSpc>
+            </a:pPr>
+            <a:r>
+              <a:rPr sz="1768" b="1">
+                <a:solidFill>
+                  <a:srgbClr val="004347"/>
+                </a:solidFill>
+                <a:latin typeface="Zen Kaku Gothic New"/>
+                <a:ea typeface="Zen Kaku Gothic New"/>
+                <a:cs typeface="Zen Kaku Gothic New"/>
+              </a:rPr>
+              <a:t>広告費込み限界利益</a:t>
+            </a:r>
+          </a:p>
+        </p:txBody>
+      </p:sp>
+      <p:sp>
+        <p:nvSpPr>
+          <p:cNvPr id="19" name="TextBox 18"/>
+          <p:cNvSpPr txBox="1"/>
+          <p:nvPr/>
+        </p:nvSpPr>
+        <p:spPr>
+          <a:xfrm>
+            <a:off x="3372255" y="2026596"/>
+            <a:ext cx="2788596" cy="583660"/>
+          </a:xfrm>
+          <a:prstGeom prst="rect">
+            <a:avLst/>
+          </a:prstGeom>
+          <a:noFill/>
+        </p:spPr>
+        <p:txBody>
+          <a:bodyPr wrap="square" anchor="t" lIns="0" rIns="0" tIns="0" bIns="0"/>
+          <a:lstStyle/>
+          <a:p>
+            <a:pPr algn="l">
+              <a:lnSpc>
+                <a:spcPct val="100000"/>
+              </a:lnSpc>
+            </a:pPr>
+            <a:r>
+              <a:rPr sz="3536" b="1">
+                <a:solidFill>
+                  <a:srgbClr val="00D79C"/>
+                </a:solidFill>
+                <a:latin typeface="Outfit"/>
+                <a:ea typeface="Outfit"/>
+                <a:cs typeface="Outfit"/>
+              </a:rPr>
+              <a:t>+47%</a:t>
+            </a:r>
+          </a:p>
+        </p:txBody>
+      </p:sp>
+      <p:sp>
+        <p:nvSpPr>
+          <p:cNvPr id="20" name="Rectangle 19"/>
           <p:cNvSpPr/>
           <p:nvPr/>
         </p:nvSpPr>
         <p:spPr>
           <a:xfrm>
-            <a:off x="6031149" y="2010383"/>
-            <a:ext cx="2594043" cy="1621277"/>
-          </a:xfrm>
-          <a:prstGeom prst="rect">
-            <a:avLst/>
-          </a:prstGeom>
-          <a:noFill/>
-          <a:ln w="19050">
-            <a:solidFill>
-              <a:srgbClr val="004347"/>
-            </a:solidFill>
-            <a:prstDash val="dash"/>
+            <a:off x="3761362" y="3810000"/>
+            <a:ext cx="778213" cy="1215957"/>
+          </a:xfrm>
+          <a:prstGeom prst="rect">
+            <a:avLst/>
+          </a:prstGeom>
+          <a:solidFill>
+            <a:srgbClr val="CBD0D3"/>
+          </a:solidFill>
+          <a:ln>
+            <a:noFill/>
           </a:ln>
           <a:effectLst/>
         </p:spPr>
@@ -12185,22 +12792,22 @@
       </p:sp>
       <p:sp>
         <p:nvSpPr>
-          <p:cNvPr id="14" name="TextBox 13"/>
-          <p:cNvSpPr txBox="1"/>
-          <p:nvPr/>
-        </p:nvSpPr>
-        <p:spPr>
-          <a:xfrm>
-            <a:off x="6031149" y="2010383"/>
-            <a:ext cx="2594043" cy="1621277"/>
-          </a:xfrm>
-          <a:prstGeom prst="rect">
-            <a:avLst/>
-          </a:prstGeom>
-          <a:noFill/>
-        </p:spPr>
-        <p:txBody>
-          <a:bodyPr wrap="square" anchor="ctr" lIns="0" rIns="0" tIns="0" bIns="0"/>
+          <p:cNvPr id="21" name="TextBox 20"/>
+          <p:cNvSpPr txBox="1"/>
+          <p:nvPr/>
+        </p:nvSpPr>
+        <p:spPr>
+          <a:xfrm>
+            <a:off x="3599234" y="3518170"/>
+            <a:ext cx="1102468" cy="243191"/>
+          </a:xfrm>
+          <a:prstGeom prst="rect">
+            <a:avLst/>
+          </a:prstGeom>
+          <a:noFill/>
+        </p:spPr>
+        <p:txBody>
+          <a:bodyPr wrap="square" anchor="t" lIns="0" rIns="0" tIns="0" bIns="0"/>
           <a:lstStyle/>
           <a:p>
             <a:pPr algn="ctr">
@@ -12209,29 +12816,225 @@
               </a:lnSpc>
             </a:pPr>
             <a:r>
-              <a:rPr sz="2778" b="1">
-                <a:solidFill>
-                  <a:srgbClr val="004347"/>
-                </a:solidFill>
-                <a:latin typeface="Zen Kaku Gothic New"/>
-                <a:ea typeface="Zen Kaku Gothic New"/>
-                <a:cs typeface="Zen Kaku Gothic New"/>
-              </a:rPr>
-              <a:t>算出中</a:t>
-            </a:r>
-          </a:p>
-        </p:txBody>
-      </p:sp>
-      <p:sp>
-        <p:nvSpPr>
-          <p:cNvPr id="15" name="TextBox 14"/>
-          <p:cNvSpPr txBox="1"/>
-          <p:nvPr/>
-        </p:nvSpPr>
-        <p:spPr>
-          <a:xfrm>
-            <a:off x="453957" y="4215319"/>
-            <a:ext cx="8106383" cy="972766"/>
+              <a:rPr sz="1389" b="1">
+                <a:solidFill>
+                  <a:srgbClr val="004347"/>
+                </a:solidFill>
+                <a:latin typeface="Outfit"/>
+                <a:ea typeface="Outfit"/>
+                <a:cs typeface="Outfit"/>
+              </a:rPr>
+              <a:t>1.5</a:t>
+            </a:r>
+          </a:p>
+        </p:txBody>
+      </p:sp>
+      <p:sp>
+        <p:nvSpPr>
+          <p:cNvPr id="22" name="TextBox 21"/>
+          <p:cNvSpPr txBox="1"/>
+          <p:nvPr/>
+        </p:nvSpPr>
+        <p:spPr>
+          <a:xfrm>
+            <a:off x="3599234" y="5107021"/>
+            <a:ext cx="1102468" cy="226979"/>
+          </a:xfrm>
+          <a:prstGeom prst="rect">
+            <a:avLst/>
+          </a:prstGeom>
+          <a:noFill/>
+        </p:spPr>
+        <p:txBody>
+          <a:bodyPr wrap="square" anchor="t" lIns="0" rIns="0" tIns="0" bIns="0"/>
+          <a:lstStyle/>
+          <a:p>
+            <a:pPr algn="ctr">
+              <a:lnSpc>
+                <a:spcPct val="150000"/>
+              </a:lnSpc>
+            </a:pPr>
+            <a:r>
+              <a:rPr sz="1136" b="0">
+                <a:solidFill>
+                  <a:srgbClr val="626262"/>
+                </a:solidFill>
+                <a:latin typeface="Zen Kaku Gothic New"/>
+                <a:ea typeface="Zen Kaku Gothic New"/>
+                <a:cs typeface="Zen Kaku Gothic New"/>
+              </a:rPr>
+              <a:t>第7期</a:t>
+            </a:r>
+          </a:p>
+        </p:txBody>
+      </p:sp>
+      <p:sp>
+        <p:nvSpPr>
+          <p:cNvPr id="23" name="Rectangle 22"/>
+          <p:cNvSpPr/>
+          <p:nvPr/>
+        </p:nvSpPr>
+        <p:spPr>
+          <a:xfrm>
+            <a:off x="4863830" y="3242553"/>
+            <a:ext cx="778213" cy="1783404"/>
+          </a:xfrm>
+          <a:prstGeom prst="rect">
+            <a:avLst/>
+          </a:prstGeom>
+          <a:solidFill>
+            <a:srgbClr val="004347"/>
+          </a:solidFill>
+          <a:ln>
+            <a:noFill/>
+          </a:ln>
+          <a:effectLst/>
+        </p:spPr>
+        <p:style>
+          <a:lnRef idx="1">
+            <a:schemeClr val="accent1"/>
+          </a:lnRef>
+          <a:fillRef idx="3">
+            <a:schemeClr val="accent1"/>
+          </a:fillRef>
+          <a:effectRef idx="2">
+            <a:schemeClr val="accent1"/>
+          </a:effectRef>
+          <a:fontRef idx="minor">
+            <a:schemeClr val="lt1"/>
+          </a:fontRef>
+        </p:style>
+        <p:txBody>
+          <a:bodyPr rtlCol="0" anchor="ctr"/>
+          <a:lstStyle/>
+          <a:p>
+            <a:pPr algn="ctr"/>
+          </a:p>
+        </p:txBody>
+      </p:sp>
+      <p:sp>
+        <p:nvSpPr>
+          <p:cNvPr id="24" name="TextBox 23"/>
+          <p:cNvSpPr txBox="1"/>
+          <p:nvPr/>
+        </p:nvSpPr>
+        <p:spPr>
+          <a:xfrm>
+            <a:off x="4701702" y="2950723"/>
+            <a:ext cx="1102468" cy="243191"/>
+          </a:xfrm>
+          <a:prstGeom prst="rect">
+            <a:avLst/>
+          </a:prstGeom>
+          <a:noFill/>
+        </p:spPr>
+        <p:txBody>
+          <a:bodyPr wrap="square" anchor="t" lIns="0" rIns="0" tIns="0" bIns="0"/>
+          <a:lstStyle/>
+          <a:p>
+            <a:pPr algn="ctr">
+              <a:lnSpc>
+                <a:spcPct val="150000"/>
+              </a:lnSpc>
+            </a:pPr>
+            <a:r>
+              <a:rPr sz="1389" b="1">
+                <a:solidFill>
+                  <a:srgbClr val="004347"/>
+                </a:solidFill>
+                <a:latin typeface="Outfit"/>
+                <a:ea typeface="Outfit"/>
+                <a:cs typeface="Outfit"/>
+              </a:rPr>
+              <a:t>2.2</a:t>
+            </a:r>
+          </a:p>
+        </p:txBody>
+      </p:sp>
+      <p:sp>
+        <p:nvSpPr>
+          <p:cNvPr id="25" name="TextBox 24"/>
+          <p:cNvSpPr txBox="1"/>
+          <p:nvPr/>
+        </p:nvSpPr>
+        <p:spPr>
+          <a:xfrm>
+            <a:off x="4701702" y="5107021"/>
+            <a:ext cx="1102468" cy="226979"/>
+          </a:xfrm>
+          <a:prstGeom prst="rect">
+            <a:avLst/>
+          </a:prstGeom>
+          <a:noFill/>
+        </p:spPr>
+        <p:txBody>
+          <a:bodyPr wrap="square" anchor="t" lIns="0" rIns="0" tIns="0" bIns="0"/>
+          <a:lstStyle/>
+          <a:p>
+            <a:pPr algn="ctr">
+              <a:lnSpc>
+                <a:spcPct val="150000"/>
+              </a:lnSpc>
+            </a:pPr>
+            <a:r>
+              <a:rPr sz="1136" b="0">
+                <a:solidFill>
+                  <a:srgbClr val="626262"/>
+                </a:solidFill>
+                <a:latin typeface="Zen Kaku Gothic New"/>
+                <a:ea typeface="Zen Kaku Gothic New"/>
+                <a:cs typeface="Zen Kaku Gothic New"/>
+              </a:rPr>
+              <a:t>第8期</a:t>
+            </a:r>
+          </a:p>
+        </p:txBody>
+      </p:sp>
+      <p:cxnSp>
+        <p:nvCxnSpPr>
+          <p:cNvPr id="26" name="Connector 25"/>
+          <p:cNvCxnSpPr/>
+          <p:nvPr/>
+        </p:nvCxnSpPr>
+        <p:spPr>
+          <a:xfrm>
+            <a:off x="3566809" y="5025957"/>
+            <a:ext cx="2399489" cy="0"/>
+          </a:xfrm>
+          <a:prstGeom prst="line">
+            <a:avLst/>
+          </a:prstGeom>
+          <a:ln w="12700">
+            <a:solidFill>
+              <a:srgbClr val="C9CFCF"/>
+            </a:solidFill>
+          </a:ln>
+        </p:spPr>
+        <p:style>
+          <a:lnRef idx="2">
+            <a:schemeClr val="accent1"/>
+          </a:lnRef>
+          <a:fillRef idx="0">
+            <a:schemeClr val="accent1"/>
+          </a:fillRef>
+          <a:effectRef idx="1">
+            <a:schemeClr val="accent1"/>
+          </a:effectRef>
+          <a:fontRef idx="minor">
+            <a:schemeClr val="tx1"/>
+          </a:fontRef>
+        </p:style>
+      </p:cxnSp>
+      <p:sp>
+        <p:nvSpPr>
+          <p:cNvPr id="27" name="TextBox 26"/>
+          <p:cNvSpPr txBox="1"/>
+          <p:nvPr/>
+        </p:nvSpPr>
+        <p:spPr>
+          <a:xfrm>
+            <a:off x="3372255" y="2691319"/>
+            <a:ext cx="2788596" cy="194553"/>
           </a:xfrm>
           <a:prstGeom prst="rect">
             <a:avLst/>
@@ -12248,7 +13051,7 @@
               </a:lnSpc>
             </a:pPr>
             <a:r>
-              <a:rPr sz="1768" b="0">
+              <a:rPr sz="1010" b="0">
                 <a:solidFill>
                   <a:srgbClr val="626262"/>
                 </a:solidFill>
@@ -12256,14 +13059,510 @@
                 <a:ea typeface="Zen Kaku Gothic New"/>
                 <a:cs typeface="Zen Kaku Gothic New"/>
               </a:rPr>
-              <a:t>（数字を入れたら、この1行を主張文に差し替え）</a:t>
-            </a:r>
-          </a:p>
-        </p:txBody>
-      </p:sp>
-      <p:sp>
-        <p:nvSpPr>
-          <p:cNvPr id="16" name="TextBox 15"/>
+              <a:t>単位：億円</a:t>
+            </a:r>
+          </a:p>
+        </p:txBody>
+      </p:sp>
+      <p:sp>
+        <p:nvSpPr>
+          <p:cNvPr id="28" name="TextBox 27"/>
+          <p:cNvSpPr txBox="1"/>
+          <p:nvPr/>
+        </p:nvSpPr>
+        <p:spPr>
+          <a:xfrm>
+            <a:off x="6290553" y="1394298"/>
+            <a:ext cx="2788596" cy="226979"/>
+          </a:xfrm>
+          <a:prstGeom prst="rect">
+            <a:avLst/>
+          </a:prstGeom>
+          <a:noFill/>
+        </p:spPr>
+        <p:txBody>
+          <a:bodyPr wrap="square" anchor="t" lIns="0" rIns="0" tIns="0" bIns="0"/>
+          <a:lstStyle/>
+          <a:p>
+            <a:pPr algn="l">
+              <a:lnSpc>
+                <a:spcPct val="150000"/>
+              </a:lnSpc>
+            </a:pPr>
+            <a:r>
+              <a:rPr sz="1136" b="0">
+                <a:solidFill>
+                  <a:srgbClr val="626262"/>
+                </a:solidFill>
+                <a:latin typeface="Zen Kaku Gothic New"/>
+                <a:ea typeface="Zen Kaku Gothic New"/>
+                <a:cs typeface="Zen Kaku Gothic New"/>
+              </a:rPr>
+              <a:t>ハナイチ</a:t>
+            </a:r>
+          </a:p>
+        </p:txBody>
+      </p:sp>
+      <p:sp>
+        <p:nvSpPr>
+          <p:cNvPr id="29" name="TextBox 28"/>
+          <p:cNvSpPr txBox="1"/>
+          <p:nvPr/>
+        </p:nvSpPr>
+        <p:spPr>
+          <a:xfrm>
+            <a:off x="6290553" y="1653702"/>
+            <a:ext cx="2788596" cy="324255"/>
+          </a:xfrm>
+          <a:prstGeom prst="rect">
+            <a:avLst/>
+          </a:prstGeom>
+          <a:noFill/>
+        </p:spPr>
+        <p:txBody>
+          <a:bodyPr wrap="square" anchor="t" lIns="0" rIns="0" tIns="0" bIns="0"/>
+          <a:lstStyle/>
+          <a:p>
+            <a:pPr algn="l">
+              <a:lnSpc>
+                <a:spcPct val="150000"/>
+              </a:lnSpc>
+            </a:pPr>
+            <a:r>
+              <a:rPr sz="1768" b="1">
+                <a:solidFill>
+                  <a:srgbClr val="004347"/>
+                </a:solidFill>
+                <a:latin typeface="Zen Kaku Gothic New"/>
+                <a:ea typeface="Zen Kaku Gothic New"/>
+                <a:cs typeface="Zen Kaku Gothic New"/>
+              </a:rPr>
+              <a:t>売上</a:t>
+            </a:r>
+          </a:p>
+        </p:txBody>
+      </p:sp>
+      <p:sp>
+        <p:nvSpPr>
+          <p:cNvPr id="30" name="TextBox 29"/>
+          <p:cNvSpPr txBox="1"/>
+          <p:nvPr/>
+        </p:nvSpPr>
+        <p:spPr>
+          <a:xfrm>
+            <a:off x="6290553" y="2026596"/>
+            <a:ext cx="2788596" cy="583660"/>
+          </a:xfrm>
+          <a:prstGeom prst="rect">
+            <a:avLst/>
+          </a:prstGeom>
+          <a:noFill/>
+        </p:spPr>
+        <p:txBody>
+          <a:bodyPr wrap="square" anchor="t" lIns="0" rIns="0" tIns="0" bIns="0"/>
+          <a:lstStyle/>
+          <a:p>
+            <a:pPr algn="l">
+              <a:lnSpc>
+                <a:spcPct val="100000"/>
+              </a:lnSpc>
+            </a:pPr>
+            <a:r>
+              <a:rPr sz="3536" b="1">
+                <a:solidFill>
+                  <a:srgbClr val="00D79C"/>
+                </a:solidFill>
+                <a:latin typeface="Outfit"/>
+                <a:ea typeface="Outfit"/>
+                <a:cs typeface="Outfit"/>
+              </a:rPr>
+              <a:t>+22%</a:t>
+            </a:r>
+          </a:p>
+        </p:txBody>
+      </p:sp>
+      <p:sp>
+        <p:nvSpPr>
+          <p:cNvPr id="31" name="Rectangle 30"/>
+          <p:cNvSpPr/>
+          <p:nvPr/>
+        </p:nvSpPr>
+        <p:spPr>
+          <a:xfrm>
+            <a:off x="6679660" y="3561030"/>
+            <a:ext cx="778213" cy="1464928"/>
+          </a:xfrm>
+          <a:prstGeom prst="rect">
+            <a:avLst/>
+          </a:prstGeom>
+          <a:solidFill>
+            <a:srgbClr val="CBD0D3"/>
+          </a:solidFill>
+          <a:ln>
+            <a:noFill/>
+          </a:ln>
+          <a:effectLst/>
+        </p:spPr>
+        <p:style>
+          <a:lnRef idx="1">
+            <a:schemeClr val="accent1"/>
+          </a:lnRef>
+          <a:fillRef idx="3">
+            <a:schemeClr val="accent1"/>
+          </a:fillRef>
+          <a:effectRef idx="2">
+            <a:schemeClr val="accent1"/>
+          </a:effectRef>
+          <a:fontRef idx="minor">
+            <a:schemeClr val="lt1"/>
+          </a:fontRef>
+        </p:style>
+        <p:txBody>
+          <a:bodyPr rtlCol="0" anchor="ctr"/>
+          <a:lstStyle/>
+          <a:p>
+            <a:pPr algn="ctr"/>
+          </a:p>
+        </p:txBody>
+      </p:sp>
+      <p:sp>
+        <p:nvSpPr>
+          <p:cNvPr id="32" name="TextBox 31"/>
+          <p:cNvSpPr txBox="1"/>
+          <p:nvPr/>
+        </p:nvSpPr>
+        <p:spPr>
+          <a:xfrm>
+            <a:off x="6517532" y="3269200"/>
+            <a:ext cx="1102468" cy="243191"/>
+          </a:xfrm>
+          <a:prstGeom prst="rect">
+            <a:avLst/>
+          </a:prstGeom>
+          <a:noFill/>
+        </p:spPr>
+        <p:txBody>
+          <a:bodyPr wrap="square" anchor="t" lIns="0" rIns="0" tIns="0" bIns="0"/>
+          <a:lstStyle/>
+          <a:p>
+            <a:pPr algn="ctr">
+              <a:lnSpc>
+                <a:spcPct val="150000"/>
+              </a:lnSpc>
+            </a:pPr>
+            <a:r>
+              <a:rPr sz="1389" b="1">
+                <a:solidFill>
+                  <a:srgbClr val="004347"/>
+                </a:solidFill>
+                <a:latin typeface="Outfit"/>
+                <a:ea typeface="Outfit"/>
+                <a:cs typeface="Outfit"/>
+              </a:rPr>
+              <a:t>4,540</a:t>
+            </a:r>
+          </a:p>
+        </p:txBody>
+      </p:sp>
+      <p:sp>
+        <p:nvSpPr>
+          <p:cNvPr id="33" name="TextBox 32"/>
+          <p:cNvSpPr txBox="1"/>
+          <p:nvPr/>
+        </p:nvSpPr>
+        <p:spPr>
+          <a:xfrm>
+            <a:off x="6517532" y="5107021"/>
+            <a:ext cx="1102468" cy="226979"/>
+          </a:xfrm>
+          <a:prstGeom prst="rect">
+            <a:avLst/>
+          </a:prstGeom>
+          <a:noFill/>
+        </p:spPr>
+        <p:txBody>
+          <a:bodyPr wrap="square" anchor="t" lIns="0" rIns="0" tIns="0" bIns="0"/>
+          <a:lstStyle/>
+          <a:p>
+            <a:pPr algn="ctr">
+              <a:lnSpc>
+                <a:spcPct val="150000"/>
+              </a:lnSpc>
+            </a:pPr>
+            <a:r>
+              <a:rPr sz="1136" b="0">
+                <a:solidFill>
+                  <a:srgbClr val="626262"/>
+                </a:solidFill>
+                <a:latin typeface="Zen Kaku Gothic New"/>
+                <a:ea typeface="Zen Kaku Gothic New"/>
+                <a:cs typeface="Zen Kaku Gothic New"/>
+              </a:rPr>
+              <a:t>第7期</a:t>
+            </a:r>
+          </a:p>
+        </p:txBody>
+      </p:sp>
+      <p:sp>
+        <p:nvSpPr>
+          <p:cNvPr id="34" name="Rectangle 33"/>
+          <p:cNvSpPr/>
+          <p:nvPr/>
+        </p:nvSpPr>
+        <p:spPr>
+          <a:xfrm>
+            <a:off x="7782128" y="3242553"/>
+            <a:ext cx="778213" cy="1783404"/>
+          </a:xfrm>
+          <a:prstGeom prst="rect">
+            <a:avLst/>
+          </a:prstGeom>
+          <a:solidFill>
+            <a:srgbClr val="004347"/>
+          </a:solidFill>
+          <a:ln>
+            <a:noFill/>
+          </a:ln>
+          <a:effectLst/>
+        </p:spPr>
+        <p:style>
+          <a:lnRef idx="1">
+            <a:schemeClr val="accent1"/>
+          </a:lnRef>
+          <a:fillRef idx="3">
+            <a:schemeClr val="accent1"/>
+          </a:fillRef>
+          <a:effectRef idx="2">
+            <a:schemeClr val="accent1"/>
+          </a:effectRef>
+          <a:fontRef idx="minor">
+            <a:schemeClr val="lt1"/>
+          </a:fontRef>
+        </p:style>
+        <p:txBody>
+          <a:bodyPr rtlCol="0" anchor="ctr"/>
+          <a:lstStyle/>
+          <a:p>
+            <a:pPr algn="ctr"/>
+          </a:p>
+        </p:txBody>
+      </p:sp>
+      <p:sp>
+        <p:nvSpPr>
+          <p:cNvPr id="35" name="TextBox 34"/>
+          <p:cNvSpPr txBox="1"/>
+          <p:nvPr/>
+        </p:nvSpPr>
+        <p:spPr>
+          <a:xfrm>
+            <a:off x="7620000" y="2950723"/>
+            <a:ext cx="1102468" cy="243191"/>
+          </a:xfrm>
+          <a:prstGeom prst="rect">
+            <a:avLst/>
+          </a:prstGeom>
+          <a:noFill/>
+        </p:spPr>
+        <p:txBody>
+          <a:bodyPr wrap="square" anchor="t" lIns="0" rIns="0" tIns="0" bIns="0"/>
+          <a:lstStyle/>
+          <a:p>
+            <a:pPr algn="ctr">
+              <a:lnSpc>
+                <a:spcPct val="150000"/>
+              </a:lnSpc>
+            </a:pPr>
+            <a:r>
+              <a:rPr sz="1389" b="1">
+                <a:solidFill>
+                  <a:srgbClr val="004347"/>
+                </a:solidFill>
+                <a:latin typeface="Outfit"/>
+                <a:ea typeface="Outfit"/>
+                <a:cs typeface="Outfit"/>
+              </a:rPr>
+              <a:t>5,527</a:t>
+            </a:r>
+          </a:p>
+        </p:txBody>
+      </p:sp>
+      <p:sp>
+        <p:nvSpPr>
+          <p:cNvPr id="36" name="TextBox 35"/>
+          <p:cNvSpPr txBox="1"/>
+          <p:nvPr/>
+        </p:nvSpPr>
+        <p:spPr>
+          <a:xfrm>
+            <a:off x="7620000" y="5107021"/>
+            <a:ext cx="1102468" cy="226979"/>
+          </a:xfrm>
+          <a:prstGeom prst="rect">
+            <a:avLst/>
+          </a:prstGeom>
+          <a:noFill/>
+        </p:spPr>
+        <p:txBody>
+          <a:bodyPr wrap="square" anchor="t" lIns="0" rIns="0" tIns="0" bIns="0"/>
+          <a:lstStyle/>
+          <a:p>
+            <a:pPr algn="ctr">
+              <a:lnSpc>
+                <a:spcPct val="150000"/>
+              </a:lnSpc>
+            </a:pPr>
+            <a:r>
+              <a:rPr sz="1136" b="0">
+                <a:solidFill>
+                  <a:srgbClr val="626262"/>
+                </a:solidFill>
+                <a:latin typeface="Zen Kaku Gothic New"/>
+                <a:ea typeface="Zen Kaku Gothic New"/>
+                <a:cs typeface="Zen Kaku Gothic New"/>
+              </a:rPr>
+              <a:t>第8期</a:t>
+            </a:r>
+          </a:p>
+        </p:txBody>
+      </p:sp>
+      <p:cxnSp>
+        <p:nvCxnSpPr>
+          <p:cNvPr id="37" name="Connector 36"/>
+          <p:cNvCxnSpPr/>
+          <p:nvPr/>
+        </p:nvCxnSpPr>
+        <p:spPr>
+          <a:xfrm>
+            <a:off x="6485106" y="5025957"/>
+            <a:ext cx="2399490" cy="0"/>
+          </a:xfrm>
+          <a:prstGeom prst="line">
+            <a:avLst/>
+          </a:prstGeom>
+          <a:ln w="12700">
+            <a:solidFill>
+              <a:srgbClr val="C9CFCF"/>
+            </a:solidFill>
+          </a:ln>
+        </p:spPr>
+        <p:style>
+          <a:lnRef idx="2">
+            <a:schemeClr val="accent1"/>
+          </a:lnRef>
+          <a:fillRef idx="0">
+            <a:schemeClr val="accent1"/>
+          </a:fillRef>
+          <a:effectRef idx="1">
+            <a:schemeClr val="accent1"/>
+          </a:effectRef>
+          <a:fontRef idx="minor">
+            <a:schemeClr val="tx1"/>
+          </a:fontRef>
+        </p:style>
+      </p:cxnSp>
+      <p:sp>
+        <p:nvSpPr>
+          <p:cNvPr id="38" name="TextBox 37"/>
+          <p:cNvSpPr txBox="1"/>
+          <p:nvPr/>
+        </p:nvSpPr>
+        <p:spPr>
+          <a:xfrm>
+            <a:off x="6290553" y="2691319"/>
+            <a:ext cx="2788596" cy="194553"/>
+          </a:xfrm>
+          <a:prstGeom prst="rect">
+            <a:avLst/>
+          </a:prstGeom>
+          <a:noFill/>
+        </p:spPr>
+        <p:txBody>
+          <a:bodyPr wrap="square" anchor="t" lIns="0" rIns="0" tIns="0" bIns="0"/>
+          <a:lstStyle/>
+          <a:p>
+            <a:pPr algn="l">
+              <a:lnSpc>
+                <a:spcPct val="150000"/>
+              </a:lnSpc>
+            </a:pPr>
+            <a:r>
+              <a:rPr sz="1010" b="0">
+                <a:solidFill>
+                  <a:srgbClr val="626262"/>
+                </a:solidFill>
+                <a:latin typeface="Zen Kaku Gothic New"/>
+                <a:ea typeface="Zen Kaku Gothic New"/>
+                <a:cs typeface="Zen Kaku Gothic New"/>
+              </a:rPr>
+              <a:t>単位：万円</a:t>
+            </a:r>
+          </a:p>
+        </p:txBody>
+      </p:sp>
+      <p:sp>
+        <p:nvSpPr>
+          <p:cNvPr id="39" name="TextBox 38"/>
+          <p:cNvSpPr txBox="1"/>
+          <p:nvPr/>
+        </p:nvSpPr>
+        <p:spPr>
+          <a:xfrm>
+            <a:off x="453957" y="5593404"/>
+            <a:ext cx="8106383" cy="356681"/>
+          </a:xfrm>
+          <a:prstGeom prst="rect">
+            <a:avLst/>
+          </a:prstGeom>
+          <a:noFill/>
+        </p:spPr>
+        <p:txBody>
+          <a:bodyPr wrap="square" anchor="t" lIns="0" rIns="0" tIns="0" bIns="0"/>
+          <a:lstStyle/>
+          <a:p>
+            <a:pPr algn="l">
+              <a:lnSpc>
+                <a:spcPct val="150000"/>
+              </a:lnSpc>
+            </a:pPr>
+            <a:r>
+              <a:rPr sz="1768" b="1">
+                <a:solidFill>
+                  <a:srgbClr val="004347"/>
+                </a:solidFill>
+                <a:latin typeface="Zen Kaku Gothic New"/>
+                <a:ea typeface="Zen Kaku Gothic New"/>
+                <a:cs typeface="Zen Kaku Gothic New"/>
+              </a:rPr>
+              <a:t>広告を絞っても売上は落とさず、</a:t>
+            </a:r>
+            <a:r>
+              <a:rPr sz="1768" b="1">
+                <a:solidFill>
+                  <a:srgbClr val="00D79C"/>
+                </a:solidFill>
+                <a:latin typeface="Zen Kaku Gothic New"/>
+                <a:ea typeface="Zen Kaku Gothic New"/>
+                <a:cs typeface="Zen Kaku Gothic New"/>
+              </a:rPr>
+              <a:t>利益が大きく残る形</a:t>
+            </a:r>
+            <a:r>
+              <a:rPr sz="1768" b="1">
+                <a:solidFill>
+                  <a:srgbClr val="004347"/>
+                </a:solidFill>
+                <a:latin typeface="Zen Kaku Gothic New"/>
+                <a:ea typeface="Zen Kaku Gothic New"/>
+                <a:cs typeface="Zen Kaku Gothic New"/>
+              </a:rPr>
+              <a:t>に変わった</a:t>
+            </a:r>
+          </a:p>
+        </p:txBody>
+      </p:sp>
+      <p:sp>
+        <p:nvSpPr>
+          <p:cNvPr id="40" name="TextBox 39"/>
           <p:cNvSpPr txBox="1"/>
           <p:nvPr/>
         </p:nvSpPr>
@@ -12295,7 +13594,7 @@
                 <a:ea typeface="Zen Kaku Gothic New"/>
                 <a:cs typeface="Zen Kaku Gothic New"/>
               </a:rPr>
-              <a:t>※ 決算確定値で差し替え</a:t>
+              <a:t>※ AP/AFは自社EC＋モール、税抜（小松資料）。ハナイチは税抜・植木鉢＋生花ほか（比須田資料）</a:t>
             </a:r>
           </a:p>
         </p:txBody>

</xml_diff>

<commit_message>
Remove theme shadows, narrow quarterly chart, allocate FY8 quarters to trial balance
Co-Authored-By: Claude Opus 5.5 <noreply@anthropic.com>
Claude-Session: https://claude.ai/code/session_01BLxZCgvJ3UR61Vf1LDEwyR
</commit_message>
<xml_diff>
--- a/retreat-2026-10/20261009_1day合宿_全社_第8期振り返りと第9期に向けて.pptx
+++ b/retreat-2026-10/20261009_1day合宿_全社_第8期振り返りと第9期に向けて.pptx
@@ -853,20 +853,6 @@
           </a:ln>
           <a:effectLst/>
         </p:spPr>
-        <p:style>
-          <a:lnRef idx="1">
-            <a:schemeClr val="accent1"/>
-          </a:lnRef>
-          <a:fillRef idx="3">
-            <a:schemeClr val="accent1"/>
-          </a:fillRef>
-          <a:effectRef idx="2">
-            <a:schemeClr val="accent1"/>
-          </a:effectRef>
-          <a:fontRef idx="minor">
-            <a:schemeClr val="lt1"/>
-          </a:fontRef>
-        </p:style>
         <p:txBody>
           <a:bodyPr rtlCol="0" anchor="ctr"/>
           <a:lstStyle/>
@@ -954,20 +940,6 @@
           </a:ln>
           <a:effectLst/>
         </p:spPr>
-        <p:style>
-          <a:lnRef idx="1">
-            <a:schemeClr val="accent1"/>
-          </a:lnRef>
-          <a:fillRef idx="3">
-            <a:schemeClr val="accent1"/>
-          </a:fillRef>
-          <a:effectRef idx="2">
-            <a:schemeClr val="accent1"/>
-          </a:effectRef>
-          <a:fontRef idx="minor">
-            <a:schemeClr val="lt1"/>
-          </a:fontRef>
-        </p:style>
         <p:txBody>
           <a:bodyPr rtlCol="0" anchor="ctr"/>
           <a:lstStyle/>
@@ -1101,7 +1073,7 @@
         </p:nvSpPr>
         <p:spPr>
           <a:xfrm>
-            <a:off x="5188085" y="1378085"/>
+            <a:off x="583660" y="1297021"/>
             <a:ext cx="129702" cy="129702"/>
           </a:xfrm>
           <a:prstGeom prst="rect">
@@ -1115,20 +1087,6 @@
           </a:ln>
           <a:effectLst/>
         </p:spPr>
-        <p:style>
-          <a:lnRef idx="1">
-            <a:schemeClr val="accent1"/>
-          </a:lnRef>
-          <a:fillRef idx="3">
-            <a:schemeClr val="accent1"/>
-          </a:fillRef>
-          <a:effectRef idx="2">
-            <a:schemeClr val="accent1"/>
-          </a:effectRef>
-          <a:fontRef idx="minor">
-            <a:schemeClr val="lt1"/>
-          </a:fontRef>
-        </p:style>
         <p:txBody>
           <a:bodyPr rtlCol="0" anchor="ctr"/>
           <a:lstStyle/>
@@ -1145,7 +1103,7 @@
         </p:nvSpPr>
         <p:spPr>
           <a:xfrm>
-            <a:off x="5382638" y="1329447"/>
+            <a:off x="778213" y="1248383"/>
             <a:ext cx="1297021" cy="226979"/>
           </a:xfrm>
           <a:prstGeom prst="rect">
@@ -1184,7 +1142,7 @@
         </p:nvSpPr>
         <p:spPr>
           <a:xfrm>
-            <a:off x="6404043" y="1378085"/>
+            <a:off x="1799617" y="1297021"/>
             <a:ext cx="129702" cy="129702"/>
           </a:xfrm>
           <a:prstGeom prst="rect">
@@ -1198,20 +1156,6 @@
           </a:ln>
           <a:effectLst/>
         </p:spPr>
-        <p:style>
-          <a:lnRef idx="1">
-            <a:schemeClr val="accent1"/>
-          </a:lnRef>
-          <a:fillRef idx="3">
-            <a:schemeClr val="accent1"/>
-          </a:fillRef>
-          <a:effectRef idx="2">
-            <a:schemeClr val="accent1"/>
-          </a:effectRef>
-          <a:fontRef idx="minor">
-            <a:schemeClr val="lt1"/>
-          </a:fontRef>
-        </p:style>
         <p:txBody>
           <a:bodyPr rtlCol="0" anchor="ctr"/>
           <a:lstStyle/>
@@ -1228,7 +1172,7 @@
         </p:nvSpPr>
         <p:spPr>
           <a:xfrm>
-            <a:off x="6598596" y="1329447"/>
+            <a:off x="1994170" y="1248383"/>
             <a:ext cx="1297021" cy="226979"/>
           </a:xfrm>
           <a:prstGeom prst="rect">
@@ -1267,7 +1211,7 @@
         </p:nvSpPr>
         <p:spPr>
           <a:xfrm>
-            <a:off x="7620000" y="1378085"/>
+            <a:off x="3015574" y="1297021"/>
             <a:ext cx="129702" cy="129702"/>
           </a:xfrm>
           <a:prstGeom prst="rect">
@@ -1281,20 +1225,6 @@
           </a:ln>
           <a:effectLst/>
         </p:spPr>
-        <p:style>
-          <a:lnRef idx="1">
-            <a:schemeClr val="accent1"/>
-          </a:lnRef>
-          <a:fillRef idx="3">
-            <a:schemeClr val="accent1"/>
-          </a:fillRef>
-          <a:effectRef idx="2">
-            <a:schemeClr val="accent1"/>
-          </a:effectRef>
-          <a:fontRef idx="minor">
-            <a:schemeClr val="lt1"/>
-          </a:fontRef>
-        </p:style>
         <p:txBody>
           <a:bodyPr rtlCol="0" anchor="ctr"/>
           <a:lstStyle/>
@@ -1311,7 +1241,7 @@
         </p:nvSpPr>
         <p:spPr>
           <a:xfrm>
-            <a:off x="7814553" y="1329447"/>
+            <a:off x="3210128" y="1248383"/>
             <a:ext cx="1297021" cy="226979"/>
           </a:xfrm>
           <a:prstGeom prst="rect">
@@ -1350,8 +1280,8 @@
         </p:nvSpPr>
         <p:spPr>
           <a:xfrm>
-            <a:off x="583660" y="4919778"/>
-            <a:ext cx="251298" cy="25116"/>
+            <a:off x="583660" y="4921579"/>
+            <a:ext cx="194553" cy="23314"/>
           </a:xfrm>
           <a:prstGeom prst="rect">
             <a:avLst/>
@@ -1364,20 +1294,6 @@
           </a:ln>
           <a:effectLst/>
         </p:spPr>
-        <p:style>
-          <a:lnRef idx="1">
-            <a:schemeClr val="accent1"/>
-          </a:lnRef>
-          <a:fillRef idx="3">
-            <a:schemeClr val="accent1"/>
-          </a:fillRef>
-          <a:effectRef idx="2">
-            <a:schemeClr val="accent1"/>
-          </a:effectRef>
-          <a:fontRef idx="minor">
-            <a:schemeClr val="lt1"/>
-          </a:fontRef>
-        </p:style>
         <p:txBody>
           <a:bodyPr rtlCol="0" anchor="ctr"/>
           <a:lstStyle/>
@@ -1394,8 +1310,8 @@
         </p:nvSpPr>
         <p:spPr>
           <a:xfrm>
-            <a:off x="518809" y="4709012"/>
-            <a:ext cx="381000" cy="178340"/>
+            <a:off x="502596" y="4710813"/>
+            <a:ext cx="356681" cy="178340"/>
           </a:xfrm>
           <a:prstGeom prst="rect">
             <a:avLst/>
@@ -1433,8 +1349,8 @@
         </p:nvSpPr>
         <p:spPr>
           <a:xfrm>
-            <a:off x="948447" y="4846615"/>
-            <a:ext cx="251298" cy="98279"/>
+            <a:off x="875489" y="4853664"/>
+            <a:ext cx="194553" cy="91229"/>
           </a:xfrm>
           <a:prstGeom prst="rect">
             <a:avLst/>
@@ -1447,20 +1363,6 @@
           </a:ln>
           <a:effectLst/>
         </p:spPr>
-        <p:style>
-          <a:lnRef idx="1">
-            <a:schemeClr val="accent1"/>
-          </a:lnRef>
-          <a:fillRef idx="3">
-            <a:schemeClr val="accent1"/>
-          </a:fillRef>
-          <a:effectRef idx="2">
-            <a:schemeClr val="accent1"/>
-          </a:effectRef>
-          <a:fontRef idx="minor">
-            <a:schemeClr val="lt1"/>
-          </a:fontRef>
-        </p:style>
         <p:txBody>
           <a:bodyPr rtlCol="0" anchor="ctr"/>
           <a:lstStyle/>
@@ -1477,8 +1379,8 @@
         </p:nvSpPr>
         <p:spPr>
           <a:xfrm>
-            <a:off x="883596" y="4635849"/>
-            <a:ext cx="381000" cy="178340"/>
+            <a:off x="794426" y="4642898"/>
+            <a:ext cx="356681" cy="178340"/>
           </a:xfrm>
           <a:prstGeom prst="rect">
             <a:avLst/>
@@ -1516,8 +1418,8 @@
         </p:nvSpPr>
         <p:spPr>
           <a:xfrm>
-            <a:off x="1313234" y="4752704"/>
-            <a:ext cx="251298" cy="192189"/>
+            <a:off x="1167319" y="4766490"/>
+            <a:ext cx="194553" cy="178404"/>
           </a:xfrm>
           <a:prstGeom prst="rect">
             <a:avLst/>
@@ -1530,20 +1432,6 @@
           </a:ln>
           <a:effectLst/>
         </p:spPr>
-        <p:style>
-          <a:lnRef idx="1">
-            <a:schemeClr val="accent1"/>
-          </a:lnRef>
-          <a:fillRef idx="3">
-            <a:schemeClr val="accent1"/>
-          </a:fillRef>
-          <a:effectRef idx="2">
-            <a:schemeClr val="accent1"/>
-          </a:effectRef>
-          <a:fontRef idx="minor">
-            <a:schemeClr val="lt1"/>
-          </a:fontRef>
-        </p:style>
         <p:txBody>
           <a:bodyPr rtlCol="0" anchor="ctr"/>
           <a:lstStyle/>
@@ -1560,8 +1448,8 @@
         </p:nvSpPr>
         <p:spPr>
           <a:xfrm>
-            <a:off x="1313234" y="4749428"/>
-            <a:ext cx="251298" cy="3276"/>
+            <a:off x="1167319" y="4763449"/>
+            <a:ext cx="194553" cy="3041"/>
           </a:xfrm>
           <a:prstGeom prst="rect">
             <a:avLst/>
@@ -1574,20 +1462,6 @@
           </a:ln>
           <a:effectLst/>
         </p:spPr>
-        <p:style>
-          <a:lnRef idx="1">
-            <a:schemeClr val="accent1"/>
-          </a:lnRef>
-          <a:fillRef idx="3">
-            <a:schemeClr val="accent1"/>
-          </a:fillRef>
-          <a:effectRef idx="2">
-            <a:schemeClr val="accent1"/>
-          </a:effectRef>
-          <a:fontRef idx="minor">
-            <a:schemeClr val="lt1"/>
-          </a:fontRef>
-        </p:style>
         <p:txBody>
           <a:bodyPr rtlCol="0" anchor="ctr"/>
           <a:lstStyle/>
@@ -1604,8 +1478,8 @@
         </p:nvSpPr>
         <p:spPr>
           <a:xfrm>
-            <a:off x="1248383" y="4538662"/>
-            <a:ext cx="381000" cy="178340"/>
+            <a:off x="1086255" y="4552683"/>
+            <a:ext cx="356681" cy="178340"/>
           </a:xfrm>
           <a:prstGeom prst="rect">
             <a:avLst/>
@@ -1643,8 +1517,8 @@
         </p:nvSpPr>
         <p:spPr>
           <a:xfrm>
-            <a:off x="1678021" y="4695921"/>
-            <a:ext cx="251298" cy="248973"/>
+            <a:off x="1459149" y="4713779"/>
+            <a:ext cx="194553" cy="231114"/>
           </a:xfrm>
           <a:prstGeom prst="rect">
             <a:avLst/>
@@ -1657,20 +1531,6 @@
           </a:ln>
           <a:effectLst/>
         </p:spPr>
-        <p:style>
-          <a:lnRef idx="1">
-            <a:schemeClr val="accent1"/>
-          </a:lnRef>
-          <a:fillRef idx="3">
-            <a:schemeClr val="accent1"/>
-          </a:fillRef>
-          <a:effectRef idx="2">
-            <a:schemeClr val="accent1"/>
-          </a:effectRef>
-          <a:fontRef idx="minor">
-            <a:schemeClr val="lt1"/>
-          </a:fontRef>
-        </p:style>
         <p:txBody>
           <a:bodyPr rtlCol="0" anchor="ctr"/>
           <a:lstStyle/>
@@ -1687,8 +1547,8 @@
         </p:nvSpPr>
         <p:spPr>
           <a:xfrm>
-            <a:off x="1678021" y="4671897"/>
-            <a:ext cx="251298" cy="24024"/>
+            <a:off x="1459149" y="4691479"/>
+            <a:ext cx="194553" cy="22301"/>
           </a:xfrm>
           <a:prstGeom prst="rect">
             <a:avLst/>
@@ -1701,20 +1561,6 @@
           </a:ln>
           <a:effectLst/>
         </p:spPr>
-        <p:style>
-          <a:lnRef idx="1">
-            <a:schemeClr val="accent1"/>
-          </a:lnRef>
-          <a:fillRef idx="3">
-            <a:schemeClr val="accent1"/>
-          </a:fillRef>
-          <a:effectRef idx="2">
-            <a:schemeClr val="accent1"/>
-          </a:effectRef>
-          <a:fontRef idx="minor">
-            <a:schemeClr val="lt1"/>
-          </a:fontRef>
-        </p:style>
         <p:txBody>
           <a:bodyPr rtlCol="0" anchor="ctr"/>
           <a:lstStyle/>
@@ -1731,8 +1577,8 @@
         </p:nvSpPr>
         <p:spPr>
           <a:xfrm>
-            <a:off x="1613170" y="4461131"/>
-            <a:ext cx="381000" cy="178340"/>
+            <a:off x="1378085" y="4480713"/>
+            <a:ext cx="356681" cy="178340"/>
           </a:xfrm>
           <a:prstGeom prst="rect">
             <a:avLst/>
@@ -1770,8 +1616,8 @@
         </p:nvSpPr>
         <p:spPr>
           <a:xfrm>
-            <a:off x="2042809" y="4670805"/>
-            <a:ext cx="251298" cy="274088"/>
+            <a:off x="1750979" y="4690465"/>
+            <a:ext cx="194553" cy="254428"/>
           </a:xfrm>
           <a:prstGeom prst="rect">
             <a:avLst/>
@@ -1784,20 +1630,6 @@
           </a:ln>
           <a:effectLst/>
         </p:spPr>
-        <p:style>
-          <a:lnRef idx="1">
-            <a:schemeClr val="accent1"/>
-          </a:lnRef>
-          <a:fillRef idx="3">
-            <a:schemeClr val="accent1"/>
-          </a:fillRef>
-          <a:effectRef idx="2">
-            <a:schemeClr val="accent1"/>
-          </a:effectRef>
-          <a:fontRef idx="minor">
-            <a:schemeClr val="lt1"/>
-          </a:fontRef>
-        </p:style>
         <p:txBody>
           <a:bodyPr rtlCol="0" anchor="ctr"/>
           <a:lstStyle/>
@@ -1814,8 +1646,8 @@
         </p:nvSpPr>
         <p:spPr>
           <a:xfrm>
-            <a:off x="2042809" y="4593274"/>
-            <a:ext cx="251298" cy="77531"/>
+            <a:off x="1750979" y="4618495"/>
+            <a:ext cx="194553" cy="71970"/>
           </a:xfrm>
           <a:prstGeom prst="rect">
             <a:avLst/>
@@ -1828,20 +1660,6 @@
           </a:ln>
           <a:effectLst/>
         </p:spPr>
-        <p:style>
-          <a:lnRef idx="1">
-            <a:schemeClr val="accent1"/>
-          </a:lnRef>
-          <a:fillRef idx="3">
-            <a:schemeClr val="accent1"/>
-          </a:fillRef>
-          <a:effectRef idx="2">
-            <a:schemeClr val="accent1"/>
-          </a:effectRef>
-          <a:fontRef idx="minor">
-            <a:schemeClr val="lt1"/>
-          </a:fontRef>
-        </p:style>
         <p:txBody>
           <a:bodyPr rtlCol="0" anchor="ctr"/>
           <a:lstStyle/>
@@ -1858,8 +1676,8 @@
         </p:nvSpPr>
         <p:spPr>
           <a:xfrm>
-            <a:off x="1977957" y="4382508"/>
-            <a:ext cx="381000" cy="178340"/>
+            <a:off x="1669915" y="4407729"/>
+            <a:ext cx="356681" cy="178340"/>
           </a:xfrm>
           <a:prstGeom prst="rect">
             <a:avLst/>
@@ -1897,8 +1715,8 @@
         </p:nvSpPr>
         <p:spPr>
           <a:xfrm>
-            <a:off x="2407596" y="4636954"/>
-            <a:ext cx="251298" cy="307940"/>
+            <a:off x="2042809" y="4659042"/>
+            <a:ext cx="194553" cy="285852"/>
           </a:xfrm>
           <a:prstGeom prst="rect">
             <a:avLst/>
@@ -1911,20 +1729,6 @@
           </a:ln>
           <a:effectLst/>
         </p:spPr>
-        <p:style>
-          <a:lnRef idx="1">
-            <a:schemeClr val="accent1"/>
-          </a:lnRef>
-          <a:fillRef idx="3">
-            <a:schemeClr val="accent1"/>
-          </a:fillRef>
-          <a:effectRef idx="2">
-            <a:schemeClr val="accent1"/>
-          </a:effectRef>
-          <a:fontRef idx="minor">
-            <a:schemeClr val="lt1"/>
-          </a:fontRef>
-        </p:style>
         <p:txBody>
           <a:bodyPr rtlCol="0" anchor="ctr"/>
           <a:lstStyle/>
@@ -1941,8 +1745,8 @@
         </p:nvSpPr>
         <p:spPr>
           <a:xfrm>
-            <a:off x="2407596" y="4606378"/>
-            <a:ext cx="251298" cy="30576"/>
+            <a:off x="2042809" y="4630659"/>
+            <a:ext cx="194553" cy="28382"/>
           </a:xfrm>
           <a:prstGeom prst="rect">
             <a:avLst/>
@@ -1955,20 +1759,6 @@
           </a:ln>
           <a:effectLst/>
         </p:spPr>
-        <p:style>
-          <a:lnRef idx="1">
-            <a:schemeClr val="accent1"/>
-          </a:lnRef>
-          <a:fillRef idx="3">
-            <a:schemeClr val="accent1"/>
-          </a:fillRef>
-          <a:effectRef idx="2">
-            <a:schemeClr val="accent1"/>
-          </a:effectRef>
-          <a:fontRef idx="minor">
-            <a:schemeClr val="lt1"/>
-          </a:fontRef>
-        </p:style>
         <p:txBody>
           <a:bodyPr rtlCol="0" anchor="ctr"/>
           <a:lstStyle/>
@@ -1985,8 +1775,8 @@
         </p:nvSpPr>
         <p:spPr>
           <a:xfrm>
-            <a:off x="2342745" y="4395612"/>
-            <a:ext cx="381000" cy="178340"/>
+            <a:off x="1961745" y="4419893"/>
+            <a:ext cx="356681" cy="178340"/>
           </a:xfrm>
           <a:prstGeom prst="rect">
             <a:avLst/>
@@ -2024,8 +1814,8 @@
         </p:nvSpPr>
         <p:spPr>
           <a:xfrm>
-            <a:off x="2772383" y="4592182"/>
-            <a:ext cx="251298" cy="352711"/>
+            <a:off x="2334638" y="4617482"/>
+            <a:ext cx="194553" cy="327412"/>
           </a:xfrm>
           <a:prstGeom prst="rect">
             <a:avLst/>
@@ -2038,20 +1828,6 @@
           </a:ln>
           <a:effectLst/>
         </p:spPr>
-        <p:style>
-          <a:lnRef idx="1">
-            <a:schemeClr val="accent1"/>
-          </a:lnRef>
-          <a:fillRef idx="3">
-            <a:schemeClr val="accent1"/>
-          </a:fillRef>
-          <a:effectRef idx="2">
-            <a:schemeClr val="accent1"/>
-          </a:effectRef>
-          <a:fontRef idx="minor">
-            <a:schemeClr val="lt1"/>
-          </a:fontRef>
-        </p:style>
         <p:txBody>
           <a:bodyPr rtlCol="0" anchor="ctr"/>
           <a:lstStyle/>
@@ -2068,8 +1844,8 @@
         </p:nvSpPr>
         <p:spPr>
           <a:xfrm>
-            <a:off x="2772383" y="4547411"/>
-            <a:ext cx="251298" cy="44771"/>
+            <a:off x="2334638" y="4575922"/>
+            <a:ext cx="194553" cy="41560"/>
           </a:xfrm>
           <a:prstGeom prst="rect">
             <a:avLst/>
@@ -2082,20 +1858,6 @@
           </a:ln>
           <a:effectLst/>
         </p:spPr>
-        <p:style>
-          <a:lnRef idx="1">
-            <a:schemeClr val="accent1"/>
-          </a:lnRef>
-          <a:fillRef idx="3">
-            <a:schemeClr val="accent1"/>
-          </a:fillRef>
-          <a:effectRef idx="2">
-            <a:schemeClr val="accent1"/>
-          </a:effectRef>
-          <a:fontRef idx="minor">
-            <a:schemeClr val="lt1"/>
-          </a:fontRef>
-        </p:style>
         <p:txBody>
           <a:bodyPr rtlCol="0" anchor="ctr"/>
           <a:lstStyle/>
@@ -2112,8 +1874,8 @@
         </p:nvSpPr>
         <p:spPr>
           <a:xfrm>
-            <a:off x="2707532" y="4336645"/>
-            <a:ext cx="381000" cy="178340"/>
+            <a:off x="2253574" y="4365156"/>
+            <a:ext cx="356681" cy="178340"/>
           </a:xfrm>
           <a:prstGeom prst="rect">
             <a:avLst/>
@@ -2151,8 +1913,8 @@
         </p:nvSpPr>
         <p:spPr>
           <a:xfrm>
-            <a:off x="3137170" y="4491720"/>
-            <a:ext cx="251298" cy="453174"/>
+            <a:off x="2626468" y="4524225"/>
+            <a:ext cx="194553" cy="420669"/>
           </a:xfrm>
           <a:prstGeom prst="rect">
             <a:avLst/>
@@ -2165,20 +1927,6 @@
           </a:ln>
           <a:effectLst/>
         </p:spPr>
-        <p:style>
-          <a:lnRef idx="1">
-            <a:schemeClr val="accent1"/>
-          </a:lnRef>
-          <a:fillRef idx="3">
-            <a:schemeClr val="accent1"/>
-          </a:fillRef>
-          <a:effectRef idx="2">
-            <a:schemeClr val="accent1"/>
-          </a:effectRef>
-          <a:fontRef idx="minor">
-            <a:schemeClr val="lt1"/>
-          </a:fontRef>
-        </p:style>
         <p:txBody>
           <a:bodyPr rtlCol="0" anchor="ctr"/>
           <a:lstStyle/>
@@ -2195,8 +1943,8 @@
         </p:nvSpPr>
         <p:spPr>
           <a:xfrm>
-            <a:off x="3137170" y="4425109"/>
-            <a:ext cx="251298" cy="66611"/>
+            <a:off x="2626468" y="4462392"/>
+            <a:ext cx="194553" cy="61833"/>
           </a:xfrm>
           <a:prstGeom prst="rect">
             <a:avLst/>
@@ -2209,20 +1957,6 @@
           </a:ln>
           <a:effectLst/>
         </p:spPr>
-        <p:style>
-          <a:lnRef idx="1">
-            <a:schemeClr val="accent1"/>
-          </a:lnRef>
-          <a:fillRef idx="3">
-            <a:schemeClr val="accent1"/>
-          </a:fillRef>
-          <a:effectRef idx="2">
-            <a:schemeClr val="accent1"/>
-          </a:effectRef>
-          <a:fontRef idx="minor">
-            <a:schemeClr val="lt1"/>
-          </a:fontRef>
-        </p:style>
         <p:txBody>
           <a:bodyPr rtlCol="0" anchor="ctr"/>
           <a:lstStyle/>
@@ -2239,8 +1973,8 @@
         </p:nvSpPr>
         <p:spPr>
           <a:xfrm>
-            <a:off x="3072319" y="4214343"/>
-            <a:ext cx="381000" cy="178340"/>
+            <a:off x="2545404" y="4251626"/>
+            <a:ext cx="356681" cy="178340"/>
           </a:xfrm>
           <a:prstGeom prst="rect">
             <a:avLst/>
@@ -2278,8 +2012,8 @@
         </p:nvSpPr>
         <p:spPr>
           <a:xfrm>
-            <a:off x="3501957" y="4311542"/>
-            <a:ext cx="251298" cy="633351"/>
+            <a:off x="2918298" y="4356971"/>
+            <a:ext cx="194553" cy="587922"/>
           </a:xfrm>
           <a:prstGeom prst="rect">
             <a:avLst/>
@@ -2292,20 +2026,6 @@
           </a:ln>
           <a:effectLst/>
         </p:spPr>
-        <p:style>
-          <a:lnRef idx="1">
-            <a:schemeClr val="accent1"/>
-          </a:lnRef>
-          <a:fillRef idx="3">
-            <a:schemeClr val="accent1"/>
-          </a:fillRef>
-          <a:effectRef idx="2">
-            <a:schemeClr val="accent1"/>
-          </a:effectRef>
-          <a:fontRef idx="minor">
-            <a:schemeClr val="lt1"/>
-          </a:fontRef>
-        </p:style>
         <p:txBody>
           <a:bodyPr rtlCol="0" anchor="ctr"/>
           <a:lstStyle/>
@@ -2322,8 +2042,8 @@
         </p:nvSpPr>
         <p:spPr>
           <a:xfrm>
-            <a:off x="3501957" y="4126997"/>
-            <a:ext cx="251298" cy="184545"/>
+            <a:off x="2918298" y="4185663"/>
+            <a:ext cx="194553" cy="171308"/>
           </a:xfrm>
           <a:prstGeom prst="rect">
             <a:avLst/>
@@ -2336,20 +2056,6 @@
           </a:ln>
           <a:effectLst/>
         </p:spPr>
-        <p:style>
-          <a:lnRef idx="1">
-            <a:schemeClr val="accent1"/>
-          </a:lnRef>
-          <a:fillRef idx="3">
-            <a:schemeClr val="accent1"/>
-          </a:fillRef>
-          <a:effectRef idx="2">
-            <a:schemeClr val="accent1"/>
-          </a:effectRef>
-          <a:fontRef idx="minor">
-            <a:schemeClr val="lt1"/>
-          </a:fontRef>
-        </p:style>
         <p:txBody>
           <a:bodyPr rtlCol="0" anchor="ctr"/>
           <a:lstStyle/>
@@ -2366,8 +2072,8 @@
         </p:nvSpPr>
         <p:spPr>
           <a:xfrm>
-            <a:off x="3437106" y="3916231"/>
-            <a:ext cx="381000" cy="178340"/>
+            <a:off x="2837234" y="3974897"/>
+            <a:ext cx="356681" cy="178340"/>
           </a:xfrm>
           <a:prstGeom prst="rect">
             <a:avLst/>
@@ -2405,8 +2111,8 @@
         </p:nvSpPr>
         <p:spPr>
           <a:xfrm>
-            <a:off x="3866745" y="4263495"/>
-            <a:ext cx="251298" cy="681399"/>
+            <a:off x="3210128" y="4312370"/>
+            <a:ext cx="194553" cy="632523"/>
           </a:xfrm>
           <a:prstGeom prst="rect">
             <a:avLst/>
@@ -2419,20 +2125,6 @@
           </a:ln>
           <a:effectLst/>
         </p:spPr>
-        <p:style>
-          <a:lnRef idx="1">
-            <a:schemeClr val="accent1"/>
-          </a:lnRef>
-          <a:fillRef idx="3">
-            <a:schemeClr val="accent1"/>
-          </a:fillRef>
-          <a:effectRef idx="2">
-            <a:schemeClr val="accent1"/>
-          </a:effectRef>
-          <a:fontRef idx="minor">
-            <a:schemeClr val="lt1"/>
-          </a:fontRef>
-        </p:style>
         <p:txBody>
           <a:bodyPr rtlCol="0" anchor="ctr"/>
           <a:lstStyle/>
@@ -2449,8 +2141,8 @@
         </p:nvSpPr>
         <p:spPr>
           <a:xfrm>
-            <a:off x="3866745" y="4173952"/>
-            <a:ext cx="251298" cy="89543"/>
+            <a:off x="3210128" y="4229250"/>
+            <a:ext cx="194553" cy="83120"/>
           </a:xfrm>
           <a:prstGeom prst="rect">
             <a:avLst/>
@@ -2463,20 +2155,6 @@
           </a:ln>
           <a:effectLst/>
         </p:spPr>
-        <p:style>
-          <a:lnRef idx="1">
-            <a:schemeClr val="accent1"/>
-          </a:lnRef>
-          <a:fillRef idx="3">
-            <a:schemeClr val="accent1"/>
-          </a:fillRef>
-          <a:effectRef idx="2">
-            <a:schemeClr val="accent1"/>
-          </a:effectRef>
-          <a:fontRef idx="minor">
-            <a:schemeClr val="lt1"/>
-          </a:fontRef>
-        </p:style>
         <p:txBody>
           <a:bodyPr rtlCol="0" anchor="ctr"/>
           <a:lstStyle/>
@@ -2493,8 +2171,8 @@
         </p:nvSpPr>
         <p:spPr>
           <a:xfrm>
-            <a:off x="3801894" y="3963186"/>
-            <a:ext cx="381000" cy="178340"/>
+            <a:off x="3129064" y="4018484"/>
+            <a:ext cx="356681" cy="178340"/>
           </a:xfrm>
           <a:prstGeom prst="rect">
             <a:avLst/>
@@ -2532,8 +2210,8 @@
         </p:nvSpPr>
         <p:spPr>
           <a:xfrm>
-            <a:off x="4231532" y="4235103"/>
-            <a:ext cx="251298" cy="709790"/>
+            <a:off x="3501957" y="4286015"/>
+            <a:ext cx="194553" cy="658879"/>
           </a:xfrm>
           <a:prstGeom prst="rect">
             <a:avLst/>
@@ -2546,20 +2224,6 @@
           </a:ln>
           <a:effectLst/>
         </p:spPr>
-        <p:style>
-          <a:lnRef idx="1">
-            <a:schemeClr val="accent1"/>
-          </a:lnRef>
-          <a:fillRef idx="3">
-            <a:schemeClr val="accent1"/>
-          </a:fillRef>
-          <a:effectRef idx="2">
-            <a:schemeClr val="accent1"/>
-          </a:effectRef>
-          <a:fontRef idx="minor">
-            <a:schemeClr val="lt1"/>
-          </a:fontRef>
-        </p:style>
         <p:txBody>
           <a:bodyPr rtlCol="0" anchor="ctr"/>
           <a:lstStyle/>
@@ -2576,8 +2240,8 @@
         </p:nvSpPr>
         <p:spPr>
           <a:xfrm>
-            <a:off x="4231532" y="4117169"/>
-            <a:ext cx="251298" cy="117934"/>
+            <a:off x="3501957" y="4176540"/>
+            <a:ext cx="194553" cy="109475"/>
           </a:xfrm>
           <a:prstGeom prst="rect">
             <a:avLst/>
@@ -2590,20 +2254,6 @@
           </a:ln>
           <a:effectLst/>
         </p:spPr>
-        <p:style>
-          <a:lnRef idx="1">
-            <a:schemeClr val="accent1"/>
-          </a:lnRef>
-          <a:fillRef idx="3">
-            <a:schemeClr val="accent1"/>
-          </a:fillRef>
-          <a:effectRef idx="2">
-            <a:schemeClr val="accent1"/>
-          </a:effectRef>
-          <a:fontRef idx="minor">
-            <a:schemeClr val="lt1"/>
-          </a:fontRef>
-        </p:style>
         <p:txBody>
           <a:bodyPr rtlCol="0" anchor="ctr"/>
           <a:lstStyle/>
@@ -2620,8 +2270,8 @@
         </p:nvSpPr>
         <p:spPr>
           <a:xfrm>
-            <a:off x="4166681" y="3906403"/>
-            <a:ext cx="381000" cy="178340"/>
+            <a:off x="3420894" y="3965774"/>
+            <a:ext cx="356681" cy="178340"/>
           </a:xfrm>
           <a:prstGeom prst="rect">
             <a:avLst/>
@@ -2659,8 +2309,8 @@
         </p:nvSpPr>
         <p:spPr>
           <a:xfrm>
-            <a:off x="4596319" y="3955555"/>
-            <a:ext cx="251298" cy="989338"/>
+            <a:off x="3793787" y="4026518"/>
+            <a:ext cx="194553" cy="918375"/>
           </a:xfrm>
           <a:prstGeom prst="rect">
             <a:avLst/>
@@ -2673,20 +2323,6 @@
           </a:ln>
           <a:effectLst/>
         </p:spPr>
-        <p:style>
-          <a:lnRef idx="1">
-            <a:schemeClr val="accent1"/>
-          </a:lnRef>
-          <a:fillRef idx="3">
-            <a:schemeClr val="accent1"/>
-          </a:fillRef>
-          <a:effectRef idx="2">
-            <a:schemeClr val="accent1"/>
-          </a:effectRef>
-          <a:fontRef idx="minor">
-            <a:schemeClr val="lt1"/>
-          </a:fontRef>
-        </p:style>
         <p:txBody>
           <a:bodyPr rtlCol="0" anchor="ctr"/>
           <a:lstStyle/>
@@ -2703,8 +2339,8 @@
         </p:nvSpPr>
         <p:spPr>
           <a:xfrm>
-            <a:off x="4596319" y="3736066"/>
-            <a:ext cx="251298" cy="219489"/>
+            <a:off x="3793787" y="3822773"/>
+            <a:ext cx="194553" cy="203746"/>
           </a:xfrm>
           <a:prstGeom prst="rect">
             <a:avLst/>
@@ -2717,20 +2353,6 @@
           </a:ln>
           <a:effectLst/>
         </p:spPr>
-        <p:style>
-          <a:lnRef idx="1">
-            <a:schemeClr val="accent1"/>
-          </a:lnRef>
-          <a:fillRef idx="3">
-            <a:schemeClr val="accent1"/>
-          </a:fillRef>
-          <a:effectRef idx="2">
-            <a:schemeClr val="accent1"/>
-          </a:effectRef>
-          <a:fontRef idx="minor">
-            <a:schemeClr val="lt1"/>
-          </a:fontRef>
-        </p:style>
         <p:txBody>
           <a:bodyPr rtlCol="0" anchor="ctr"/>
           <a:lstStyle/>
@@ -2747,8 +2369,8 @@
         </p:nvSpPr>
         <p:spPr>
           <a:xfrm>
-            <a:off x="4596319" y="3729514"/>
-            <a:ext cx="251298" cy="6552"/>
+            <a:off x="3793787" y="3816691"/>
+            <a:ext cx="194553" cy="6082"/>
           </a:xfrm>
           <a:prstGeom prst="rect">
             <a:avLst/>
@@ -2761,20 +2383,6 @@
           </a:ln>
           <a:effectLst/>
         </p:spPr>
-        <p:style>
-          <a:lnRef idx="1">
-            <a:schemeClr val="accent1"/>
-          </a:lnRef>
-          <a:fillRef idx="3">
-            <a:schemeClr val="accent1"/>
-          </a:fillRef>
-          <a:effectRef idx="2">
-            <a:schemeClr val="accent1"/>
-          </a:effectRef>
-          <a:fontRef idx="minor">
-            <a:schemeClr val="lt1"/>
-          </a:fontRef>
-        </p:style>
         <p:txBody>
           <a:bodyPr rtlCol="0" anchor="ctr"/>
           <a:lstStyle/>
@@ -2791,8 +2399,8 @@
         </p:nvSpPr>
         <p:spPr>
           <a:xfrm>
-            <a:off x="4531468" y="3518748"/>
-            <a:ext cx="381000" cy="178340"/>
+            <a:off x="3712723" y="3605925"/>
+            <a:ext cx="356681" cy="178340"/>
           </a:xfrm>
           <a:prstGeom prst="rect">
             <a:avLst/>
@@ -2830,8 +2438,8 @@
         </p:nvSpPr>
         <p:spPr>
           <a:xfrm>
-            <a:off x="4961106" y="3659627"/>
-            <a:ext cx="251298" cy="1285266"/>
+            <a:off x="4085617" y="3751817"/>
+            <a:ext cx="194553" cy="1193077"/>
           </a:xfrm>
           <a:prstGeom prst="rect">
             <a:avLst/>
@@ -2844,20 +2452,6 @@
           </a:ln>
           <a:effectLst/>
         </p:spPr>
-        <p:style>
-          <a:lnRef idx="1">
-            <a:schemeClr val="accent1"/>
-          </a:lnRef>
-          <a:fillRef idx="3">
-            <a:schemeClr val="accent1"/>
-          </a:fillRef>
-          <a:effectRef idx="2">
-            <a:schemeClr val="accent1"/>
-          </a:effectRef>
-          <a:fontRef idx="minor">
-            <a:schemeClr val="lt1"/>
-          </a:fontRef>
-        </p:style>
         <p:txBody>
           <a:bodyPr rtlCol="0" anchor="ctr"/>
           <a:lstStyle/>
@@ -2874,8 +2468,8 @@
         </p:nvSpPr>
         <p:spPr>
           <a:xfrm>
-            <a:off x="4961106" y="3206453"/>
-            <a:ext cx="251298" cy="453174"/>
+            <a:off x="4085617" y="3331148"/>
+            <a:ext cx="194553" cy="420669"/>
           </a:xfrm>
           <a:prstGeom prst="rect">
             <a:avLst/>
@@ -2888,20 +2482,6 @@
           </a:ln>
           <a:effectLst/>
         </p:spPr>
-        <p:style>
-          <a:lnRef idx="1">
-            <a:schemeClr val="accent1"/>
-          </a:lnRef>
-          <a:fillRef idx="3">
-            <a:schemeClr val="accent1"/>
-          </a:fillRef>
-          <a:effectRef idx="2">
-            <a:schemeClr val="accent1"/>
-          </a:effectRef>
-          <a:fontRef idx="minor">
-            <a:schemeClr val="lt1"/>
-          </a:fontRef>
-        </p:style>
         <p:txBody>
           <a:bodyPr rtlCol="0" anchor="ctr"/>
           <a:lstStyle/>
@@ -2918,8 +2498,8 @@
         </p:nvSpPr>
         <p:spPr>
           <a:xfrm>
-            <a:off x="4961106" y="3161682"/>
-            <a:ext cx="251298" cy="44771"/>
+            <a:off x="4085617" y="3289588"/>
+            <a:ext cx="194553" cy="41560"/>
           </a:xfrm>
           <a:prstGeom prst="rect">
             <a:avLst/>
@@ -2932,20 +2512,6 @@
           </a:ln>
           <a:effectLst/>
         </p:spPr>
-        <p:style>
-          <a:lnRef idx="1">
-            <a:schemeClr val="accent1"/>
-          </a:lnRef>
-          <a:fillRef idx="3">
-            <a:schemeClr val="accent1"/>
-          </a:fillRef>
-          <a:effectRef idx="2">
-            <a:schemeClr val="accent1"/>
-          </a:effectRef>
-          <a:fontRef idx="minor">
-            <a:schemeClr val="lt1"/>
-          </a:fontRef>
-        </p:style>
         <p:txBody>
           <a:bodyPr rtlCol="0" anchor="ctr"/>
           <a:lstStyle/>
@@ -2962,8 +2528,8 @@
         </p:nvSpPr>
         <p:spPr>
           <a:xfrm>
-            <a:off x="4896255" y="2950916"/>
-            <a:ext cx="381000" cy="178340"/>
+            <a:off x="4004553" y="3078822"/>
+            <a:ext cx="356681" cy="178340"/>
           </a:xfrm>
           <a:prstGeom prst="rect">
             <a:avLst/>
@@ -3001,8 +2567,8 @@
         </p:nvSpPr>
         <p:spPr>
           <a:xfrm>
-            <a:off x="5325894" y="3638880"/>
-            <a:ext cx="251298" cy="1306014"/>
+            <a:off x="4377447" y="3732557"/>
+            <a:ext cx="194553" cy="1212337"/>
           </a:xfrm>
           <a:prstGeom prst="rect">
             <a:avLst/>
@@ -3015,20 +2581,6 @@
           </a:ln>
           <a:effectLst/>
         </p:spPr>
-        <p:style>
-          <a:lnRef idx="1">
-            <a:schemeClr val="accent1"/>
-          </a:lnRef>
-          <a:fillRef idx="3">
-            <a:schemeClr val="accent1"/>
-          </a:fillRef>
-          <a:effectRef idx="2">
-            <a:schemeClr val="accent1"/>
-          </a:effectRef>
-          <a:fontRef idx="minor">
-            <a:schemeClr val="lt1"/>
-          </a:fontRef>
-        </p:style>
         <p:txBody>
           <a:bodyPr rtlCol="0" anchor="ctr"/>
           <a:lstStyle/>
@@ -3045,8 +2597,8 @@
         </p:nvSpPr>
         <p:spPr>
           <a:xfrm>
-            <a:off x="5325894" y="3342952"/>
-            <a:ext cx="251298" cy="295928"/>
+            <a:off x="4377447" y="3457855"/>
+            <a:ext cx="194553" cy="274702"/>
           </a:xfrm>
           <a:prstGeom prst="rect">
             <a:avLst/>
@@ -3059,20 +2611,6 @@
           </a:ln>
           <a:effectLst/>
         </p:spPr>
-        <p:style>
-          <a:lnRef idx="1">
-            <a:schemeClr val="accent1"/>
-          </a:lnRef>
-          <a:fillRef idx="3">
-            <a:schemeClr val="accent1"/>
-          </a:fillRef>
-          <a:effectRef idx="2">
-            <a:schemeClr val="accent1"/>
-          </a:effectRef>
-          <a:fontRef idx="minor">
-            <a:schemeClr val="lt1"/>
-          </a:fontRef>
-        </p:style>
         <p:txBody>
           <a:bodyPr rtlCol="0" anchor="ctr"/>
           <a:lstStyle/>
@@ -3089,8 +2627,8 @@
         </p:nvSpPr>
         <p:spPr>
           <a:xfrm>
-            <a:off x="5325894" y="3263237"/>
-            <a:ext cx="251298" cy="79715"/>
+            <a:off x="4377447" y="3383858"/>
+            <a:ext cx="194553" cy="73997"/>
           </a:xfrm>
           <a:prstGeom prst="rect">
             <a:avLst/>
@@ -3103,20 +2641,6 @@
           </a:ln>
           <a:effectLst/>
         </p:spPr>
-        <p:style>
-          <a:lnRef idx="1">
-            <a:schemeClr val="accent1"/>
-          </a:lnRef>
-          <a:fillRef idx="3">
-            <a:schemeClr val="accent1"/>
-          </a:fillRef>
-          <a:effectRef idx="2">
-            <a:schemeClr val="accent1"/>
-          </a:effectRef>
-          <a:fontRef idx="minor">
-            <a:schemeClr val="lt1"/>
-          </a:fontRef>
-        </p:style>
         <p:txBody>
           <a:bodyPr rtlCol="0" anchor="ctr"/>
           <a:lstStyle/>
@@ -3133,8 +2657,8 @@
         </p:nvSpPr>
         <p:spPr>
           <a:xfrm>
-            <a:off x="5261043" y="3052471"/>
-            <a:ext cx="381000" cy="178340"/>
+            <a:off x="4296383" y="3173092"/>
+            <a:ext cx="356681" cy="178340"/>
           </a:xfrm>
           <a:prstGeom prst="rect">
             <a:avLst/>
@@ -3172,8 +2696,8 @@
         </p:nvSpPr>
         <p:spPr>
           <a:xfrm>
-            <a:off x="5690681" y="3743710"/>
-            <a:ext cx="251298" cy="1201184"/>
+            <a:off x="4669277" y="3829868"/>
+            <a:ext cx="194553" cy="1115025"/>
           </a:xfrm>
           <a:prstGeom prst="rect">
             <a:avLst/>
@@ -3186,20 +2710,6 @@
           </a:ln>
           <a:effectLst/>
         </p:spPr>
-        <p:style>
-          <a:lnRef idx="1">
-            <a:schemeClr val="accent1"/>
-          </a:lnRef>
-          <a:fillRef idx="3">
-            <a:schemeClr val="accent1"/>
-          </a:fillRef>
-          <a:effectRef idx="2">
-            <a:schemeClr val="accent1"/>
-          </a:effectRef>
-          <a:fontRef idx="minor">
-            <a:schemeClr val="lt1"/>
-          </a:fontRef>
-        </p:style>
         <p:txBody>
           <a:bodyPr rtlCol="0" anchor="ctr"/>
           <a:lstStyle/>
@@ -3216,8 +2726,8 @@
         </p:nvSpPr>
         <p:spPr>
           <a:xfrm>
-            <a:off x="5690681" y="3382263"/>
-            <a:ext cx="251298" cy="361447"/>
+            <a:off x="4669277" y="3494347"/>
+            <a:ext cx="194553" cy="335521"/>
           </a:xfrm>
           <a:prstGeom prst="rect">
             <a:avLst/>
@@ -3230,20 +2740,6 @@
           </a:ln>
           <a:effectLst/>
         </p:spPr>
-        <p:style>
-          <a:lnRef idx="1">
-            <a:schemeClr val="accent1"/>
-          </a:lnRef>
-          <a:fillRef idx="3">
-            <a:schemeClr val="accent1"/>
-          </a:fillRef>
-          <a:effectRef idx="2">
-            <a:schemeClr val="accent1"/>
-          </a:effectRef>
-          <a:fontRef idx="minor">
-            <a:schemeClr val="lt1"/>
-          </a:fontRef>
-        </p:style>
         <p:txBody>
           <a:bodyPr rtlCol="0" anchor="ctr"/>
           <a:lstStyle/>
@@ -3260,8 +2756,8 @@
         </p:nvSpPr>
         <p:spPr>
           <a:xfrm>
-            <a:off x="5690681" y="3350595"/>
-            <a:ext cx="251298" cy="31668"/>
+            <a:off x="4669277" y="3464951"/>
+            <a:ext cx="194553" cy="29396"/>
           </a:xfrm>
           <a:prstGeom prst="rect">
             <a:avLst/>
@@ -3274,20 +2770,6 @@
           </a:ln>
           <a:effectLst/>
         </p:spPr>
-        <p:style>
-          <a:lnRef idx="1">
-            <a:schemeClr val="accent1"/>
-          </a:lnRef>
-          <a:fillRef idx="3">
-            <a:schemeClr val="accent1"/>
-          </a:fillRef>
-          <a:effectRef idx="2">
-            <a:schemeClr val="accent1"/>
-          </a:effectRef>
-          <a:fontRef idx="minor">
-            <a:schemeClr val="lt1"/>
-          </a:fontRef>
-        </p:style>
         <p:txBody>
           <a:bodyPr rtlCol="0" anchor="ctr"/>
           <a:lstStyle/>
@@ -3304,8 +2786,8 @@
         </p:nvSpPr>
         <p:spPr>
           <a:xfrm>
-            <a:off x="5625830" y="3139830"/>
-            <a:ext cx="381000" cy="178340"/>
+            <a:off x="4588213" y="3254185"/>
+            <a:ext cx="356681" cy="178340"/>
           </a:xfrm>
           <a:prstGeom prst="rect">
             <a:avLst/>
@@ -3343,8 +2825,8 @@
         </p:nvSpPr>
         <p:spPr>
           <a:xfrm>
-            <a:off x="6055468" y="3356055"/>
-            <a:ext cx="251298" cy="1588838"/>
+            <a:off x="4961106" y="3470019"/>
+            <a:ext cx="194553" cy="1474874"/>
           </a:xfrm>
           <a:prstGeom prst="rect">
             <a:avLst/>
@@ -3357,20 +2839,6 @@
           </a:ln>
           <a:effectLst/>
         </p:spPr>
-        <p:style>
-          <a:lnRef idx="1">
-            <a:schemeClr val="accent1"/>
-          </a:lnRef>
-          <a:fillRef idx="3">
-            <a:schemeClr val="accent1"/>
-          </a:fillRef>
-          <a:effectRef idx="2">
-            <a:schemeClr val="accent1"/>
-          </a:effectRef>
-          <a:fontRef idx="minor">
-            <a:schemeClr val="lt1"/>
-          </a:fontRef>
-        </p:style>
         <p:txBody>
           <a:bodyPr rtlCol="0" anchor="ctr"/>
           <a:lstStyle/>
@@ -3387,8 +2855,8 @@
         </p:nvSpPr>
         <p:spPr>
           <a:xfrm>
-            <a:off x="6055468" y="2957481"/>
-            <a:ext cx="251298" cy="398575"/>
+            <a:off x="4961106" y="3100034"/>
+            <a:ext cx="194553" cy="369986"/>
           </a:xfrm>
           <a:prstGeom prst="rect">
             <a:avLst/>
@@ -3401,20 +2869,6 @@
           </a:ln>
           <a:effectLst/>
         </p:spPr>
-        <p:style>
-          <a:lnRef idx="1">
-            <a:schemeClr val="accent1"/>
-          </a:lnRef>
-          <a:fillRef idx="3">
-            <a:schemeClr val="accent1"/>
-          </a:fillRef>
-          <a:effectRef idx="2">
-            <a:schemeClr val="accent1"/>
-          </a:effectRef>
-          <a:fontRef idx="minor">
-            <a:schemeClr val="lt1"/>
-          </a:fontRef>
-        </p:style>
         <p:txBody>
           <a:bodyPr rtlCol="0" anchor="ctr"/>
           <a:lstStyle/>
@@ -3431,8 +2885,8 @@
         </p:nvSpPr>
         <p:spPr>
           <a:xfrm>
-            <a:off x="6055468" y="2895238"/>
-            <a:ext cx="251298" cy="62243"/>
+            <a:off x="4961106" y="3042255"/>
+            <a:ext cx="194553" cy="57779"/>
           </a:xfrm>
           <a:prstGeom prst="rect">
             <a:avLst/>
@@ -3445,20 +2899,6 @@
           </a:ln>
           <a:effectLst/>
         </p:spPr>
-        <p:style>
-          <a:lnRef idx="1">
-            <a:schemeClr val="accent1"/>
-          </a:lnRef>
-          <a:fillRef idx="3">
-            <a:schemeClr val="accent1"/>
-          </a:fillRef>
-          <a:effectRef idx="2">
-            <a:schemeClr val="accent1"/>
-          </a:effectRef>
-          <a:fontRef idx="minor">
-            <a:schemeClr val="lt1"/>
-          </a:fontRef>
-        </p:style>
         <p:txBody>
           <a:bodyPr rtlCol="0" anchor="ctr"/>
           <a:lstStyle/>
@@ -3475,8 +2915,8 @@
         </p:nvSpPr>
         <p:spPr>
           <a:xfrm>
-            <a:off x="5990617" y="2684472"/>
-            <a:ext cx="381000" cy="178340"/>
+            <a:off x="4880043" y="2831489"/>
+            <a:ext cx="356681" cy="178340"/>
           </a:xfrm>
           <a:prstGeom prst="rect">
             <a:avLst/>
@@ -3514,8 +2954,8 @@
         </p:nvSpPr>
         <p:spPr>
           <a:xfrm>
-            <a:off x="6420255" y="3077599"/>
-            <a:ext cx="251298" cy="1867294"/>
+            <a:off x="5252936" y="3211536"/>
+            <a:ext cx="194553" cy="1733358"/>
           </a:xfrm>
           <a:prstGeom prst="rect">
             <a:avLst/>
@@ -3528,20 +2968,6 @@
           </a:ln>
           <a:effectLst/>
         </p:spPr>
-        <p:style>
-          <a:lnRef idx="1">
-            <a:schemeClr val="accent1"/>
-          </a:lnRef>
-          <a:fillRef idx="3">
-            <a:schemeClr val="accent1"/>
-          </a:fillRef>
-          <a:effectRef idx="2">
-            <a:schemeClr val="accent1"/>
-          </a:effectRef>
-          <a:fontRef idx="minor">
-            <a:schemeClr val="lt1"/>
-          </a:fontRef>
-        </p:style>
         <p:txBody>
           <a:bodyPr rtlCol="0" anchor="ctr"/>
           <a:lstStyle/>
@@ -3558,8 +2984,8 @@
         </p:nvSpPr>
         <p:spPr>
           <a:xfrm>
-            <a:off x="6420255" y="2462812"/>
-            <a:ext cx="251298" cy="614788"/>
+            <a:off x="5252936" y="2640846"/>
+            <a:ext cx="194553" cy="570690"/>
           </a:xfrm>
           <a:prstGeom prst="rect">
             <a:avLst/>
@@ -3572,20 +2998,6 @@
           </a:ln>
           <a:effectLst/>
         </p:spPr>
-        <p:style>
-          <a:lnRef idx="1">
-            <a:schemeClr val="accent1"/>
-          </a:lnRef>
-          <a:fillRef idx="3">
-            <a:schemeClr val="accent1"/>
-          </a:fillRef>
-          <a:effectRef idx="2">
-            <a:schemeClr val="accent1"/>
-          </a:effectRef>
-          <a:fontRef idx="minor">
-            <a:schemeClr val="lt1"/>
-          </a:fontRef>
-        </p:style>
         <p:txBody>
           <a:bodyPr rtlCol="0" anchor="ctr"/>
           <a:lstStyle/>
@@ -3602,8 +3014,8 @@
         </p:nvSpPr>
         <p:spPr>
           <a:xfrm>
-            <a:off x="6420255" y="2344877"/>
-            <a:ext cx="251298" cy="117934"/>
+            <a:off x="5252936" y="2531371"/>
+            <a:ext cx="194553" cy="109475"/>
           </a:xfrm>
           <a:prstGeom prst="rect">
             <a:avLst/>
@@ -3616,20 +3028,6 @@
           </a:ln>
           <a:effectLst/>
         </p:spPr>
-        <p:style>
-          <a:lnRef idx="1">
-            <a:schemeClr val="accent1"/>
-          </a:lnRef>
-          <a:fillRef idx="3">
-            <a:schemeClr val="accent1"/>
-          </a:fillRef>
-          <a:effectRef idx="2">
-            <a:schemeClr val="accent1"/>
-          </a:effectRef>
-          <a:fontRef idx="minor">
-            <a:schemeClr val="lt1"/>
-          </a:fontRef>
-        </p:style>
         <p:txBody>
           <a:bodyPr rtlCol="0" anchor="ctr"/>
           <a:lstStyle/>
@@ -3646,8 +3044,8 @@
         </p:nvSpPr>
         <p:spPr>
           <a:xfrm>
-            <a:off x="6355404" y="2134111"/>
-            <a:ext cx="381000" cy="178340"/>
+            <a:off x="5171872" y="2320605"/>
+            <a:ext cx="356681" cy="178340"/>
           </a:xfrm>
           <a:prstGeom prst="rect">
             <a:avLst/>
@@ -3685,8 +3083,8 @@
         </p:nvSpPr>
         <p:spPr>
           <a:xfrm>
-            <a:off x="6785043" y="3544969"/>
-            <a:ext cx="251298" cy="1399925"/>
+            <a:off x="5544766" y="3645382"/>
+            <a:ext cx="194553" cy="1299511"/>
           </a:xfrm>
           <a:prstGeom prst="rect">
             <a:avLst/>
@@ -3699,20 +3097,6 @@
           </a:ln>
           <a:effectLst/>
         </p:spPr>
-        <p:style>
-          <a:lnRef idx="1">
-            <a:schemeClr val="accent1"/>
-          </a:lnRef>
-          <a:fillRef idx="3">
-            <a:schemeClr val="accent1"/>
-          </a:fillRef>
-          <a:effectRef idx="2">
-            <a:schemeClr val="accent1"/>
-          </a:effectRef>
-          <a:fontRef idx="minor">
-            <a:schemeClr val="lt1"/>
-          </a:fontRef>
-        </p:style>
         <p:txBody>
           <a:bodyPr rtlCol="0" anchor="ctr"/>
           <a:lstStyle/>
@@ -3729,8 +3113,8 @@
         </p:nvSpPr>
         <p:spPr>
           <a:xfrm>
-            <a:off x="6785043" y="3155130"/>
-            <a:ext cx="251298" cy="389839"/>
+            <a:off x="5544766" y="3283506"/>
+            <a:ext cx="194553" cy="361876"/>
           </a:xfrm>
           <a:prstGeom prst="rect">
             <a:avLst/>
@@ -3743,20 +3127,6 @@
           </a:ln>
           <a:effectLst/>
         </p:spPr>
-        <p:style>
-          <a:lnRef idx="1">
-            <a:schemeClr val="accent1"/>
-          </a:lnRef>
-          <a:fillRef idx="3">
-            <a:schemeClr val="accent1"/>
-          </a:fillRef>
-          <a:effectRef idx="2">
-            <a:schemeClr val="accent1"/>
-          </a:effectRef>
-          <a:fontRef idx="minor">
-            <a:schemeClr val="lt1"/>
-          </a:fontRef>
-        </p:style>
         <p:txBody>
           <a:bodyPr rtlCol="0" anchor="ctr"/>
           <a:lstStyle/>
@@ -3773,8 +3143,8 @@
         </p:nvSpPr>
         <p:spPr>
           <a:xfrm>
-            <a:off x="6785043" y="3035012"/>
-            <a:ext cx="251298" cy="120118"/>
+            <a:off x="5544766" y="3172003"/>
+            <a:ext cx="194553" cy="111503"/>
           </a:xfrm>
           <a:prstGeom prst="rect">
             <a:avLst/>
@@ -3787,20 +3157,6 @@
           </a:ln>
           <a:effectLst/>
         </p:spPr>
-        <p:style>
-          <a:lnRef idx="1">
-            <a:schemeClr val="accent1"/>
-          </a:lnRef>
-          <a:fillRef idx="3">
-            <a:schemeClr val="accent1"/>
-          </a:fillRef>
-          <a:effectRef idx="2">
-            <a:schemeClr val="accent1"/>
-          </a:effectRef>
-          <a:fontRef idx="minor">
-            <a:schemeClr val="lt1"/>
-          </a:fontRef>
-        </p:style>
         <p:txBody>
           <a:bodyPr rtlCol="0" anchor="ctr"/>
           <a:lstStyle/>
@@ -3817,8 +3173,8 @@
         </p:nvSpPr>
         <p:spPr>
           <a:xfrm>
-            <a:off x="6720191" y="2824246"/>
-            <a:ext cx="381000" cy="178340"/>
+            <a:off x="5463702" y="2961237"/>
+            <a:ext cx="356681" cy="178340"/>
           </a:xfrm>
           <a:prstGeom prst="rect">
             <a:avLst/>
@@ -3856,8 +3212,8 @@
         </p:nvSpPr>
         <p:spPr>
           <a:xfrm>
-            <a:off x="7149830" y="3654167"/>
-            <a:ext cx="251298" cy="1290726"/>
+            <a:off x="5836596" y="3660233"/>
+            <a:ext cx="194553" cy="1284661"/>
           </a:xfrm>
           <a:prstGeom prst="rect">
             <a:avLst/>
@@ -3870,20 +3226,6 @@
           </a:ln>
           <a:effectLst/>
         </p:spPr>
-        <p:style>
-          <a:lnRef idx="1">
-            <a:schemeClr val="accent1"/>
-          </a:lnRef>
-          <a:fillRef idx="3">
-            <a:schemeClr val="accent1"/>
-          </a:fillRef>
-          <a:effectRef idx="2">
-            <a:schemeClr val="accent1"/>
-          </a:effectRef>
-          <a:fontRef idx="minor">
-            <a:schemeClr val="lt1"/>
-          </a:fontRef>
-        </p:style>
         <p:txBody>
           <a:bodyPr rtlCol="0" anchor="ctr"/>
           <a:lstStyle/>
@@ -3900,8 +3242,8 @@
         </p:nvSpPr>
         <p:spPr>
           <a:xfrm>
-            <a:off x="7149830" y="3205361"/>
-            <a:ext cx="251298" cy="448806"/>
+            <a:off x="5836596" y="3213536"/>
+            <a:ext cx="194553" cy="446697"/>
           </a:xfrm>
           <a:prstGeom prst="rect">
             <a:avLst/>
@@ -3914,20 +3256,6 @@
           </a:ln>
           <a:effectLst/>
         </p:spPr>
-        <p:style>
-          <a:lnRef idx="1">
-            <a:schemeClr val="accent1"/>
-          </a:lnRef>
-          <a:fillRef idx="3">
-            <a:schemeClr val="accent1"/>
-          </a:fillRef>
-          <a:effectRef idx="2">
-            <a:schemeClr val="accent1"/>
-          </a:effectRef>
-          <a:fontRef idx="minor">
-            <a:schemeClr val="lt1"/>
-          </a:fontRef>
-        </p:style>
         <p:txBody>
           <a:bodyPr rtlCol="0" anchor="ctr"/>
           <a:lstStyle/>
@@ -3944,8 +3272,8 @@
         </p:nvSpPr>
         <p:spPr>
           <a:xfrm>
-            <a:off x="7149830" y="3124555"/>
-            <a:ext cx="251298" cy="80807"/>
+            <a:off x="5836596" y="3133109"/>
+            <a:ext cx="194553" cy="80427"/>
           </a:xfrm>
           <a:prstGeom prst="rect">
             <a:avLst/>
@@ -3958,20 +3286,6 @@
           </a:ln>
           <a:effectLst/>
         </p:spPr>
-        <p:style>
-          <a:lnRef idx="1">
-            <a:schemeClr val="accent1"/>
-          </a:lnRef>
-          <a:fillRef idx="3">
-            <a:schemeClr val="accent1"/>
-          </a:fillRef>
-          <a:effectRef idx="2">
-            <a:schemeClr val="accent1"/>
-          </a:effectRef>
-          <a:fontRef idx="minor">
-            <a:schemeClr val="lt1"/>
-          </a:fontRef>
-        </p:style>
         <p:txBody>
           <a:bodyPr rtlCol="0" anchor="ctr"/>
           <a:lstStyle/>
@@ -3988,8 +3302,8 @@
         </p:nvSpPr>
         <p:spPr>
           <a:xfrm>
-            <a:off x="7084979" y="2913789"/>
-            <a:ext cx="381000" cy="178340"/>
+            <a:off x="5755532" y="2922343"/>
+            <a:ext cx="356681" cy="178340"/>
           </a:xfrm>
           <a:prstGeom prst="rect">
             <a:avLst/>
@@ -4014,7 +3328,7 @@
                 <a:ea typeface="Outfit"/>
                 <a:cs typeface="Outfit"/>
               </a:rPr>
-              <a:t>167</a:t>
+              <a:t>179</a:t>
             </a:r>
           </a:p>
         </p:txBody>
@@ -4027,8 +3341,8 @@
         </p:nvSpPr>
         <p:spPr>
           <a:xfrm>
-            <a:off x="7514617" y="3401919"/>
-            <a:ext cx="251298" cy="1542975"/>
+            <a:off x="6128426" y="3410499"/>
+            <a:ext cx="194553" cy="1534395"/>
           </a:xfrm>
           <a:prstGeom prst="rect">
             <a:avLst/>
@@ -4041,20 +3355,6 @@
           </a:ln>
           <a:effectLst/>
         </p:spPr>
-        <p:style>
-          <a:lnRef idx="1">
-            <a:schemeClr val="accent1"/>
-          </a:lnRef>
-          <a:fillRef idx="3">
-            <a:schemeClr val="accent1"/>
-          </a:fillRef>
-          <a:effectRef idx="2">
-            <a:schemeClr val="accent1"/>
-          </a:effectRef>
-          <a:fontRef idx="minor">
-            <a:schemeClr val="lt1"/>
-          </a:fontRef>
-        </p:style>
         <p:txBody>
           <a:bodyPr rtlCol="0" anchor="ctr"/>
           <a:lstStyle/>
@@ -4071,8 +3371,8 @@
         </p:nvSpPr>
         <p:spPr>
           <a:xfrm>
-            <a:off x="7514617" y="2996792"/>
-            <a:ext cx="251298" cy="405126"/>
+            <a:off x="6128426" y="3007625"/>
+            <a:ext cx="194553" cy="402874"/>
           </a:xfrm>
           <a:prstGeom prst="rect">
             <a:avLst/>
@@ -4085,20 +3385,6 @@
           </a:ln>
           <a:effectLst/>
         </p:spPr>
-        <p:style>
-          <a:lnRef idx="1">
-            <a:schemeClr val="accent1"/>
-          </a:lnRef>
-          <a:fillRef idx="3">
-            <a:schemeClr val="accent1"/>
-          </a:fillRef>
-          <a:effectRef idx="2">
-            <a:schemeClr val="accent1"/>
-          </a:effectRef>
-          <a:fontRef idx="minor">
-            <a:schemeClr val="lt1"/>
-          </a:fontRef>
-        </p:style>
         <p:txBody>
           <a:bodyPr rtlCol="0" anchor="ctr"/>
           <a:lstStyle/>
@@ -4115,8 +3401,8 @@
         </p:nvSpPr>
         <p:spPr>
           <a:xfrm>
-            <a:off x="7514617" y="2888686"/>
-            <a:ext cx="251298" cy="108107"/>
+            <a:off x="6128426" y="2900120"/>
+            <a:ext cx="194553" cy="107505"/>
           </a:xfrm>
           <a:prstGeom prst="rect">
             <a:avLst/>
@@ -4129,20 +3415,6 @@
           </a:ln>
           <a:effectLst/>
         </p:spPr>
-        <p:style>
-          <a:lnRef idx="1">
-            <a:schemeClr val="accent1"/>
-          </a:lnRef>
-          <a:fillRef idx="3">
-            <a:schemeClr val="accent1"/>
-          </a:fillRef>
-          <a:effectRef idx="2">
-            <a:schemeClr val="accent1"/>
-          </a:effectRef>
-          <a:fontRef idx="minor">
-            <a:schemeClr val="lt1"/>
-          </a:fontRef>
-        </p:style>
         <p:txBody>
           <a:bodyPr rtlCol="0" anchor="ctr"/>
           <a:lstStyle/>
@@ -4159,8 +3431,8 @@
         </p:nvSpPr>
         <p:spPr>
           <a:xfrm>
-            <a:off x="7449766" y="2677920"/>
-            <a:ext cx="381000" cy="178340"/>
+            <a:off x="6047362" y="2689354"/>
+            <a:ext cx="356681" cy="178340"/>
           </a:xfrm>
           <a:prstGeom prst="rect">
             <a:avLst/>
@@ -4185,7 +3457,7 @@
                 <a:ea typeface="Outfit"/>
                 <a:cs typeface="Outfit"/>
               </a:rPr>
-              <a:t>188</a:t>
+              <a:t>202</a:t>
             </a:r>
           </a:p>
         </p:txBody>
@@ -4198,8 +3470,8 @@
         </p:nvSpPr>
         <p:spPr>
           <a:xfrm>
-            <a:off x="7879404" y="3066679"/>
-            <a:ext cx="251298" cy="1878214"/>
+            <a:off x="6420255" y="3066679"/>
+            <a:ext cx="194553" cy="1878214"/>
           </a:xfrm>
           <a:prstGeom prst="rect">
             <a:avLst/>
@@ -4212,20 +3484,6 @@
           </a:ln>
           <a:effectLst/>
         </p:spPr>
-        <p:style>
-          <a:lnRef idx="1">
-            <a:schemeClr val="accent1"/>
-          </a:lnRef>
-          <a:fillRef idx="3">
-            <a:schemeClr val="accent1"/>
-          </a:fillRef>
-          <a:effectRef idx="2">
-            <a:schemeClr val="accent1"/>
-          </a:effectRef>
-          <a:fontRef idx="minor">
-            <a:schemeClr val="lt1"/>
-          </a:fontRef>
-        </p:style>
         <p:txBody>
           <a:bodyPr rtlCol="0" anchor="ctr"/>
           <a:lstStyle/>
@@ -4242,8 +3500,8 @@
         </p:nvSpPr>
         <p:spPr>
           <a:xfrm>
-            <a:off x="7879404" y="2340509"/>
-            <a:ext cx="251298" cy="726170"/>
+            <a:off x="6420255" y="2340509"/>
+            <a:ext cx="194553" cy="726170"/>
           </a:xfrm>
           <a:prstGeom prst="rect">
             <a:avLst/>
@@ -4256,20 +3514,6 @@
           </a:ln>
           <a:effectLst/>
         </p:spPr>
-        <p:style>
-          <a:lnRef idx="1">
-            <a:schemeClr val="accent1"/>
-          </a:lnRef>
-          <a:fillRef idx="3">
-            <a:schemeClr val="accent1"/>
-          </a:fillRef>
-          <a:effectRef idx="2">
-            <a:schemeClr val="accent1"/>
-          </a:effectRef>
-          <a:fontRef idx="minor">
-            <a:schemeClr val="lt1"/>
-          </a:fontRef>
-        </p:style>
         <p:txBody>
           <a:bodyPr rtlCol="0" anchor="ctr"/>
           <a:lstStyle/>
@@ -4286,8 +3530,8 @@
         </p:nvSpPr>
         <p:spPr>
           <a:xfrm>
-            <a:off x="7879404" y="2188723"/>
-            <a:ext cx="251298" cy="151786"/>
+            <a:off x="6420255" y="2188723"/>
+            <a:ext cx="194553" cy="151786"/>
           </a:xfrm>
           <a:prstGeom prst="rect">
             <a:avLst/>
@@ -4300,20 +3544,6 @@
           </a:ln>
           <a:effectLst/>
         </p:spPr>
-        <p:style>
-          <a:lnRef idx="1">
-            <a:schemeClr val="accent1"/>
-          </a:lnRef>
-          <a:fillRef idx="3">
-            <a:schemeClr val="accent1"/>
-          </a:fillRef>
-          <a:effectRef idx="2">
-            <a:schemeClr val="accent1"/>
-          </a:effectRef>
-          <a:fontRef idx="minor">
-            <a:schemeClr val="lt1"/>
-          </a:fontRef>
-        </p:style>
         <p:txBody>
           <a:bodyPr rtlCol="0" anchor="ctr"/>
           <a:lstStyle/>
@@ -4330,8 +3560,8 @@
         </p:nvSpPr>
         <p:spPr>
           <a:xfrm>
-            <a:off x="7814553" y="1977957"/>
-            <a:ext cx="381000" cy="178340"/>
+            <a:off x="6339191" y="1977957"/>
+            <a:ext cx="356681" cy="178340"/>
           </a:xfrm>
           <a:prstGeom prst="rect">
             <a:avLst/>
@@ -4356,7 +3586,7 @@
                 <a:ea typeface="Outfit"/>
                 <a:cs typeface="Outfit"/>
               </a:rPr>
-              <a:t>252</a:t>
+              <a:t>272</a:t>
             </a:r>
           </a:p>
         </p:txBody>
@@ -4369,8 +3599,8 @@
         </p:nvSpPr>
         <p:spPr>
           <a:xfrm>
-            <a:off x="8244191" y="3506749"/>
-            <a:ext cx="251298" cy="1438144"/>
+            <a:off x="6712085" y="3557815"/>
+            <a:ext cx="194553" cy="1387078"/>
           </a:xfrm>
           <a:prstGeom prst="rect">
             <a:avLst/>
@@ -4383,20 +3613,6 @@
           </a:ln>
           <a:effectLst/>
         </p:spPr>
-        <p:style>
-          <a:lnRef idx="1">
-            <a:schemeClr val="accent1"/>
-          </a:lnRef>
-          <a:fillRef idx="3">
-            <a:schemeClr val="accent1"/>
-          </a:fillRef>
-          <a:effectRef idx="2">
-            <a:schemeClr val="accent1"/>
-          </a:effectRef>
-          <a:fontRef idx="minor">
-            <a:schemeClr val="lt1"/>
-          </a:fontRef>
-        </p:style>
         <p:txBody>
           <a:bodyPr rtlCol="0" anchor="ctr"/>
           <a:lstStyle/>
@@ -4413,8 +3629,8 @@
         </p:nvSpPr>
         <p:spPr>
           <a:xfrm>
-            <a:off x="8244191" y="3203177"/>
-            <a:ext cx="251298" cy="303572"/>
+            <a:off x="6712085" y="3265023"/>
+            <a:ext cx="194553" cy="292793"/>
           </a:xfrm>
           <a:prstGeom prst="rect">
             <a:avLst/>
@@ -4427,20 +3643,6 @@
           </a:ln>
           <a:effectLst/>
         </p:spPr>
-        <p:style>
-          <a:lnRef idx="1">
-            <a:schemeClr val="accent1"/>
-          </a:lnRef>
-          <a:fillRef idx="3">
-            <a:schemeClr val="accent1"/>
-          </a:fillRef>
-          <a:effectRef idx="2">
-            <a:schemeClr val="accent1"/>
-          </a:effectRef>
-          <a:fontRef idx="minor">
-            <a:schemeClr val="lt1"/>
-          </a:fontRef>
-        </p:style>
         <p:txBody>
           <a:bodyPr rtlCol="0" anchor="ctr"/>
           <a:lstStyle/>
@@ -4457,8 +3659,8 @@
         </p:nvSpPr>
         <p:spPr>
           <a:xfrm>
-            <a:off x="8244191" y="3031736"/>
-            <a:ext cx="251298" cy="171442"/>
+            <a:off x="6712085" y="3099669"/>
+            <a:ext cx="194553" cy="165354"/>
           </a:xfrm>
           <a:prstGeom prst="rect">
             <a:avLst/>
@@ -4471,20 +3673,6 @@
           </a:ln>
           <a:effectLst/>
         </p:spPr>
-        <p:style>
-          <a:lnRef idx="1">
-            <a:schemeClr val="accent1"/>
-          </a:lnRef>
-          <a:fillRef idx="3">
-            <a:schemeClr val="accent1"/>
-          </a:fillRef>
-          <a:effectRef idx="2">
-            <a:schemeClr val="accent1"/>
-          </a:effectRef>
-          <a:fontRef idx="minor">
-            <a:schemeClr val="lt1"/>
-          </a:fontRef>
-        </p:style>
         <p:txBody>
           <a:bodyPr rtlCol="0" anchor="ctr"/>
           <a:lstStyle/>
@@ -4501,8 +3689,8 @@
         </p:nvSpPr>
         <p:spPr>
           <a:xfrm>
-            <a:off x="8179340" y="2820970"/>
-            <a:ext cx="381000" cy="178340"/>
+            <a:off x="6631021" y="2888903"/>
+            <a:ext cx="356681" cy="178340"/>
           </a:xfrm>
           <a:prstGeom prst="rect">
             <a:avLst/>
@@ -4527,7 +3715,7 @@
                 <a:ea typeface="Outfit"/>
                 <a:cs typeface="Outfit"/>
               </a:rPr>
-              <a:t>175</a:t>
+              <a:t>182</a:t>
             </a:r>
           </a:p>
         </p:txBody>
@@ -4541,7 +3729,7 @@
         <p:spPr>
           <a:xfrm>
             <a:off x="518809" y="4944894"/>
-            <a:ext cx="8041531" cy="0"/>
+            <a:ext cx="6436468" cy="0"/>
           </a:xfrm>
           <a:prstGeom prst="line">
             <a:avLst/>
@@ -4552,20 +3740,6 @@
             </a:solidFill>
           </a:ln>
         </p:spPr>
-        <p:style>
-          <a:lnRef idx="2">
-            <a:schemeClr val="accent1"/>
-          </a:lnRef>
-          <a:fillRef idx="0">
-            <a:schemeClr val="accent1"/>
-          </a:fillRef>
-          <a:effectRef idx="1">
-            <a:schemeClr val="accent1"/>
-          </a:effectRef>
-          <a:fontRef idx="minor">
-            <a:schemeClr val="tx1"/>
-          </a:fontRef>
-        </p:style>
       </p:cxnSp>
       <p:sp>
         <p:nvSpPr>
@@ -4576,7 +3750,7 @@
         <p:spPr>
           <a:xfrm>
             <a:off x="526915" y="5042170"/>
-            <a:ext cx="729574" cy="226979"/>
+            <a:ext cx="583660" cy="226979"/>
           </a:xfrm>
           <a:prstGeom prst="rect">
             <a:avLst/>
@@ -4614,42 +3788,7 @@
         </p:nvCxnSpPr>
         <p:spPr>
           <a:xfrm>
-            <a:off x="1256489" y="5009745"/>
-            <a:ext cx="811" cy="0"/>
-          </a:xfrm>
-          <a:prstGeom prst="line">
-            <a:avLst/>
-          </a:prstGeom>
-          <a:ln w="12700">
-            <a:solidFill>
-              <a:srgbClr val="C9CFCF"/>
-            </a:solidFill>
-          </a:ln>
-        </p:spPr>
-        <p:style>
-          <a:lnRef idx="2">
-            <a:schemeClr val="accent1"/>
-          </a:lnRef>
-          <a:fillRef idx="0">
-            <a:schemeClr val="accent1"/>
-          </a:fillRef>
-          <a:effectRef idx="1">
-            <a:schemeClr val="accent1"/>
-          </a:effectRef>
-          <a:fontRef idx="minor">
-            <a:schemeClr val="tx1"/>
-          </a:fontRef>
-        </p:style>
-      </p:cxnSp>
-      <p:cxnSp>
-        <p:nvCxnSpPr>
-          <p:cNvPr id="90" name="Connector 89"/>
-          <p:cNvCxnSpPr/>
-          <p:nvPr/>
-        </p:nvCxnSpPr>
-        <p:spPr>
-          <a:xfrm>
-            <a:off x="1256489" y="4977319"/>
+            <a:off x="1110574" y="4977319"/>
             <a:ext cx="0" cy="291830"/>
           </a:xfrm>
           <a:prstGeom prst="line">
@@ -4661,31 +3800,17 @@
             </a:solidFill>
           </a:ln>
         </p:spPr>
-        <p:style>
-          <a:lnRef idx="2">
-            <a:schemeClr val="accent1"/>
-          </a:lnRef>
-          <a:fillRef idx="0">
-            <a:schemeClr val="accent1"/>
-          </a:fillRef>
-          <a:effectRef idx="1">
-            <a:schemeClr val="accent1"/>
-          </a:effectRef>
-          <a:fontRef idx="minor">
-            <a:schemeClr val="tx1"/>
-          </a:fontRef>
-        </p:style>
       </p:cxnSp>
       <p:sp>
         <p:nvSpPr>
-          <p:cNvPr id="91" name="TextBox 90"/>
-          <p:cNvSpPr txBox="1"/>
-          <p:nvPr/>
-        </p:nvSpPr>
-        <p:spPr>
-          <a:xfrm>
-            <a:off x="1256489" y="5042170"/>
-            <a:ext cx="1459149" cy="226979"/>
+          <p:cNvPr id="90" name="TextBox 89"/>
+          <p:cNvSpPr txBox="1"/>
+          <p:nvPr/>
+        </p:nvSpPr>
+        <p:spPr>
+          <a:xfrm>
+            <a:off x="1110574" y="5042170"/>
+            <a:ext cx="1167319" cy="226979"/>
           </a:xfrm>
           <a:prstGeom prst="rect">
             <a:avLst/>
@@ -4717,48 +3842,13 @@
       </p:sp>
       <p:cxnSp>
         <p:nvCxnSpPr>
-          <p:cNvPr id="92" name="Connector 91"/>
+          <p:cNvPr id="91" name="Connector 90"/>
           <p:cNvCxnSpPr/>
           <p:nvPr/>
         </p:nvCxnSpPr>
         <p:spPr>
           <a:xfrm>
-            <a:off x="2715638" y="5009745"/>
-            <a:ext cx="811" cy="0"/>
-          </a:xfrm>
-          <a:prstGeom prst="line">
-            <a:avLst/>
-          </a:prstGeom>
-          <a:ln w="12700">
-            <a:solidFill>
-              <a:srgbClr val="C9CFCF"/>
-            </a:solidFill>
-          </a:ln>
-        </p:spPr>
-        <p:style>
-          <a:lnRef idx="2">
-            <a:schemeClr val="accent1"/>
-          </a:lnRef>
-          <a:fillRef idx="0">
-            <a:schemeClr val="accent1"/>
-          </a:fillRef>
-          <a:effectRef idx="1">
-            <a:schemeClr val="accent1"/>
-          </a:effectRef>
-          <a:fontRef idx="minor">
-            <a:schemeClr val="tx1"/>
-          </a:fontRef>
-        </p:style>
-      </p:cxnSp>
-      <p:cxnSp>
-        <p:nvCxnSpPr>
-          <p:cNvPr id="93" name="Connector 92"/>
-          <p:cNvCxnSpPr/>
-          <p:nvPr/>
-        </p:nvCxnSpPr>
-        <p:spPr>
-          <a:xfrm>
-            <a:off x="2715638" y="4977319"/>
+            <a:off x="2277894" y="4977319"/>
             <a:ext cx="0" cy="291830"/>
           </a:xfrm>
           <a:prstGeom prst="line">
@@ -4770,31 +3860,17 @@
             </a:solidFill>
           </a:ln>
         </p:spPr>
-        <p:style>
-          <a:lnRef idx="2">
-            <a:schemeClr val="accent1"/>
-          </a:lnRef>
-          <a:fillRef idx="0">
-            <a:schemeClr val="accent1"/>
-          </a:fillRef>
-          <a:effectRef idx="1">
-            <a:schemeClr val="accent1"/>
-          </a:effectRef>
-          <a:fontRef idx="minor">
-            <a:schemeClr val="tx1"/>
-          </a:fontRef>
-        </p:style>
       </p:cxnSp>
       <p:sp>
         <p:nvSpPr>
-          <p:cNvPr id="94" name="TextBox 93"/>
-          <p:cNvSpPr txBox="1"/>
-          <p:nvPr/>
-        </p:nvSpPr>
-        <p:spPr>
-          <a:xfrm>
-            <a:off x="2715638" y="5042170"/>
-            <a:ext cx="1459149" cy="226979"/>
+          <p:cNvPr id="92" name="TextBox 91"/>
+          <p:cNvSpPr txBox="1"/>
+          <p:nvPr/>
+        </p:nvSpPr>
+        <p:spPr>
+          <a:xfrm>
+            <a:off x="2277894" y="5042170"/>
+            <a:ext cx="1167319" cy="226979"/>
           </a:xfrm>
           <a:prstGeom prst="rect">
             <a:avLst/>
@@ -4826,48 +3902,13 @@
       </p:sp>
       <p:cxnSp>
         <p:nvCxnSpPr>
-          <p:cNvPr id="95" name="Connector 94"/>
+          <p:cNvPr id="93" name="Connector 92"/>
           <p:cNvCxnSpPr/>
           <p:nvPr/>
         </p:nvCxnSpPr>
         <p:spPr>
           <a:xfrm>
-            <a:off x="4174787" y="5009745"/>
-            <a:ext cx="811" cy="0"/>
-          </a:xfrm>
-          <a:prstGeom prst="line">
-            <a:avLst/>
-          </a:prstGeom>
-          <a:ln w="12700">
-            <a:solidFill>
-              <a:srgbClr val="C9CFCF"/>
-            </a:solidFill>
-          </a:ln>
-        </p:spPr>
-        <p:style>
-          <a:lnRef idx="2">
-            <a:schemeClr val="accent1"/>
-          </a:lnRef>
-          <a:fillRef idx="0">
-            <a:schemeClr val="accent1"/>
-          </a:fillRef>
-          <a:effectRef idx="1">
-            <a:schemeClr val="accent1"/>
-          </a:effectRef>
-          <a:fontRef idx="minor">
-            <a:schemeClr val="tx1"/>
-          </a:fontRef>
-        </p:style>
-      </p:cxnSp>
-      <p:cxnSp>
-        <p:nvCxnSpPr>
-          <p:cNvPr id="96" name="Connector 95"/>
-          <p:cNvCxnSpPr/>
-          <p:nvPr/>
-        </p:nvCxnSpPr>
-        <p:spPr>
-          <a:xfrm>
-            <a:off x="4174787" y="4977319"/>
+            <a:off x="3445213" y="4977319"/>
             <a:ext cx="0" cy="291830"/>
           </a:xfrm>
           <a:prstGeom prst="line">
@@ -4879,31 +3920,17 @@
             </a:solidFill>
           </a:ln>
         </p:spPr>
-        <p:style>
-          <a:lnRef idx="2">
-            <a:schemeClr val="accent1"/>
-          </a:lnRef>
-          <a:fillRef idx="0">
-            <a:schemeClr val="accent1"/>
-          </a:fillRef>
-          <a:effectRef idx="1">
-            <a:schemeClr val="accent1"/>
-          </a:effectRef>
-          <a:fontRef idx="minor">
-            <a:schemeClr val="tx1"/>
-          </a:fontRef>
-        </p:style>
       </p:cxnSp>
       <p:sp>
         <p:nvSpPr>
-          <p:cNvPr id="97" name="TextBox 96"/>
-          <p:cNvSpPr txBox="1"/>
-          <p:nvPr/>
-        </p:nvSpPr>
-        <p:spPr>
-          <a:xfrm>
-            <a:off x="4174787" y="5042170"/>
-            <a:ext cx="1459149" cy="226979"/>
+          <p:cNvPr id="94" name="TextBox 93"/>
+          <p:cNvSpPr txBox="1"/>
+          <p:nvPr/>
+        </p:nvSpPr>
+        <p:spPr>
+          <a:xfrm>
+            <a:off x="3445213" y="5042170"/>
+            <a:ext cx="1167319" cy="226979"/>
           </a:xfrm>
           <a:prstGeom prst="rect">
             <a:avLst/>
@@ -4935,48 +3962,13 @@
       </p:sp>
       <p:cxnSp>
         <p:nvCxnSpPr>
-          <p:cNvPr id="98" name="Connector 97"/>
+          <p:cNvPr id="95" name="Connector 94"/>
           <p:cNvCxnSpPr/>
           <p:nvPr/>
         </p:nvCxnSpPr>
         <p:spPr>
           <a:xfrm>
-            <a:off x="5633936" y="5009745"/>
-            <a:ext cx="811" cy="0"/>
-          </a:xfrm>
-          <a:prstGeom prst="line">
-            <a:avLst/>
-          </a:prstGeom>
-          <a:ln w="12700">
-            <a:solidFill>
-              <a:srgbClr val="C9CFCF"/>
-            </a:solidFill>
-          </a:ln>
-        </p:spPr>
-        <p:style>
-          <a:lnRef idx="2">
-            <a:schemeClr val="accent1"/>
-          </a:lnRef>
-          <a:fillRef idx="0">
-            <a:schemeClr val="accent1"/>
-          </a:fillRef>
-          <a:effectRef idx="1">
-            <a:schemeClr val="accent1"/>
-          </a:effectRef>
-          <a:fontRef idx="minor">
-            <a:schemeClr val="tx1"/>
-          </a:fontRef>
-        </p:style>
-      </p:cxnSp>
-      <p:cxnSp>
-        <p:nvCxnSpPr>
-          <p:cNvPr id="99" name="Connector 98"/>
-          <p:cNvCxnSpPr/>
-          <p:nvPr/>
-        </p:nvCxnSpPr>
-        <p:spPr>
-          <a:xfrm>
-            <a:off x="5633936" y="4977319"/>
+            <a:off x="4612532" y="4977319"/>
             <a:ext cx="0" cy="291830"/>
           </a:xfrm>
           <a:prstGeom prst="line">
@@ -4988,31 +3980,17 @@
             </a:solidFill>
           </a:ln>
         </p:spPr>
-        <p:style>
-          <a:lnRef idx="2">
-            <a:schemeClr val="accent1"/>
-          </a:lnRef>
-          <a:fillRef idx="0">
-            <a:schemeClr val="accent1"/>
-          </a:fillRef>
-          <a:effectRef idx="1">
-            <a:schemeClr val="accent1"/>
-          </a:effectRef>
-          <a:fontRef idx="minor">
-            <a:schemeClr val="tx1"/>
-          </a:fontRef>
-        </p:style>
       </p:cxnSp>
       <p:sp>
         <p:nvSpPr>
-          <p:cNvPr id="100" name="TextBox 99"/>
-          <p:cNvSpPr txBox="1"/>
-          <p:nvPr/>
-        </p:nvSpPr>
-        <p:spPr>
-          <a:xfrm>
-            <a:off x="5633936" y="5042170"/>
-            <a:ext cx="1459149" cy="226979"/>
+          <p:cNvPr id="96" name="TextBox 95"/>
+          <p:cNvSpPr txBox="1"/>
+          <p:nvPr/>
+        </p:nvSpPr>
+        <p:spPr>
+          <a:xfrm>
+            <a:off x="4612532" y="5042170"/>
+            <a:ext cx="1167319" cy="226979"/>
           </a:xfrm>
           <a:prstGeom prst="rect">
             <a:avLst/>
@@ -5044,48 +4022,13 @@
       </p:sp>
       <p:cxnSp>
         <p:nvCxnSpPr>
-          <p:cNvPr id="101" name="Connector 100"/>
+          <p:cNvPr id="97" name="Connector 96"/>
           <p:cNvCxnSpPr/>
           <p:nvPr/>
         </p:nvCxnSpPr>
         <p:spPr>
           <a:xfrm>
-            <a:off x="7093085" y="5009745"/>
-            <a:ext cx="811" cy="0"/>
-          </a:xfrm>
-          <a:prstGeom prst="line">
-            <a:avLst/>
-          </a:prstGeom>
-          <a:ln w="12700">
-            <a:solidFill>
-              <a:srgbClr val="C9CFCF"/>
-            </a:solidFill>
-          </a:ln>
-        </p:spPr>
-        <p:style>
-          <a:lnRef idx="2">
-            <a:schemeClr val="accent1"/>
-          </a:lnRef>
-          <a:fillRef idx="0">
-            <a:schemeClr val="accent1"/>
-          </a:fillRef>
-          <a:effectRef idx="1">
-            <a:schemeClr val="accent1"/>
-          </a:effectRef>
-          <a:fontRef idx="minor">
-            <a:schemeClr val="tx1"/>
-          </a:fontRef>
-        </p:style>
-      </p:cxnSp>
-      <p:cxnSp>
-        <p:nvCxnSpPr>
-          <p:cNvPr id="102" name="Connector 101"/>
-          <p:cNvCxnSpPr/>
-          <p:nvPr/>
-        </p:nvCxnSpPr>
-        <p:spPr>
-          <a:xfrm>
-            <a:off x="7093085" y="4977319"/>
+            <a:off x="5779851" y="4977319"/>
             <a:ext cx="0" cy="291830"/>
           </a:xfrm>
           <a:prstGeom prst="line">
@@ -5097,31 +4040,17 @@
             </a:solidFill>
           </a:ln>
         </p:spPr>
-        <p:style>
-          <a:lnRef idx="2">
-            <a:schemeClr val="accent1"/>
-          </a:lnRef>
-          <a:fillRef idx="0">
-            <a:schemeClr val="accent1"/>
-          </a:fillRef>
-          <a:effectRef idx="1">
-            <a:schemeClr val="accent1"/>
-          </a:effectRef>
-          <a:fontRef idx="minor">
-            <a:schemeClr val="tx1"/>
-          </a:fontRef>
-        </p:style>
       </p:cxnSp>
       <p:sp>
         <p:nvSpPr>
-          <p:cNvPr id="103" name="TextBox 102"/>
-          <p:cNvSpPr txBox="1"/>
-          <p:nvPr/>
-        </p:nvSpPr>
-        <p:spPr>
-          <a:xfrm>
-            <a:off x="7093085" y="5042170"/>
-            <a:ext cx="1459149" cy="226979"/>
+          <p:cNvPr id="98" name="TextBox 97"/>
+          <p:cNvSpPr txBox="1"/>
+          <p:nvPr/>
+        </p:nvSpPr>
+        <p:spPr>
+          <a:xfrm>
+            <a:off x="5779851" y="5042170"/>
+            <a:ext cx="1167319" cy="226979"/>
           </a:xfrm>
           <a:prstGeom prst="rect">
             <a:avLst/>
@@ -5153,7 +4082,7 @@
       </p:sp>
       <p:sp>
         <p:nvSpPr>
-          <p:cNvPr id="104" name="TextBox 103"/>
+          <p:cNvPr id="99" name="TextBox 98"/>
           <p:cNvSpPr txBox="1"/>
           <p:nvPr/>
         </p:nvSpPr>
@@ -5196,7 +4125,7 @@
                 <a:ea typeface="Zen Kaku Gothic New"/>
                 <a:cs typeface="Zen Kaku Gothic New"/>
               </a:rPr>
-              <a:t>四半期2.5億円</a:t>
+              <a:t>四半期2.7億円</a:t>
             </a:r>
             <a:r>
               <a:rPr sz="1768" b="1">
@@ -5214,7 +4143,7 @@
       </p:sp>
       <p:sp>
         <p:nvSpPr>
-          <p:cNvPr id="105" name="TextBox 104"/>
+          <p:cNvPr id="100" name="TextBox 99"/>
           <p:cNvSpPr txBox="1"/>
           <p:nvPr/>
         </p:nvSpPr>
@@ -5246,7 +4175,7 @@
                 <a:ea typeface="Zen Kaku Gothic New"/>
                 <a:cs typeface="Zen Kaku Gothic New"/>
               </a:rPr>
-              <a:t>※ 事業別 四半期エコノミクスの集計（注文日ベース・税抜）。全社の試算表とは集計基準が異なる。第3期は2021年4月〜</a:t>
+              <a:t>※ 第3〜7期は事業別の集計（注文日ベース・税抜）。第8期は試算表の売上高を事業別の比率で按分（イネイブラー等を含む）</a:t>
             </a:r>
           </a:p>
         </p:txBody>
@@ -5291,20 +4220,6 @@
           </a:ln>
           <a:effectLst/>
         </p:spPr>
-        <p:style>
-          <a:lnRef idx="1">
-            <a:schemeClr val="accent1"/>
-          </a:lnRef>
-          <a:fillRef idx="3">
-            <a:schemeClr val="accent1"/>
-          </a:fillRef>
-          <a:effectRef idx="2">
-            <a:schemeClr val="accent1"/>
-          </a:effectRef>
-          <a:fontRef idx="minor">
-            <a:schemeClr val="lt1"/>
-          </a:fontRef>
-        </p:style>
         <p:txBody>
           <a:bodyPr rtlCol="0" anchor="ctr"/>
           <a:lstStyle/>
@@ -5569,20 +4484,6 @@
           </a:ln>
           <a:effectLst/>
         </p:spPr>
-        <p:style>
-          <a:lnRef idx="1">
-            <a:schemeClr val="accent1"/>
-          </a:lnRef>
-          <a:fillRef idx="3">
-            <a:schemeClr val="accent1"/>
-          </a:fillRef>
-          <a:effectRef idx="2">
-            <a:schemeClr val="accent1"/>
-          </a:effectRef>
-          <a:fontRef idx="minor">
-            <a:schemeClr val="lt1"/>
-          </a:fontRef>
-        </p:style>
         <p:txBody>
           <a:bodyPr rtlCol="0" anchor="ctr"/>
           <a:lstStyle/>
@@ -5691,20 +4592,6 @@
           </a:ln>
           <a:effectLst/>
         </p:spPr>
-        <p:style>
-          <a:lnRef idx="1">
-            <a:schemeClr val="accent1"/>
-          </a:lnRef>
-          <a:fillRef idx="3">
-            <a:schemeClr val="accent1"/>
-          </a:fillRef>
-          <a:effectRef idx="2">
-            <a:schemeClr val="accent1"/>
-          </a:effectRef>
-          <a:fontRef idx="minor">
-            <a:schemeClr val="lt1"/>
-          </a:fontRef>
-        </p:style>
         <p:txBody>
           <a:bodyPr rtlCol="0" anchor="ctr"/>
           <a:lstStyle/>
@@ -5811,20 +4698,6 @@
             </a:solidFill>
           </a:ln>
         </p:spPr>
-        <p:style>
-          <a:lnRef idx="2">
-            <a:schemeClr val="accent1"/>
-          </a:lnRef>
-          <a:fillRef idx="0">
-            <a:schemeClr val="accent1"/>
-          </a:fillRef>
-          <a:effectRef idx="1">
-            <a:schemeClr val="accent1"/>
-          </a:effectRef>
-          <a:fontRef idx="minor">
-            <a:schemeClr val="tx1"/>
-          </a:fontRef>
-        </p:style>
       </p:cxnSp>
       <p:sp>
         <p:nvSpPr>
@@ -6004,20 +4877,6 @@
           </a:ln>
           <a:effectLst/>
         </p:spPr>
-        <p:style>
-          <a:lnRef idx="1">
-            <a:schemeClr val="accent1"/>
-          </a:lnRef>
-          <a:fillRef idx="3">
-            <a:schemeClr val="accent1"/>
-          </a:fillRef>
-          <a:effectRef idx="2">
-            <a:schemeClr val="accent1"/>
-          </a:effectRef>
-          <a:fontRef idx="minor">
-            <a:schemeClr val="lt1"/>
-          </a:fontRef>
-        </p:style>
         <p:txBody>
           <a:bodyPr rtlCol="0" anchor="ctr"/>
           <a:lstStyle/>
@@ -6126,20 +4985,6 @@
           </a:ln>
           <a:effectLst/>
         </p:spPr>
-        <p:style>
-          <a:lnRef idx="1">
-            <a:schemeClr val="accent1"/>
-          </a:lnRef>
-          <a:fillRef idx="3">
-            <a:schemeClr val="accent1"/>
-          </a:fillRef>
-          <a:effectRef idx="2">
-            <a:schemeClr val="accent1"/>
-          </a:effectRef>
-          <a:fontRef idx="minor">
-            <a:schemeClr val="lt1"/>
-          </a:fontRef>
-        </p:style>
         <p:txBody>
           <a:bodyPr rtlCol="0" anchor="ctr"/>
           <a:lstStyle/>
@@ -6246,20 +5091,6 @@
             </a:solidFill>
           </a:ln>
         </p:spPr>
-        <p:style>
-          <a:lnRef idx="2">
-            <a:schemeClr val="accent1"/>
-          </a:lnRef>
-          <a:fillRef idx="0">
-            <a:schemeClr val="accent1"/>
-          </a:fillRef>
-          <a:effectRef idx="1">
-            <a:schemeClr val="accent1"/>
-          </a:effectRef>
-          <a:fontRef idx="minor">
-            <a:schemeClr val="tx1"/>
-          </a:fontRef>
-        </p:style>
       </p:cxnSp>
       <p:sp>
         <p:nvSpPr>
@@ -6439,20 +5270,6 @@
           </a:ln>
           <a:effectLst/>
         </p:spPr>
-        <p:style>
-          <a:lnRef idx="1">
-            <a:schemeClr val="accent1"/>
-          </a:lnRef>
-          <a:fillRef idx="3">
-            <a:schemeClr val="accent1"/>
-          </a:fillRef>
-          <a:effectRef idx="2">
-            <a:schemeClr val="accent1"/>
-          </a:effectRef>
-          <a:fontRef idx="minor">
-            <a:schemeClr val="lt1"/>
-          </a:fontRef>
-        </p:style>
         <p:txBody>
           <a:bodyPr rtlCol="0" anchor="ctr"/>
           <a:lstStyle/>
@@ -6561,20 +5378,6 @@
           </a:ln>
           <a:effectLst/>
         </p:spPr>
-        <p:style>
-          <a:lnRef idx="1">
-            <a:schemeClr val="accent1"/>
-          </a:lnRef>
-          <a:fillRef idx="3">
-            <a:schemeClr val="accent1"/>
-          </a:fillRef>
-          <a:effectRef idx="2">
-            <a:schemeClr val="accent1"/>
-          </a:effectRef>
-          <a:fontRef idx="minor">
-            <a:schemeClr val="lt1"/>
-          </a:fontRef>
-        </p:style>
         <p:txBody>
           <a:bodyPr rtlCol="0" anchor="ctr"/>
           <a:lstStyle/>
@@ -6681,20 +5484,6 @@
             </a:solidFill>
           </a:ln>
         </p:spPr>
-        <p:style>
-          <a:lnRef idx="2">
-            <a:schemeClr val="accent1"/>
-          </a:lnRef>
-          <a:fillRef idx="0">
-            <a:schemeClr val="accent1"/>
-          </a:fillRef>
-          <a:effectRef idx="1">
-            <a:schemeClr val="accent1"/>
-          </a:effectRef>
-          <a:fontRef idx="minor">
-            <a:schemeClr val="tx1"/>
-          </a:fontRef>
-        </p:style>
       </p:cxnSp>
       <p:sp>
         <p:nvSpPr>
@@ -6875,20 +5664,6 @@
           </a:ln>
           <a:effectLst/>
         </p:spPr>
-        <p:style>
-          <a:lnRef idx="1">
-            <a:schemeClr val="accent1"/>
-          </a:lnRef>
-          <a:fillRef idx="3">
-            <a:schemeClr val="accent1"/>
-          </a:fillRef>
-          <a:effectRef idx="2">
-            <a:schemeClr val="accent1"/>
-          </a:effectRef>
-          <a:fontRef idx="minor">
-            <a:schemeClr val="lt1"/>
-          </a:fontRef>
-        </p:style>
         <p:txBody>
           <a:bodyPr rtlCol="0" anchor="ctr"/>
           <a:lstStyle/>
@@ -7151,20 +5926,6 @@
           </a:ln>
           <a:effectLst/>
         </p:spPr>
-        <p:style>
-          <a:lnRef idx="1">
-            <a:schemeClr val="accent1"/>
-          </a:lnRef>
-          <a:fillRef idx="3">
-            <a:schemeClr val="accent1"/>
-          </a:fillRef>
-          <a:effectRef idx="2">
-            <a:schemeClr val="accent1"/>
-          </a:effectRef>
-          <a:fontRef idx="minor">
-            <a:schemeClr val="lt1"/>
-          </a:fontRef>
-        </p:style>
         <p:txBody>
           <a:bodyPr rtlCol="0" anchor="ctr"/>
           <a:lstStyle/>
@@ -7310,20 +6071,6 @@
             </a:solidFill>
           </a:ln>
         </p:spPr>
-        <p:style>
-          <a:lnRef idx="2">
-            <a:schemeClr val="accent1"/>
-          </a:lnRef>
-          <a:fillRef idx="0">
-            <a:schemeClr val="accent1"/>
-          </a:fillRef>
-          <a:effectRef idx="1">
-            <a:schemeClr val="accent1"/>
-          </a:effectRef>
-          <a:fontRef idx="minor">
-            <a:schemeClr val="tx1"/>
-          </a:fontRef>
-        </p:style>
       </p:cxnSp>
       <p:sp>
         <p:nvSpPr>
@@ -7347,20 +6094,6 @@
           </a:ln>
           <a:effectLst/>
         </p:spPr>
-        <p:style>
-          <a:lnRef idx="1">
-            <a:schemeClr val="accent1"/>
-          </a:lnRef>
-          <a:fillRef idx="3">
-            <a:schemeClr val="accent1"/>
-          </a:fillRef>
-          <a:effectRef idx="2">
-            <a:schemeClr val="accent1"/>
-          </a:effectRef>
-          <a:fontRef idx="minor">
-            <a:schemeClr val="lt1"/>
-          </a:fontRef>
-        </p:style>
         <p:txBody>
           <a:bodyPr rtlCol="0" anchor="ctr"/>
           <a:lstStyle/>
@@ -7487,20 +6220,6 @@
           </a:ln>
           <a:effectLst/>
         </p:spPr>
-        <p:style>
-          <a:lnRef idx="1">
-            <a:schemeClr val="accent1"/>
-          </a:lnRef>
-          <a:fillRef idx="3">
-            <a:schemeClr val="accent1"/>
-          </a:fillRef>
-          <a:effectRef idx="2">
-            <a:schemeClr val="accent1"/>
-          </a:effectRef>
-          <a:fontRef idx="minor">
-            <a:schemeClr val="lt1"/>
-          </a:fontRef>
-        </p:style>
         <p:txBody>
           <a:bodyPr rtlCol="0" anchor="ctr"/>
           <a:lstStyle/>
@@ -7627,20 +6346,6 @@
           </a:ln>
           <a:effectLst/>
         </p:spPr>
-        <p:style>
-          <a:lnRef idx="1">
-            <a:schemeClr val="accent1"/>
-          </a:lnRef>
-          <a:fillRef idx="3">
-            <a:schemeClr val="accent1"/>
-          </a:fillRef>
-          <a:effectRef idx="2">
-            <a:schemeClr val="accent1"/>
-          </a:effectRef>
-          <a:fontRef idx="minor">
-            <a:schemeClr val="lt1"/>
-          </a:fontRef>
-        </p:style>
         <p:txBody>
           <a:bodyPr rtlCol="0" anchor="ctr"/>
           <a:lstStyle/>
@@ -7767,20 +6472,6 @@
           </a:ln>
           <a:effectLst/>
         </p:spPr>
-        <p:style>
-          <a:lnRef idx="1">
-            <a:schemeClr val="accent1"/>
-          </a:lnRef>
-          <a:fillRef idx="3">
-            <a:schemeClr val="accent1"/>
-          </a:fillRef>
-          <a:effectRef idx="2">
-            <a:schemeClr val="accent1"/>
-          </a:effectRef>
-          <a:fontRef idx="minor">
-            <a:schemeClr val="lt1"/>
-          </a:fontRef>
-        </p:style>
         <p:txBody>
           <a:bodyPr rtlCol="0" anchor="ctr"/>
           <a:lstStyle/>
@@ -7907,20 +6598,6 @@
           </a:ln>
           <a:effectLst/>
         </p:spPr>
-        <p:style>
-          <a:lnRef idx="1">
-            <a:schemeClr val="accent1"/>
-          </a:lnRef>
-          <a:fillRef idx="3">
-            <a:schemeClr val="accent1"/>
-          </a:fillRef>
-          <a:effectRef idx="2">
-            <a:schemeClr val="accent1"/>
-          </a:effectRef>
-          <a:fontRef idx="minor">
-            <a:schemeClr val="lt1"/>
-          </a:fontRef>
-        </p:style>
         <p:txBody>
           <a:bodyPr rtlCol="0" anchor="ctr"/>
           <a:lstStyle/>
@@ -8047,20 +6724,6 @@
           </a:ln>
           <a:effectLst/>
         </p:spPr>
-        <p:style>
-          <a:lnRef idx="1">
-            <a:schemeClr val="accent1"/>
-          </a:lnRef>
-          <a:fillRef idx="3">
-            <a:schemeClr val="accent1"/>
-          </a:fillRef>
-          <a:effectRef idx="2">
-            <a:schemeClr val="accent1"/>
-          </a:effectRef>
-          <a:fontRef idx="minor">
-            <a:schemeClr val="lt1"/>
-          </a:fontRef>
-        </p:style>
         <p:txBody>
           <a:bodyPr rtlCol="0" anchor="ctr"/>
           <a:lstStyle/>
@@ -8187,20 +6850,6 @@
           </a:ln>
           <a:effectLst/>
         </p:spPr>
-        <p:style>
-          <a:lnRef idx="1">
-            <a:schemeClr val="accent1"/>
-          </a:lnRef>
-          <a:fillRef idx="3">
-            <a:schemeClr val="accent1"/>
-          </a:fillRef>
-          <a:effectRef idx="2">
-            <a:schemeClr val="accent1"/>
-          </a:effectRef>
-          <a:fontRef idx="minor">
-            <a:schemeClr val="lt1"/>
-          </a:fontRef>
-        </p:style>
         <p:txBody>
           <a:bodyPr rtlCol="0" anchor="ctr"/>
           <a:lstStyle/>
@@ -8327,20 +6976,6 @@
           </a:ln>
           <a:effectLst/>
         </p:spPr>
-        <p:style>
-          <a:lnRef idx="1">
-            <a:schemeClr val="accent1"/>
-          </a:lnRef>
-          <a:fillRef idx="3">
-            <a:schemeClr val="accent1"/>
-          </a:fillRef>
-          <a:effectRef idx="2">
-            <a:schemeClr val="accent1"/>
-          </a:effectRef>
-          <a:fontRef idx="minor">
-            <a:schemeClr val="lt1"/>
-          </a:fontRef>
-        </p:style>
         <p:txBody>
           <a:bodyPr rtlCol="0" anchor="ctr"/>
           <a:lstStyle/>
@@ -8465,20 +7100,6 @@
             </a:solidFill>
           </a:ln>
         </p:spPr>
-        <p:style>
-          <a:lnRef idx="2">
-            <a:schemeClr val="accent1"/>
-          </a:lnRef>
-          <a:fillRef idx="0">
-            <a:schemeClr val="accent1"/>
-          </a:fillRef>
-          <a:effectRef idx="1">
-            <a:schemeClr val="accent1"/>
-          </a:effectRef>
-          <a:fontRef idx="minor">
-            <a:schemeClr val="tx1"/>
-          </a:fontRef>
-        </p:style>
       </p:cxnSp>
       <p:sp>
         <p:nvSpPr>
@@ -8780,20 +7401,6 @@
           </a:ln>
           <a:effectLst/>
         </p:spPr>
-        <p:style>
-          <a:lnRef idx="1">
-            <a:schemeClr val="accent1"/>
-          </a:lnRef>
-          <a:fillRef idx="3">
-            <a:schemeClr val="accent1"/>
-          </a:fillRef>
-          <a:effectRef idx="2">
-            <a:schemeClr val="accent1"/>
-          </a:effectRef>
-          <a:fontRef idx="minor">
-            <a:schemeClr val="lt1"/>
-          </a:fontRef>
-        </p:style>
         <p:txBody>
           <a:bodyPr rtlCol="0" anchor="ctr"/>
           <a:lstStyle/>
@@ -9019,20 +7626,6 @@
           </a:ln>
           <a:effectLst/>
         </p:spPr>
-        <p:style>
-          <a:lnRef idx="1">
-            <a:schemeClr val="accent1"/>
-          </a:lnRef>
-          <a:fillRef idx="3">
-            <a:schemeClr val="accent1"/>
-          </a:fillRef>
-          <a:effectRef idx="2">
-            <a:schemeClr val="accent1"/>
-          </a:effectRef>
-          <a:fontRef idx="minor">
-            <a:schemeClr val="lt1"/>
-          </a:fontRef>
-        </p:style>
         <p:txBody>
           <a:bodyPr rtlCol="0" anchor="ctr"/>
           <a:lstStyle/>
@@ -9141,20 +7734,6 @@
           </a:ln>
           <a:effectLst/>
         </p:spPr>
-        <p:style>
-          <a:lnRef idx="1">
-            <a:schemeClr val="accent1"/>
-          </a:lnRef>
-          <a:fillRef idx="3">
-            <a:schemeClr val="accent1"/>
-          </a:fillRef>
-          <a:effectRef idx="2">
-            <a:schemeClr val="accent1"/>
-          </a:effectRef>
-          <a:fontRef idx="minor">
-            <a:schemeClr val="lt1"/>
-          </a:fontRef>
-        </p:style>
         <p:txBody>
           <a:bodyPr rtlCol="0" anchor="ctr"/>
           <a:lstStyle/>
@@ -9261,20 +7840,6 @@
             </a:solidFill>
           </a:ln>
         </p:spPr>
-        <p:style>
-          <a:lnRef idx="2">
-            <a:schemeClr val="accent1"/>
-          </a:lnRef>
-          <a:fillRef idx="0">
-            <a:schemeClr val="accent1"/>
-          </a:fillRef>
-          <a:effectRef idx="1">
-            <a:schemeClr val="accent1"/>
-          </a:effectRef>
-          <a:fontRef idx="minor">
-            <a:schemeClr val="tx1"/>
-          </a:fontRef>
-        </p:style>
       </p:cxnSp>
       <p:sp>
         <p:nvSpPr>
@@ -9415,20 +7980,6 @@
           </a:ln>
           <a:effectLst/>
         </p:spPr>
-        <p:style>
-          <a:lnRef idx="1">
-            <a:schemeClr val="accent1"/>
-          </a:lnRef>
-          <a:fillRef idx="3">
-            <a:schemeClr val="accent1"/>
-          </a:fillRef>
-          <a:effectRef idx="2">
-            <a:schemeClr val="accent1"/>
-          </a:effectRef>
-          <a:fontRef idx="minor">
-            <a:schemeClr val="lt1"/>
-          </a:fontRef>
-        </p:style>
         <p:txBody>
           <a:bodyPr rtlCol="0" anchor="ctr"/>
           <a:lstStyle/>
@@ -9537,20 +8088,6 @@
           </a:ln>
           <a:effectLst/>
         </p:spPr>
-        <p:style>
-          <a:lnRef idx="1">
-            <a:schemeClr val="accent1"/>
-          </a:lnRef>
-          <a:fillRef idx="3">
-            <a:schemeClr val="accent1"/>
-          </a:fillRef>
-          <a:effectRef idx="2">
-            <a:schemeClr val="accent1"/>
-          </a:effectRef>
-          <a:fontRef idx="minor">
-            <a:schemeClr val="lt1"/>
-          </a:fontRef>
-        </p:style>
         <p:txBody>
           <a:bodyPr rtlCol="0" anchor="ctr"/>
           <a:lstStyle/>
@@ -9657,20 +8194,6 @@
             </a:solidFill>
           </a:ln>
         </p:spPr>
-        <p:style>
-          <a:lnRef idx="2">
-            <a:schemeClr val="accent1"/>
-          </a:lnRef>
-          <a:fillRef idx="0">
-            <a:schemeClr val="accent1"/>
-          </a:fillRef>
-          <a:effectRef idx="1">
-            <a:schemeClr val="accent1"/>
-          </a:effectRef>
-          <a:fontRef idx="minor">
-            <a:schemeClr val="tx1"/>
-          </a:fontRef>
-        </p:style>
       </p:cxnSp>
       <p:sp>
         <p:nvSpPr>
@@ -10036,20 +8559,6 @@
           </a:ln>
           <a:effectLst/>
         </p:spPr>
-        <p:style>
-          <a:lnRef idx="1">
-            <a:schemeClr val="accent1"/>
-          </a:lnRef>
-          <a:fillRef idx="3">
-            <a:schemeClr val="accent1"/>
-          </a:fillRef>
-          <a:effectRef idx="2">
-            <a:schemeClr val="accent1"/>
-          </a:effectRef>
-          <a:fontRef idx="minor">
-            <a:schemeClr val="lt1"/>
-          </a:fontRef>
-        </p:style>
         <p:txBody>
           <a:bodyPr rtlCol="0" anchor="ctr"/>
           <a:lstStyle/>
@@ -10340,20 +8849,6 @@
           </a:ln>
           <a:effectLst/>
         </p:spPr>
-        <p:style>
-          <a:lnRef idx="1">
-            <a:schemeClr val="accent1"/>
-          </a:lnRef>
-          <a:fillRef idx="3">
-            <a:schemeClr val="accent1"/>
-          </a:fillRef>
-          <a:effectRef idx="2">
-            <a:schemeClr val="accent1"/>
-          </a:effectRef>
-          <a:fontRef idx="minor">
-            <a:schemeClr val="lt1"/>
-          </a:fontRef>
-        </p:style>
         <p:txBody>
           <a:bodyPr rtlCol="0" anchor="ctr"/>
           <a:lstStyle/>
@@ -10605,20 +9100,6 @@
           </a:ln>
           <a:effectLst/>
         </p:spPr>
-        <p:style>
-          <a:lnRef idx="1">
-            <a:schemeClr val="accent1"/>
-          </a:lnRef>
-          <a:fillRef idx="3">
-            <a:schemeClr val="accent1"/>
-          </a:fillRef>
-          <a:effectRef idx="2">
-            <a:schemeClr val="accent1"/>
-          </a:effectRef>
-          <a:fontRef idx="minor">
-            <a:schemeClr val="lt1"/>
-          </a:fontRef>
-        </p:style>
         <p:txBody>
           <a:bodyPr rtlCol="0" anchor="ctr"/>
           <a:lstStyle/>
@@ -10953,20 +9434,6 @@
             </a:solidFill>
           </a:ln>
         </p:spPr>
-        <p:style>
-          <a:lnRef idx="2">
-            <a:schemeClr val="accent1"/>
-          </a:lnRef>
-          <a:fillRef idx="0">
-            <a:schemeClr val="accent1"/>
-          </a:fillRef>
-          <a:effectRef idx="1">
-            <a:schemeClr val="accent1"/>
-          </a:effectRef>
-          <a:fontRef idx="minor">
-            <a:schemeClr val="tx1"/>
-          </a:fontRef>
-        </p:style>
       </p:cxnSp>
       <p:sp>
         <p:nvSpPr>
@@ -11144,20 +9611,6 @@
           </a:ln>
           <a:effectLst/>
         </p:spPr>
-        <p:style>
-          <a:lnRef idx="1">
-            <a:schemeClr val="accent1"/>
-          </a:lnRef>
-          <a:fillRef idx="3">
-            <a:schemeClr val="accent1"/>
-          </a:fillRef>
-          <a:effectRef idx="2">
-            <a:schemeClr val="accent1"/>
-          </a:effectRef>
-          <a:fontRef idx="minor">
-            <a:schemeClr val="lt1"/>
-          </a:fontRef>
-        </p:style>
         <p:txBody>
           <a:bodyPr rtlCol="0" anchor="ctr"/>
           <a:lstStyle/>
@@ -11342,20 +9795,6 @@
             </a:solidFill>
           </a:ln>
         </p:spPr>
-        <p:style>
-          <a:lnRef idx="2">
-            <a:schemeClr val="accent1"/>
-          </a:lnRef>
-          <a:fillRef idx="0">
-            <a:schemeClr val="accent1"/>
-          </a:fillRef>
-          <a:effectRef idx="1">
-            <a:schemeClr val="accent1"/>
-          </a:effectRef>
-          <a:fontRef idx="minor">
-            <a:schemeClr val="tx1"/>
-          </a:fontRef>
-        </p:style>
       </p:cxnSp>
       <p:sp>
         <p:nvSpPr>
@@ -11455,20 +9894,6 @@
             </a:solidFill>
           </a:ln>
         </p:spPr>
-        <p:style>
-          <a:lnRef idx="2">
-            <a:schemeClr val="accent1"/>
-          </a:lnRef>
-          <a:fillRef idx="0">
-            <a:schemeClr val="accent1"/>
-          </a:fillRef>
-          <a:effectRef idx="1">
-            <a:schemeClr val="accent1"/>
-          </a:effectRef>
-          <a:fontRef idx="minor">
-            <a:schemeClr val="tx1"/>
-          </a:fontRef>
-        </p:style>
       </p:cxnSp>
       <p:sp>
         <p:nvSpPr>
@@ -11588,20 +10013,6 @@
           </a:ln>
           <a:effectLst/>
         </p:spPr>
-        <p:style>
-          <a:lnRef idx="1">
-            <a:schemeClr val="accent1"/>
-          </a:lnRef>
-          <a:fillRef idx="3">
-            <a:schemeClr val="accent1"/>
-          </a:fillRef>
-          <a:effectRef idx="2">
-            <a:schemeClr val="accent1"/>
-          </a:effectRef>
-          <a:fontRef idx="minor">
-            <a:schemeClr val="lt1"/>
-          </a:fontRef>
-        </p:style>
         <p:txBody>
           <a:bodyPr rtlCol="0" anchor="ctr"/>
           <a:lstStyle/>
@@ -11710,20 +10121,6 @@
           </a:ln>
           <a:effectLst/>
         </p:spPr>
-        <p:style>
-          <a:lnRef idx="1">
-            <a:schemeClr val="accent1"/>
-          </a:lnRef>
-          <a:fillRef idx="3">
-            <a:schemeClr val="accent1"/>
-          </a:fillRef>
-          <a:effectRef idx="2">
-            <a:schemeClr val="accent1"/>
-          </a:effectRef>
-          <a:fontRef idx="minor">
-            <a:schemeClr val="lt1"/>
-          </a:fontRef>
-        </p:style>
         <p:txBody>
           <a:bodyPr rtlCol="0" anchor="ctr"/>
           <a:lstStyle/>
@@ -11793,20 +10190,6 @@
           </a:ln>
           <a:effectLst/>
         </p:spPr>
-        <p:style>
-          <a:lnRef idx="1">
-            <a:schemeClr val="accent1"/>
-          </a:lnRef>
-          <a:fillRef idx="3">
-            <a:schemeClr val="accent1"/>
-          </a:fillRef>
-          <a:effectRef idx="2">
-            <a:schemeClr val="accent1"/>
-          </a:effectRef>
-          <a:fontRef idx="minor">
-            <a:schemeClr val="lt1"/>
-          </a:fontRef>
-        </p:style>
         <p:txBody>
           <a:bodyPr rtlCol="0" anchor="ctr"/>
           <a:lstStyle/>
@@ -11837,20 +10220,6 @@
           </a:ln>
           <a:effectLst/>
         </p:spPr>
-        <p:style>
-          <a:lnRef idx="1">
-            <a:schemeClr val="accent1"/>
-          </a:lnRef>
-          <a:fillRef idx="3">
-            <a:schemeClr val="accent1"/>
-          </a:fillRef>
-          <a:effectRef idx="2">
-            <a:schemeClr val="accent1"/>
-          </a:effectRef>
-          <a:fontRef idx="minor">
-            <a:schemeClr val="lt1"/>
-          </a:fontRef>
-        </p:style>
         <p:txBody>
           <a:bodyPr rtlCol="0" anchor="ctr"/>
           <a:lstStyle/>
@@ -11920,20 +10289,6 @@
           </a:ln>
           <a:effectLst/>
         </p:spPr>
-        <p:style>
-          <a:lnRef idx="1">
-            <a:schemeClr val="accent1"/>
-          </a:lnRef>
-          <a:fillRef idx="3">
-            <a:schemeClr val="accent1"/>
-          </a:fillRef>
-          <a:effectRef idx="2">
-            <a:schemeClr val="accent1"/>
-          </a:effectRef>
-          <a:fontRef idx="minor">
-            <a:schemeClr val="lt1"/>
-          </a:fontRef>
-        </p:style>
         <p:txBody>
           <a:bodyPr rtlCol="0" anchor="ctr"/>
           <a:lstStyle/>
@@ -11964,20 +10319,6 @@
           </a:ln>
           <a:effectLst/>
         </p:spPr>
-        <p:style>
-          <a:lnRef idx="1">
-            <a:schemeClr val="accent1"/>
-          </a:lnRef>
-          <a:fillRef idx="3">
-            <a:schemeClr val="accent1"/>
-          </a:fillRef>
-          <a:effectRef idx="2">
-            <a:schemeClr val="accent1"/>
-          </a:effectRef>
-          <a:fontRef idx="minor">
-            <a:schemeClr val="lt1"/>
-          </a:fontRef>
-        </p:style>
         <p:txBody>
           <a:bodyPr rtlCol="0" anchor="ctr"/>
           <a:lstStyle/>
@@ -12047,20 +10388,6 @@
           </a:ln>
           <a:effectLst/>
         </p:spPr>
-        <p:style>
-          <a:lnRef idx="1">
-            <a:schemeClr val="accent1"/>
-          </a:lnRef>
-          <a:fillRef idx="3">
-            <a:schemeClr val="accent1"/>
-          </a:fillRef>
-          <a:effectRef idx="2">
-            <a:schemeClr val="accent1"/>
-          </a:effectRef>
-          <a:fontRef idx="minor">
-            <a:schemeClr val="lt1"/>
-          </a:fontRef>
-        </p:style>
         <p:txBody>
           <a:bodyPr rtlCol="0" anchor="ctr"/>
           <a:lstStyle/>
@@ -12091,20 +10418,6 @@
           </a:ln>
           <a:effectLst/>
         </p:spPr>
-        <p:style>
-          <a:lnRef idx="1">
-            <a:schemeClr val="accent1"/>
-          </a:lnRef>
-          <a:fillRef idx="3">
-            <a:schemeClr val="accent1"/>
-          </a:fillRef>
-          <a:effectRef idx="2">
-            <a:schemeClr val="accent1"/>
-          </a:effectRef>
-          <a:fontRef idx="minor">
-            <a:schemeClr val="lt1"/>
-          </a:fontRef>
-        </p:style>
         <p:txBody>
           <a:bodyPr rtlCol="0" anchor="ctr"/>
           <a:lstStyle/>
@@ -12174,20 +10487,6 @@
           </a:ln>
           <a:effectLst/>
         </p:spPr>
-        <p:style>
-          <a:lnRef idx="1">
-            <a:schemeClr val="accent1"/>
-          </a:lnRef>
-          <a:fillRef idx="3">
-            <a:schemeClr val="accent1"/>
-          </a:fillRef>
-          <a:effectRef idx="2">
-            <a:schemeClr val="accent1"/>
-          </a:effectRef>
-          <a:fontRef idx="minor">
-            <a:schemeClr val="lt1"/>
-          </a:fontRef>
-        </p:style>
         <p:txBody>
           <a:bodyPr rtlCol="0" anchor="ctr"/>
           <a:lstStyle/>
@@ -12218,20 +10517,6 @@
           </a:ln>
           <a:effectLst/>
         </p:spPr>
-        <p:style>
-          <a:lnRef idx="1">
-            <a:schemeClr val="accent1"/>
-          </a:lnRef>
-          <a:fillRef idx="3">
-            <a:schemeClr val="accent1"/>
-          </a:fillRef>
-          <a:effectRef idx="2">
-            <a:schemeClr val="accent1"/>
-          </a:effectRef>
-          <a:fontRef idx="minor">
-            <a:schemeClr val="lt1"/>
-          </a:fontRef>
-        </p:style>
         <p:txBody>
           <a:bodyPr rtlCol="0" anchor="ctr"/>
           <a:lstStyle/>
@@ -12301,20 +10586,6 @@
           </a:ln>
           <a:effectLst/>
         </p:spPr>
-        <p:style>
-          <a:lnRef idx="1">
-            <a:schemeClr val="accent1"/>
-          </a:lnRef>
-          <a:fillRef idx="3">
-            <a:schemeClr val="accent1"/>
-          </a:fillRef>
-          <a:effectRef idx="2">
-            <a:schemeClr val="accent1"/>
-          </a:effectRef>
-          <a:fontRef idx="minor">
-            <a:schemeClr val="lt1"/>
-          </a:fontRef>
-        </p:style>
         <p:txBody>
           <a:bodyPr rtlCol="0" anchor="ctr"/>
           <a:lstStyle/>
@@ -12345,20 +10616,6 @@
           </a:ln>
           <a:effectLst/>
         </p:spPr>
-        <p:style>
-          <a:lnRef idx="1">
-            <a:schemeClr val="accent1"/>
-          </a:lnRef>
-          <a:fillRef idx="3">
-            <a:schemeClr val="accent1"/>
-          </a:fillRef>
-          <a:effectRef idx="2">
-            <a:schemeClr val="accent1"/>
-          </a:effectRef>
-          <a:fontRef idx="minor">
-            <a:schemeClr val="lt1"/>
-          </a:fontRef>
-        </p:style>
         <p:txBody>
           <a:bodyPr rtlCol="0" anchor="ctr"/>
           <a:lstStyle/>
@@ -12428,20 +10685,6 @@
           </a:ln>
           <a:effectLst/>
         </p:spPr>
-        <p:style>
-          <a:lnRef idx="1">
-            <a:schemeClr val="accent1"/>
-          </a:lnRef>
-          <a:fillRef idx="3">
-            <a:schemeClr val="accent1"/>
-          </a:fillRef>
-          <a:effectRef idx="2">
-            <a:schemeClr val="accent1"/>
-          </a:effectRef>
-          <a:fontRef idx="minor">
-            <a:schemeClr val="lt1"/>
-          </a:fontRef>
-        </p:style>
         <p:txBody>
           <a:bodyPr rtlCol="0" anchor="ctr"/>
           <a:lstStyle/>
@@ -12472,20 +10715,6 @@
           </a:ln>
           <a:effectLst/>
         </p:spPr>
-        <p:style>
-          <a:lnRef idx="1">
-            <a:schemeClr val="accent1"/>
-          </a:lnRef>
-          <a:fillRef idx="3">
-            <a:schemeClr val="accent1"/>
-          </a:fillRef>
-          <a:effectRef idx="2">
-            <a:schemeClr val="accent1"/>
-          </a:effectRef>
-          <a:fontRef idx="minor">
-            <a:schemeClr val="lt1"/>
-          </a:fontRef>
-        </p:style>
         <p:txBody>
           <a:bodyPr rtlCol="0" anchor="ctr"/>
           <a:lstStyle/>
@@ -12716,20 +10945,6 @@
           </a:ln>
           <a:effectLst/>
         </p:spPr>
-        <p:style>
-          <a:lnRef idx="1">
-            <a:schemeClr val="accent1"/>
-          </a:lnRef>
-          <a:fillRef idx="3">
-            <a:schemeClr val="accent1"/>
-          </a:fillRef>
-          <a:effectRef idx="2">
-            <a:schemeClr val="accent1"/>
-          </a:effectRef>
-          <a:fontRef idx="minor">
-            <a:schemeClr val="lt1"/>
-          </a:fontRef>
-        </p:style>
         <p:txBody>
           <a:bodyPr rtlCol="0" anchor="ctr"/>
           <a:lstStyle/>
@@ -12953,20 +11168,6 @@
             </a:solidFill>
           </a:ln>
         </p:spPr>
-        <p:style>
-          <a:lnRef idx="2">
-            <a:schemeClr val="accent1"/>
-          </a:lnRef>
-          <a:fillRef idx="0">
-            <a:schemeClr val="accent1"/>
-          </a:fillRef>
-          <a:effectRef idx="1">
-            <a:schemeClr val="accent1"/>
-          </a:effectRef>
-          <a:fontRef idx="minor">
-            <a:schemeClr val="tx1"/>
-          </a:fontRef>
-        </p:style>
       </p:cxnSp>
       <p:sp>
         <p:nvSpPr>
@@ -13105,20 +11306,6 @@
             </a:solidFill>
           </a:ln>
         </p:spPr>
-        <p:style>
-          <a:lnRef idx="2">
-            <a:schemeClr val="accent1"/>
-          </a:lnRef>
-          <a:fillRef idx="0">
-            <a:schemeClr val="accent1"/>
-          </a:fillRef>
-          <a:effectRef idx="1">
-            <a:schemeClr val="accent1"/>
-          </a:effectRef>
-          <a:fontRef idx="minor">
-            <a:schemeClr val="tx1"/>
-          </a:fontRef>
-        </p:style>
       </p:cxnSp>
       <p:sp>
         <p:nvSpPr>
@@ -13257,20 +11444,6 @@
             </a:solidFill>
           </a:ln>
         </p:spPr>
-        <p:style>
-          <a:lnRef idx="2">
-            <a:schemeClr val="accent1"/>
-          </a:lnRef>
-          <a:fillRef idx="0">
-            <a:schemeClr val="accent1"/>
-          </a:fillRef>
-          <a:effectRef idx="1">
-            <a:schemeClr val="accent1"/>
-          </a:effectRef>
-          <a:fontRef idx="minor">
-            <a:schemeClr val="tx1"/>
-          </a:fontRef>
-        </p:style>
       </p:cxnSp>
       <p:sp>
         <p:nvSpPr>
@@ -13333,20 +11506,6 @@
           </a:ln>
           <a:effectLst/>
         </p:spPr>
-        <p:style>
-          <a:lnRef idx="1">
-            <a:schemeClr val="accent1"/>
-          </a:lnRef>
-          <a:fillRef idx="3">
-            <a:schemeClr val="accent1"/>
-          </a:fillRef>
-          <a:effectRef idx="2">
-            <a:schemeClr val="accent1"/>
-          </a:effectRef>
-          <a:fontRef idx="minor">
-            <a:schemeClr val="lt1"/>
-          </a:fontRef>
-        </p:style>
         <p:txBody>
           <a:bodyPr rtlCol="0" anchor="ctr"/>
           <a:lstStyle/>
@@ -13416,20 +11575,6 @@
           </a:ln>
           <a:effectLst/>
         </p:spPr>
-        <p:style>
-          <a:lnRef idx="1">
-            <a:schemeClr val="accent1"/>
-          </a:lnRef>
-          <a:fillRef idx="3">
-            <a:schemeClr val="accent1"/>
-          </a:fillRef>
-          <a:effectRef idx="2">
-            <a:schemeClr val="accent1"/>
-          </a:effectRef>
-          <a:fontRef idx="minor">
-            <a:schemeClr val="lt1"/>
-          </a:fontRef>
-        </p:style>
         <p:txBody>
           <a:bodyPr rtlCol="0" anchor="ctr"/>
           <a:lstStyle/>
@@ -13499,20 +11644,6 @@
           </a:ln>
           <a:effectLst/>
         </p:spPr>
-        <p:style>
-          <a:lnRef idx="1">
-            <a:schemeClr val="accent1"/>
-          </a:lnRef>
-          <a:fillRef idx="3">
-            <a:schemeClr val="accent1"/>
-          </a:fillRef>
-          <a:effectRef idx="2">
-            <a:schemeClr val="accent1"/>
-          </a:effectRef>
-          <a:fontRef idx="minor">
-            <a:schemeClr val="lt1"/>
-          </a:fontRef>
-        </p:style>
         <p:txBody>
           <a:bodyPr rtlCol="0" anchor="ctr"/>
           <a:lstStyle/>
@@ -13639,20 +11770,6 @@
           </a:ln>
           <a:effectLst/>
         </p:spPr>
-        <p:style>
-          <a:lnRef idx="1">
-            <a:schemeClr val="accent1"/>
-          </a:lnRef>
-          <a:fillRef idx="3">
-            <a:schemeClr val="accent1"/>
-          </a:fillRef>
-          <a:effectRef idx="2">
-            <a:schemeClr val="accent1"/>
-          </a:effectRef>
-          <a:fontRef idx="minor">
-            <a:schemeClr val="lt1"/>
-          </a:fontRef>
-        </p:style>
         <p:txBody>
           <a:bodyPr rtlCol="0" anchor="ctr"/>
           <a:lstStyle/>
@@ -13895,20 +12012,6 @@
             </a:solidFill>
           </a:ln>
         </p:spPr>
-        <p:style>
-          <a:lnRef idx="2">
-            <a:schemeClr val="accent1"/>
-          </a:lnRef>
-          <a:fillRef idx="0">
-            <a:schemeClr val="accent1"/>
-          </a:fillRef>
-          <a:effectRef idx="1">
-            <a:schemeClr val="accent1"/>
-          </a:effectRef>
-          <a:fontRef idx="minor">
-            <a:schemeClr val="tx1"/>
-          </a:fontRef>
-        </p:style>
       </p:cxnSp>
       <p:sp>
         <p:nvSpPr>
@@ -14362,20 +12465,6 @@
           </a:ln>
           <a:effectLst/>
         </p:spPr>
-        <p:style>
-          <a:lnRef idx="1">
-            <a:schemeClr val="accent1"/>
-          </a:lnRef>
-          <a:fillRef idx="3">
-            <a:schemeClr val="accent1"/>
-          </a:fillRef>
-          <a:effectRef idx="2">
-            <a:schemeClr val="accent1"/>
-          </a:effectRef>
-          <a:fontRef idx="minor">
-            <a:schemeClr val="lt1"/>
-          </a:fontRef>
-        </p:style>
         <p:txBody>
           <a:bodyPr rtlCol="0" anchor="ctr"/>
           <a:lstStyle/>
@@ -14660,20 +12749,6 @@
           </a:ln>
           <a:effectLst/>
         </p:spPr>
-        <p:style>
-          <a:lnRef idx="1">
-            <a:schemeClr val="accent1"/>
-          </a:lnRef>
-          <a:fillRef idx="3">
-            <a:schemeClr val="accent1"/>
-          </a:fillRef>
-          <a:effectRef idx="2">
-            <a:schemeClr val="accent1"/>
-          </a:effectRef>
-          <a:fontRef idx="minor">
-            <a:schemeClr val="lt1"/>
-          </a:fontRef>
-        </p:style>
         <p:txBody>
           <a:bodyPr rtlCol="0" anchor="ctr"/>
           <a:lstStyle/>
@@ -15008,20 +13083,6 @@
           </a:ln>
           <a:effectLst/>
         </p:spPr>
-        <p:style>
-          <a:lnRef idx="1">
-            <a:schemeClr val="accent1"/>
-          </a:lnRef>
-          <a:fillRef idx="3">
-            <a:schemeClr val="accent1"/>
-          </a:fillRef>
-          <a:effectRef idx="2">
-            <a:schemeClr val="accent1"/>
-          </a:effectRef>
-          <a:fontRef idx="minor">
-            <a:schemeClr val="lt1"/>
-          </a:fontRef>
-        </p:style>
         <p:txBody>
           <a:bodyPr rtlCol="0" anchor="ctr"/>
           <a:lstStyle/>
@@ -15148,20 +13209,6 @@
           </a:ln>
           <a:effectLst/>
         </p:spPr>
-        <p:style>
-          <a:lnRef idx="1">
-            <a:schemeClr val="accent1"/>
-          </a:lnRef>
-          <a:fillRef idx="3">
-            <a:schemeClr val="accent1"/>
-          </a:fillRef>
-          <a:effectRef idx="2">
-            <a:schemeClr val="accent1"/>
-          </a:effectRef>
-          <a:fontRef idx="minor">
-            <a:schemeClr val="lt1"/>
-          </a:fontRef>
-        </p:style>
         <p:txBody>
           <a:bodyPr rtlCol="0" anchor="ctr"/>
           <a:lstStyle/>
@@ -15288,20 +13335,6 @@
           </a:ln>
           <a:effectLst/>
         </p:spPr>
-        <p:style>
-          <a:lnRef idx="1">
-            <a:schemeClr val="accent1"/>
-          </a:lnRef>
-          <a:fillRef idx="3">
-            <a:schemeClr val="accent1"/>
-          </a:fillRef>
-          <a:effectRef idx="2">
-            <a:schemeClr val="accent1"/>
-          </a:effectRef>
-          <a:fontRef idx="minor">
-            <a:schemeClr val="lt1"/>
-          </a:fontRef>
-        </p:style>
         <p:txBody>
           <a:bodyPr rtlCol="0" anchor="ctr"/>
           <a:lstStyle/>
@@ -15428,20 +13461,6 @@
           </a:ln>
           <a:effectLst/>
         </p:spPr>
-        <p:style>
-          <a:lnRef idx="1">
-            <a:schemeClr val="accent1"/>
-          </a:lnRef>
-          <a:fillRef idx="3">
-            <a:schemeClr val="accent1"/>
-          </a:fillRef>
-          <a:effectRef idx="2">
-            <a:schemeClr val="accent1"/>
-          </a:effectRef>
-          <a:fontRef idx="minor">
-            <a:schemeClr val="lt1"/>
-          </a:fontRef>
-        </p:style>
         <p:txBody>
           <a:bodyPr rtlCol="0" anchor="ctr"/>
           <a:lstStyle/>
@@ -15626,20 +13645,6 @@
             </a:solidFill>
           </a:ln>
         </p:spPr>
-        <p:style>
-          <a:lnRef idx="2">
-            <a:schemeClr val="accent1"/>
-          </a:lnRef>
-          <a:fillRef idx="0">
-            <a:schemeClr val="accent1"/>
-          </a:fillRef>
-          <a:effectRef idx="1">
-            <a:schemeClr val="accent1"/>
-          </a:effectRef>
-          <a:fontRef idx="minor">
-            <a:schemeClr val="tx1"/>
-          </a:fontRef>
-        </p:style>
       </p:cxnSp>
       <p:sp>
         <p:nvSpPr>
@@ -15739,20 +13744,6 @@
             </a:solidFill>
           </a:ln>
         </p:spPr>
-        <p:style>
-          <a:lnRef idx="2">
-            <a:schemeClr val="accent1"/>
-          </a:lnRef>
-          <a:fillRef idx="0">
-            <a:schemeClr val="accent1"/>
-          </a:fillRef>
-          <a:effectRef idx="1">
-            <a:schemeClr val="accent1"/>
-          </a:effectRef>
-          <a:fontRef idx="minor">
-            <a:schemeClr val="tx1"/>
-          </a:fontRef>
-        </p:style>
       </p:cxnSp>
       <p:sp>
         <p:nvSpPr>
@@ -16122,20 +14113,6 @@
           </a:ln>
           <a:effectLst/>
         </p:spPr>
-        <p:style>
-          <a:lnRef idx="1">
-            <a:schemeClr val="accent1"/>
-          </a:lnRef>
-          <a:fillRef idx="3">
-            <a:schemeClr val="accent1"/>
-          </a:fillRef>
-          <a:effectRef idx="2">
-            <a:schemeClr val="accent1"/>
-          </a:effectRef>
-          <a:fontRef idx="minor">
-            <a:schemeClr val="lt1"/>
-          </a:fontRef>
-        </p:style>
         <p:txBody>
           <a:bodyPr rtlCol="0" anchor="ctr"/>
           <a:lstStyle/>
@@ -16539,20 +14516,6 @@
           </a:ln>
           <a:effectLst/>
         </p:spPr>
-        <p:style>
-          <a:lnRef idx="1">
-            <a:schemeClr val="accent1"/>
-          </a:lnRef>
-          <a:fillRef idx="3">
-            <a:schemeClr val="accent1"/>
-          </a:fillRef>
-          <a:effectRef idx="2">
-            <a:schemeClr val="accent1"/>
-          </a:effectRef>
-          <a:fontRef idx="minor">
-            <a:schemeClr val="lt1"/>
-          </a:fontRef>
-        </p:style>
         <p:txBody>
           <a:bodyPr rtlCol="0" anchor="ctr"/>
           <a:lstStyle/>
@@ -16661,20 +14624,6 @@
           </a:ln>
           <a:effectLst/>
         </p:spPr>
-        <p:style>
-          <a:lnRef idx="1">
-            <a:schemeClr val="accent1"/>
-          </a:lnRef>
-          <a:fillRef idx="3">
-            <a:schemeClr val="accent1"/>
-          </a:fillRef>
-          <a:effectRef idx="2">
-            <a:schemeClr val="accent1"/>
-          </a:effectRef>
-          <a:fontRef idx="minor">
-            <a:schemeClr val="lt1"/>
-          </a:fontRef>
-        </p:style>
         <p:txBody>
           <a:bodyPr rtlCol="0" anchor="ctr"/>
           <a:lstStyle/>
@@ -16783,20 +14732,6 @@
           </a:ln>
           <a:effectLst/>
         </p:spPr>
-        <p:style>
-          <a:lnRef idx="1">
-            <a:schemeClr val="accent1"/>
-          </a:lnRef>
-          <a:fillRef idx="3">
-            <a:schemeClr val="accent1"/>
-          </a:fillRef>
-          <a:effectRef idx="2">
-            <a:schemeClr val="accent1"/>
-          </a:effectRef>
-          <a:fontRef idx="minor">
-            <a:schemeClr val="lt1"/>
-          </a:fontRef>
-        </p:style>
         <p:txBody>
           <a:bodyPr rtlCol="0" anchor="ctr"/>
           <a:lstStyle/>
@@ -16905,20 +14840,6 @@
           </a:ln>
           <a:effectLst/>
         </p:spPr>
-        <p:style>
-          <a:lnRef idx="1">
-            <a:schemeClr val="accent1"/>
-          </a:lnRef>
-          <a:fillRef idx="3">
-            <a:schemeClr val="accent1"/>
-          </a:fillRef>
-          <a:effectRef idx="2">
-            <a:schemeClr val="accent1"/>
-          </a:effectRef>
-          <a:fontRef idx="minor">
-            <a:schemeClr val="lt1"/>
-          </a:fontRef>
-        </p:style>
         <p:txBody>
           <a:bodyPr rtlCol="0" anchor="ctr"/>
           <a:lstStyle/>
@@ -17027,20 +14948,6 @@
           </a:ln>
           <a:effectLst/>
         </p:spPr>
-        <p:style>
-          <a:lnRef idx="1">
-            <a:schemeClr val="accent1"/>
-          </a:lnRef>
-          <a:fillRef idx="3">
-            <a:schemeClr val="accent1"/>
-          </a:fillRef>
-          <a:effectRef idx="2">
-            <a:schemeClr val="accent1"/>
-          </a:effectRef>
-          <a:fontRef idx="minor">
-            <a:schemeClr val="lt1"/>
-          </a:fontRef>
-        </p:style>
         <p:txBody>
           <a:bodyPr rtlCol="0" anchor="ctr"/>
           <a:lstStyle/>
@@ -17149,20 +15056,6 @@
           </a:ln>
           <a:effectLst/>
         </p:spPr>
-        <p:style>
-          <a:lnRef idx="1">
-            <a:schemeClr val="accent1"/>
-          </a:lnRef>
-          <a:fillRef idx="3">
-            <a:schemeClr val="accent1"/>
-          </a:fillRef>
-          <a:effectRef idx="2">
-            <a:schemeClr val="accent1"/>
-          </a:effectRef>
-          <a:fontRef idx="minor">
-            <a:schemeClr val="lt1"/>
-          </a:fontRef>
-        </p:style>
         <p:txBody>
           <a:bodyPr rtlCol="0" anchor="ctr"/>
           <a:lstStyle/>
@@ -17271,20 +15164,6 @@
           </a:ln>
           <a:effectLst/>
         </p:spPr>
-        <p:style>
-          <a:lnRef idx="1">
-            <a:schemeClr val="accent1"/>
-          </a:lnRef>
-          <a:fillRef idx="3">
-            <a:schemeClr val="accent1"/>
-          </a:fillRef>
-          <a:effectRef idx="2">
-            <a:schemeClr val="accent1"/>
-          </a:effectRef>
-          <a:fontRef idx="minor">
-            <a:schemeClr val="lt1"/>
-          </a:fontRef>
-        </p:style>
         <p:txBody>
           <a:bodyPr rtlCol="0" anchor="ctr"/>
           <a:lstStyle/>
@@ -17393,20 +15272,6 @@
           </a:ln>
           <a:effectLst/>
         </p:spPr>
-        <p:style>
-          <a:lnRef idx="1">
-            <a:schemeClr val="accent1"/>
-          </a:lnRef>
-          <a:fillRef idx="3">
-            <a:schemeClr val="accent1"/>
-          </a:fillRef>
-          <a:effectRef idx="2">
-            <a:schemeClr val="accent1"/>
-          </a:effectRef>
-          <a:fontRef idx="minor">
-            <a:schemeClr val="lt1"/>
-          </a:fontRef>
-        </p:style>
         <p:txBody>
           <a:bodyPr rtlCol="0" anchor="ctr"/>
           <a:lstStyle/>
@@ -17515,20 +15380,6 @@
           </a:ln>
           <a:effectLst/>
         </p:spPr>
-        <p:style>
-          <a:lnRef idx="1">
-            <a:schemeClr val="accent1"/>
-          </a:lnRef>
-          <a:fillRef idx="3">
-            <a:schemeClr val="accent1"/>
-          </a:fillRef>
-          <a:effectRef idx="2">
-            <a:schemeClr val="accent1"/>
-          </a:effectRef>
-          <a:fontRef idx="minor">
-            <a:schemeClr val="lt1"/>
-          </a:fontRef>
-        </p:style>
         <p:txBody>
           <a:bodyPr rtlCol="0" anchor="ctr"/>
           <a:lstStyle/>
@@ -17637,20 +15488,6 @@
           </a:ln>
           <a:effectLst/>
         </p:spPr>
-        <p:style>
-          <a:lnRef idx="1">
-            <a:schemeClr val="accent1"/>
-          </a:lnRef>
-          <a:fillRef idx="3">
-            <a:schemeClr val="accent1"/>
-          </a:fillRef>
-          <a:effectRef idx="2">
-            <a:schemeClr val="accent1"/>
-          </a:effectRef>
-          <a:fontRef idx="minor">
-            <a:schemeClr val="lt1"/>
-          </a:fontRef>
-        </p:style>
         <p:txBody>
           <a:bodyPr rtlCol="0" anchor="ctr"/>
           <a:lstStyle/>
@@ -17759,20 +15596,6 @@
           </a:ln>
           <a:effectLst/>
         </p:spPr>
-        <p:style>
-          <a:lnRef idx="1">
-            <a:schemeClr val="accent1"/>
-          </a:lnRef>
-          <a:fillRef idx="3">
-            <a:schemeClr val="accent1"/>
-          </a:fillRef>
-          <a:effectRef idx="2">
-            <a:schemeClr val="accent1"/>
-          </a:effectRef>
-          <a:fontRef idx="minor">
-            <a:schemeClr val="lt1"/>
-          </a:fontRef>
-        </p:style>
         <p:txBody>
           <a:bodyPr rtlCol="0" anchor="ctr"/>
           <a:lstStyle/>
@@ -17881,20 +15704,6 @@
           </a:ln>
           <a:effectLst/>
         </p:spPr>
-        <p:style>
-          <a:lnRef idx="1">
-            <a:schemeClr val="accent1"/>
-          </a:lnRef>
-          <a:fillRef idx="3">
-            <a:schemeClr val="accent1"/>
-          </a:fillRef>
-          <a:effectRef idx="2">
-            <a:schemeClr val="accent1"/>
-          </a:effectRef>
-          <a:fontRef idx="minor">
-            <a:schemeClr val="lt1"/>
-          </a:fontRef>
-        </p:style>
         <p:txBody>
           <a:bodyPr rtlCol="0" anchor="ctr"/>
           <a:lstStyle/>
@@ -18001,20 +15810,6 @@
             </a:solidFill>
           </a:ln>
         </p:spPr>
-        <p:style>
-          <a:lnRef idx="2">
-            <a:schemeClr val="accent1"/>
-          </a:lnRef>
-          <a:fillRef idx="0">
-            <a:schemeClr val="accent1"/>
-          </a:fillRef>
-          <a:effectRef idx="1">
-            <a:schemeClr val="accent1"/>
-          </a:effectRef>
-          <a:fontRef idx="minor">
-            <a:schemeClr val="tx1"/>
-          </a:fontRef>
-        </p:style>
       </p:cxnSp>
       <p:sp>
         <p:nvSpPr>

</xml_diff>